<commit_message>
Update portfolio presentation summary and sections
</commit_message>
<xml_diff>
--- a/downloads/Unified_Content_Strategy_in_Practice.pptx
+++ b/downloads/Unified_Content_Strategy_in_Practice.pptx
@@ -2,39 +2,39 @@
 <file path=ppt/presentation.xml><?xml version="1.0" encoding="utf-8"?>
 <p:presentation xmlns:p="http://schemas.openxmlformats.org/presentationml/2006/main">
   <p:sldMasterIdLst>
-    <p:sldMasterId xmlns:r="http://schemas.openxmlformats.org/officeDocument/2006/relationships" id="2147483648" r:id="R7cd37a7b47234492"/>
+    <p:sldMasterId xmlns:r="http://schemas.openxmlformats.org/officeDocument/2006/relationships" id="2147483648" r:id="R73cc3f5ab54040c2"/>
   </p:sldMasterIdLst>
   <p:notesMasterIdLst>
-    <p:notesMasterId xmlns:r="http://schemas.openxmlformats.org/officeDocument/2006/relationships" r:id="R31547eadf8444619"/>
+    <p:notesMasterId xmlns:r="http://schemas.openxmlformats.org/officeDocument/2006/relationships" r:id="Raf58b23cd4674043"/>
   </p:notesMasterIdLst>
   <p:sldIdLst>
-    <p:sldId xmlns:r="http://schemas.openxmlformats.org/officeDocument/2006/relationships" id="256" r:id="Rbd3324cbb87c498d"/>
-    <p:sldId xmlns:r="http://schemas.openxmlformats.org/officeDocument/2006/relationships" id="257" r:id="R00a719bfaa0c4edb"/>
-    <p:sldId xmlns:r="http://schemas.openxmlformats.org/officeDocument/2006/relationships" id="258" r:id="Rbdb36f467c324949"/>
-    <p:sldId xmlns:r="http://schemas.openxmlformats.org/officeDocument/2006/relationships" id="259" r:id="R8e368b53c09c40b4"/>
-    <p:sldId xmlns:r="http://schemas.openxmlformats.org/officeDocument/2006/relationships" id="260" r:id="R512e29b4872349cf"/>
-    <p:sldId xmlns:r="http://schemas.openxmlformats.org/officeDocument/2006/relationships" id="261" r:id="R076907e184244773"/>
-    <p:sldId xmlns:r="http://schemas.openxmlformats.org/officeDocument/2006/relationships" id="262" r:id="R97f3a2d4036046ce"/>
-    <p:sldId xmlns:r="http://schemas.openxmlformats.org/officeDocument/2006/relationships" id="263" r:id="R1e0fe71759414057"/>
-    <p:sldId xmlns:r="http://schemas.openxmlformats.org/officeDocument/2006/relationships" id="264" r:id="R5308bca6c64e4404"/>
-    <p:sldId xmlns:r="http://schemas.openxmlformats.org/officeDocument/2006/relationships" id="265" r:id="R11783590330d4f0b"/>
-    <p:sldId xmlns:r="http://schemas.openxmlformats.org/officeDocument/2006/relationships" id="266" r:id="R4e29431b2692466e"/>
-    <p:sldId xmlns:r="http://schemas.openxmlformats.org/officeDocument/2006/relationships" id="267" r:id="R78979e2ea0a1492b"/>
-    <p:sldId xmlns:r="http://schemas.openxmlformats.org/officeDocument/2006/relationships" id="268" r:id="Rdf1e60e0cfcc4f3d"/>
-    <p:sldId xmlns:r="http://schemas.openxmlformats.org/officeDocument/2006/relationships" id="269" r:id="R0bae079f75944008"/>
-    <p:sldId xmlns:r="http://schemas.openxmlformats.org/officeDocument/2006/relationships" id="270" r:id="Rf87f3ec4d6df493c"/>
-    <p:sldId xmlns:r="http://schemas.openxmlformats.org/officeDocument/2006/relationships" id="271" r:id="R16924f8c28224311"/>
-    <p:sldId xmlns:r="http://schemas.openxmlformats.org/officeDocument/2006/relationships" id="272" r:id="Re5ec463be5c24a87"/>
-    <p:sldId xmlns:r="http://schemas.openxmlformats.org/officeDocument/2006/relationships" id="273" r:id="Rfdbf1ecc07054558"/>
-    <p:sldId xmlns:r="http://schemas.openxmlformats.org/officeDocument/2006/relationships" id="274" r:id="R2bb1c03ca23043df"/>
-    <p:sldId xmlns:r="http://schemas.openxmlformats.org/officeDocument/2006/relationships" id="275" r:id="R03b81c99e79a44c2"/>
-    <p:sldId xmlns:r="http://schemas.openxmlformats.org/officeDocument/2006/relationships" id="276" r:id="Re49243eb0e3f4e42"/>
-    <p:sldId xmlns:r="http://schemas.openxmlformats.org/officeDocument/2006/relationships" id="277" r:id="R1e305d68be1b4136"/>
-    <p:sldId xmlns:r="http://schemas.openxmlformats.org/officeDocument/2006/relationships" id="278" r:id="R49baa1406f4646b4"/>
-    <p:sldId xmlns:r="http://schemas.openxmlformats.org/officeDocument/2006/relationships" id="279" r:id="R5c78d4d441d041d0"/>
-    <p:sldId xmlns:r="http://schemas.openxmlformats.org/officeDocument/2006/relationships" id="280" r:id="Ra03e575b31ca4b3d"/>
-    <p:sldId xmlns:r="http://schemas.openxmlformats.org/officeDocument/2006/relationships" id="281" r:id="Rf032b87e35314152"/>
-    <p:sldId xmlns:r="http://schemas.openxmlformats.org/officeDocument/2006/relationships" id="282" r:id="R4df1ee1407d64606"/>
+    <p:sldId xmlns:r="http://schemas.openxmlformats.org/officeDocument/2006/relationships" id="256" r:id="R8207b907634d412a"/>
+    <p:sldId xmlns:r="http://schemas.openxmlformats.org/officeDocument/2006/relationships" id="257" r:id="R46e3c106fa2c459d"/>
+    <p:sldId xmlns:r="http://schemas.openxmlformats.org/officeDocument/2006/relationships" id="258" r:id="R38b26a95c6e747a5"/>
+    <p:sldId xmlns:r="http://schemas.openxmlformats.org/officeDocument/2006/relationships" id="259" r:id="Re153b29a28c740d8"/>
+    <p:sldId xmlns:r="http://schemas.openxmlformats.org/officeDocument/2006/relationships" id="260" r:id="R13933309211642ba"/>
+    <p:sldId xmlns:r="http://schemas.openxmlformats.org/officeDocument/2006/relationships" id="261" r:id="R104546bcb4c446b2"/>
+    <p:sldId xmlns:r="http://schemas.openxmlformats.org/officeDocument/2006/relationships" id="262" r:id="Raf4951449c7c4bca"/>
+    <p:sldId xmlns:r="http://schemas.openxmlformats.org/officeDocument/2006/relationships" id="263" r:id="Rc7ebbcfbea3a462e"/>
+    <p:sldId xmlns:r="http://schemas.openxmlformats.org/officeDocument/2006/relationships" id="264" r:id="R7e84b8ea096845bd"/>
+    <p:sldId xmlns:r="http://schemas.openxmlformats.org/officeDocument/2006/relationships" id="265" r:id="R8aa84fc1fae14b97"/>
+    <p:sldId xmlns:r="http://schemas.openxmlformats.org/officeDocument/2006/relationships" id="266" r:id="Rb04bf01932b8468b"/>
+    <p:sldId xmlns:r="http://schemas.openxmlformats.org/officeDocument/2006/relationships" id="267" r:id="Rdb59c384284441bd"/>
+    <p:sldId xmlns:r="http://schemas.openxmlformats.org/officeDocument/2006/relationships" id="268" r:id="Rbefdfd7dd65e4a16"/>
+    <p:sldId xmlns:r="http://schemas.openxmlformats.org/officeDocument/2006/relationships" id="269" r:id="R50280247022a49ce"/>
+    <p:sldId xmlns:r="http://schemas.openxmlformats.org/officeDocument/2006/relationships" id="270" r:id="R13959823e62d4ec4"/>
+    <p:sldId xmlns:r="http://schemas.openxmlformats.org/officeDocument/2006/relationships" id="271" r:id="R612036dfaa4c4ae4"/>
+    <p:sldId xmlns:r="http://schemas.openxmlformats.org/officeDocument/2006/relationships" id="272" r:id="Rc3e4edb3af784a82"/>
+    <p:sldId xmlns:r="http://schemas.openxmlformats.org/officeDocument/2006/relationships" id="273" r:id="R14db7a520be54889"/>
+    <p:sldId xmlns:r="http://schemas.openxmlformats.org/officeDocument/2006/relationships" id="274" r:id="R78ff8c9938b84dd5"/>
+    <p:sldId xmlns:r="http://schemas.openxmlformats.org/officeDocument/2006/relationships" id="275" r:id="R1d0c6fc149ca4c19"/>
+    <p:sldId xmlns:r="http://schemas.openxmlformats.org/officeDocument/2006/relationships" id="276" r:id="R8860d7e6e1544330"/>
+    <p:sldId xmlns:r="http://schemas.openxmlformats.org/officeDocument/2006/relationships" id="277" r:id="R3ca7cde1d143459b"/>
+    <p:sldId xmlns:r="http://schemas.openxmlformats.org/officeDocument/2006/relationships" id="278" r:id="R2b0887227d314b32"/>
+    <p:sldId xmlns:r="http://schemas.openxmlformats.org/officeDocument/2006/relationships" id="279" r:id="R02997283ca4d4ac6"/>
+    <p:sldId xmlns:r="http://schemas.openxmlformats.org/officeDocument/2006/relationships" id="280" r:id="R6bf7135ab3cd4082"/>
+    <p:sldId xmlns:r="http://schemas.openxmlformats.org/officeDocument/2006/relationships" id="281" r:id="R5231eaa6b88c4cd0"/>
+    <p:sldId xmlns:r="http://schemas.openxmlformats.org/officeDocument/2006/relationships" id="282" r:id="Rb267ef757adf4fdb"/>
   </p:sldIdLst>
   <p:sldSz cx="12192000" cy="6858000"/>
   <p:notesSz cx="6858000" cy="9144000"/>
@@ -2268,7 +2268,7 @@
   </p:cSld>
   <p:clrMap bg1="lt1" tx1="dk1" bg2="lt2" tx2="dk2" accent1="accent1" accent2="accent2" accent3="accent3" accent4="accent4" accent5="accent5" accent6="accent6" hlink="hlink" folHlink="folHlink"/>
   <p:sldLayoutIdLst>
-    <p:sldLayoutId xmlns:r="http://schemas.openxmlformats.org/officeDocument/2006/relationships" id="2147483649" r:id="Re84521b4780540bf"/>
+    <p:sldLayoutId xmlns:r="http://schemas.openxmlformats.org/officeDocument/2006/relationships" id="2147483649" r:id="R30e56b3b362347d5"/>
   </p:sldLayoutIdLst>
   <p:txStyles>
     <p:titleStyle>
@@ -2816,7 +2816,7 @@
           <p:nvPr/>
         </p:nvPicPr>
         <p:blipFill>
-          <a:blip xmlns:r="http://schemas.openxmlformats.org/officeDocument/2006/relationships" xmlns:a="http://schemas.openxmlformats.org/drawingml/2006/main" r:embed="R6a07472d18f74b61"/>
+          <a:blip xmlns:r="http://schemas.openxmlformats.org/officeDocument/2006/relationships" xmlns:a="http://schemas.openxmlformats.org/drawingml/2006/main" r:embed="Raf11fc7b135f4523"/>
           <a:srcRect xmlns:a="http://schemas.openxmlformats.org/drawingml/2006/main" l="0" t="0" r="0" b="0"/>
           <a:stretch xmlns:a="http://schemas.openxmlformats.org/drawingml/2006/main">
             <a:fillRect l="0" t="0" r="0" b="0"/>
@@ -2895,6 +2895,7 @@
           <a:lstStyle xmlns:a="http://schemas.openxmlformats.org/drawingml/2006/main"/>
           <a:p xmlns:a="http://schemas.openxmlformats.org/drawingml/2006/main">
             <a:pPr algn="l">
+              <a:buNone/>
               <a:defRPr sz="975" b="1">
                 <a:solidFill>
                   <a:srgbClr val="D76532"/>
@@ -2913,7 +2914,7 @@
                 <a:ea typeface="Arial"/>
                 <a:cs typeface="Arial"/>
               </a:rPr>
-              <a:t>STEP 3</a:t>
+              <a:t>02  THE WORKING METHOD</a:t>
             </a:r>
           </a:p>
         </p:txBody>
@@ -2952,6 +2953,7 @@
           <a:lstStyle xmlns:a="http://schemas.openxmlformats.org/drawingml/2006/main"/>
           <a:p xmlns:a="http://schemas.openxmlformats.org/drawingml/2006/main">
             <a:pPr algn="r">
+              <a:buNone/>
               <a:defRPr sz="825" b="0">
                 <a:solidFill>
                   <a:srgbClr val="8A8179"/>
@@ -3009,6 +3011,7 @@
           <a:lstStyle xmlns:a="http://schemas.openxmlformats.org/drawingml/2006/main"/>
           <a:p xmlns:a="http://schemas.openxmlformats.org/drawingml/2006/main">
             <a:pPr algn="l">
+              <a:buNone/>
               <a:defRPr sz="2850" b="1">
                 <a:solidFill>
                   <a:srgbClr val="172737"/>
@@ -3066,6 +3069,7 @@
           <a:lstStyle xmlns:a="http://schemas.openxmlformats.org/drawingml/2006/main"/>
           <a:p xmlns:a="http://schemas.openxmlformats.org/drawingml/2006/main">
             <a:pPr algn="l">
+              <a:buNone/>
               <a:defRPr sz="1575" b="1">
                 <a:solidFill>
                   <a:srgbClr val="D76532"/>
@@ -3123,6 +3127,7 @@
           <a:lstStyle xmlns:a="http://schemas.openxmlformats.org/drawingml/2006/main"/>
           <a:p xmlns:a="http://schemas.openxmlformats.org/drawingml/2006/main">
             <a:pPr algn="l">
+              <a:buNone/>
               <a:defRPr sz="1800" b="1">
                 <a:solidFill>
                   <a:srgbClr val="172737"/>
@@ -3242,6 +3247,7 @@
           <a:lstStyle xmlns:a="http://schemas.openxmlformats.org/drawingml/2006/main"/>
           <a:p xmlns:a="http://schemas.openxmlformats.org/drawingml/2006/main">
             <a:pPr algn="l">
+              <a:buNone/>
               <a:defRPr sz="1425" b="0">
                 <a:solidFill>
                   <a:srgbClr val="5F6B76"/>
@@ -3331,6 +3337,7 @@
           <a:lstStyle xmlns:a="http://schemas.openxmlformats.org/drawingml/2006/main"/>
           <a:p xmlns:a="http://schemas.openxmlformats.org/drawingml/2006/main">
             <a:pPr algn="l">
+              <a:buNone/>
               <a:defRPr sz="1425" b="0">
                 <a:solidFill>
                   <a:srgbClr val="5F6B76"/>
@@ -3420,6 +3427,7 @@
           <a:lstStyle xmlns:a="http://schemas.openxmlformats.org/drawingml/2006/main"/>
           <a:p xmlns:a="http://schemas.openxmlformats.org/drawingml/2006/main">
             <a:pPr algn="l">
+              <a:buNone/>
               <a:defRPr sz="1425" b="0">
                 <a:solidFill>
                   <a:srgbClr val="5F6B76"/>
@@ -3509,6 +3517,7 @@
           <a:lstStyle xmlns:a="http://schemas.openxmlformats.org/drawingml/2006/main"/>
           <a:p xmlns:a="http://schemas.openxmlformats.org/drawingml/2006/main">
             <a:pPr algn="l">
+              <a:buNone/>
               <a:defRPr sz="1425" b="0">
                 <a:solidFill>
                   <a:srgbClr val="5F6B76"/>
@@ -3566,6 +3575,7 @@
           <a:lstStyle xmlns:a="http://schemas.openxmlformats.org/drawingml/2006/main"/>
           <a:p xmlns:a="http://schemas.openxmlformats.org/drawingml/2006/main">
             <a:pPr algn="l">
+              <a:buNone/>
               <a:defRPr sz="1800" b="1">
                 <a:solidFill>
                   <a:srgbClr val="172737"/>
@@ -3685,6 +3695,7 @@
           <a:lstStyle xmlns:a="http://schemas.openxmlformats.org/drawingml/2006/main"/>
           <a:p xmlns:a="http://schemas.openxmlformats.org/drawingml/2006/main">
             <a:pPr algn="l">
+              <a:buNone/>
               <a:defRPr sz="1425" b="0">
                 <a:solidFill>
                   <a:srgbClr val="5F6B76"/>
@@ -3774,6 +3785,7 @@
           <a:lstStyle xmlns:a="http://schemas.openxmlformats.org/drawingml/2006/main"/>
           <a:p xmlns:a="http://schemas.openxmlformats.org/drawingml/2006/main">
             <a:pPr algn="l">
+              <a:buNone/>
               <a:defRPr sz="1425" b="0">
                 <a:solidFill>
                   <a:srgbClr val="5F6B76"/>
@@ -3863,6 +3875,7 @@
           <a:lstStyle xmlns:a="http://schemas.openxmlformats.org/drawingml/2006/main"/>
           <a:p xmlns:a="http://schemas.openxmlformats.org/drawingml/2006/main">
             <a:pPr algn="l">
+              <a:buNone/>
               <a:defRPr sz="1425" b="0">
                 <a:solidFill>
                   <a:srgbClr val="5F6B76"/>
@@ -3952,6 +3965,7 @@
           <a:lstStyle xmlns:a="http://schemas.openxmlformats.org/drawingml/2006/main"/>
           <a:p xmlns:a="http://schemas.openxmlformats.org/drawingml/2006/main">
             <a:pPr algn="l">
+              <a:buNone/>
               <a:defRPr sz="1425" b="0">
                 <a:solidFill>
                   <a:srgbClr val="5F6B76"/>
@@ -4038,6 +4052,7 @@
           <a:lstStyle xmlns:a="http://schemas.openxmlformats.org/drawingml/2006/main"/>
           <a:p xmlns:a="http://schemas.openxmlformats.org/drawingml/2006/main">
             <a:pPr algn="l">
+              <a:buNone/>
               <a:defRPr sz="975" b="1">
                 <a:solidFill>
                   <a:srgbClr val="D76532"/>
@@ -4056,7 +4071,7 @@
                 <a:ea typeface="Arial"/>
                 <a:cs typeface="Arial"/>
               </a:rPr>
-              <a:t>STEP 4</a:t>
+              <a:t>02  THE WORKING METHOD</a:t>
             </a:r>
           </a:p>
         </p:txBody>
@@ -4095,6 +4110,7 @@
           <a:lstStyle xmlns:a="http://schemas.openxmlformats.org/drawingml/2006/main"/>
           <a:p xmlns:a="http://schemas.openxmlformats.org/drawingml/2006/main">
             <a:pPr algn="r">
+              <a:buNone/>
               <a:defRPr sz="825" b="0">
                 <a:solidFill>
                   <a:srgbClr val="8A8179"/>
@@ -4152,6 +4168,7 @@
           <a:lstStyle xmlns:a="http://schemas.openxmlformats.org/drawingml/2006/main"/>
           <a:p xmlns:a="http://schemas.openxmlformats.org/drawingml/2006/main">
             <a:pPr algn="l">
+              <a:buNone/>
               <a:defRPr sz="2850" b="1">
                 <a:solidFill>
                   <a:srgbClr val="172737"/>
@@ -4209,6 +4226,7 @@
           <a:lstStyle xmlns:a="http://schemas.openxmlformats.org/drawingml/2006/main"/>
           <a:p xmlns:a="http://schemas.openxmlformats.org/drawingml/2006/main">
             <a:pPr algn="l">
+              <a:buNone/>
               <a:defRPr sz="1575" b="1">
                 <a:solidFill>
                   <a:srgbClr val="D76532"/>
@@ -4266,6 +4284,7 @@
           <a:lstStyle xmlns:a="http://schemas.openxmlformats.org/drawingml/2006/main"/>
           <a:p xmlns:a="http://schemas.openxmlformats.org/drawingml/2006/main">
             <a:pPr algn="l">
+              <a:buNone/>
               <a:defRPr sz="1800" b="1">
                 <a:solidFill>
                   <a:srgbClr val="172737"/>
@@ -4385,6 +4404,7 @@
           <a:lstStyle xmlns:a="http://schemas.openxmlformats.org/drawingml/2006/main"/>
           <a:p xmlns:a="http://schemas.openxmlformats.org/drawingml/2006/main">
             <a:pPr algn="l">
+              <a:buNone/>
               <a:defRPr sz="1425" b="0">
                 <a:solidFill>
                   <a:srgbClr val="5F6B76"/>
@@ -4474,6 +4494,7 @@
           <a:lstStyle xmlns:a="http://schemas.openxmlformats.org/drawingml/2006/main"/>
           <a:p xmlns:a="http://schemas.openxmlformats.org/drawingml/2006/main">
             <a:pPr algn="l">
+              <a:buNone/>
               <a:defRPr sz="1425" b="0">
                 <a:solidFill>
                   <a:srgbClr val="5F6B76"/>
@@ -4563,6 +4584,7 @@
           <a:lstStyle xmlns:a="http://schemas.openxmlformats.org/drawingml/2006/main"/>
           <a:p xmlns:a="http://schemas.openxmlformats.org/drawingml/2006/main">
             <a:pPr algn="l">
+              <a:buNone/>
               <a:defRPr sz="1425" b="0">
                 <a:solidFill>
                   <a:srgbClr val="5F6B76"/>
@@ -4652,6 +4674,7 @@
           <a:lstStyle xmlns:a="http://schemas.openxmlformats.org/drawingml/2006/main"/>
           <a:p xmlns:a="http://schemas.openxmlformats.org/drawingml/2006/main">
             <a:pPr algn="l">
+              <a:buNone/>
               <a:defRPr sz="1425" b="0">
                 <a:solidFill>
                   <a:srgbClr val="5F6B76"/>
@@ -4709,6 +4732,7 @@
           <a:lstStyle xmlns:a="http://schemas.openxmlformats.org/drawingml/2006/main"/>
           <a:p xmlns:a="http://schemas.openxmlformats.org/drawingml/2006/main">
             <a:pPr algn="l">
+              <a:buNone/>
               <a:defRPr sz="1800" b="1">
                 <a:solidFill>
                   <a:srgbClr val="172737"/>
@@ -4828,6 +4852,7 @@
           <a:lstStyle xmlns:a="http://schemas.openxmlformats.org/drawingml/2006/main"/>
           <a:p xmlns:a="http://schemas.openxmlformats.org/drawingml/2006/main">
             <a:pPr algn="l">
+              <a:buNone/>
               <a:defRPr sz="1425" b="0">
                 <a:solidFill>
                   <a:srgbClr val="5F6B76"/>
@@ -4917,6 +4942,7 @@
           <a:lstStyle xmlns:a="http://schemas.openxmlformats.org/drawingml/2006/main"/>
           <a:p xmlns:a="http://schemas.openxmlformats.org/drawingml/2006/main">
             <a:pPr algn="l">
+              <a:buNone/>
               <a:defRPr sz="1425" b="0">
                 <a:solidFill>
                   <a:srgbClr val="5F6B76"/>
@@ -5006,6 +5032,7 @@
           <a:lstStyle xmlns:a="http://schemas.openxmlformats.org/drawingml/2006/main"/>
           <a:p xmlns:a="http://schemas.openxmlformats.org/drawingml/2006/main">
             <a:pPr algn="l">
+              <a:buNone/>
               <a:defRPr sz="1425" b="0">
                 <a:solidFill>
                   <a:srgbClr val="5F6B76"/>
@@ -5095,6 +5122,7 @@
           <a:lstStyle xmlns:a="http://schemas.openxmlformats.org/drawingml/2006/main"/>
           <a:p xmlns:a="http://schemas.openxmlformats.org/drawingml/2006/main">
             <a:pPr algn="l">
+              <a:buNone/>
               <a:defRPr sz="1425" b="0">
                 <a:solidFill>
                   <a:srgbClr val="5F6B76"/>
@@ -5181,6 +5209,7 @@
           <a:lstStyle xmlns:a="http://schemas.openxmlformats.org/drawingml/2006/main"/>
           <a:p xmlns:a="http://schemas.openxmlformats.org/drawingml/2006/main">
             <a:pPr algn="l">
+              <a:buNone/>
               <a:defRPr sz="975" b="1">
                 <a:solidFill>
                   <a:srgbClr val="D76532"/>
@@ -5199,7 +5228,7 @@
                 <a:ea typeface="Arial"/>
                 <a:cs typeface="Arial"/>
               </a:rPr>
-              <a:t>STEP 5</a:t>
+              <a:t>02  THE WORKING METHOD</a:t>
             </a:r>
           </a:p>
         </p:txBody>
@@ -5238,6 +5267,7 @@
           <a:lstStyle xmlns:a="http://schemas.openxmlformats.org/drawingml/2006/main"/>
           <a:p xmlns:a="http://schemas.openxmlformats.org/drawingml/2006/main">
             <a:pPr algn="r">
+              <a:buNone/>
               <a:defRPr sz="825" b="0">
                 <a:solidFill>
                   <a:srgbClr val="8A8179"/>
@@ -5295,6 +5325,7 @@
           <a:lstStyle xmlns:a="http://schemas.openxmlformats.org/drawingml/2006/main"/>
           <a:p xmlns:a="http://schemas.openxmlformats.org/drawingml/2006/main">
             <a:pPr algn="l">
+              <a:buNone/>
               <a:defRPr sz="2850" b="1">
                 <a:solidFill>
                   <a:srgbClr val="172737"/>
@@ -5352,6 +5383,7 @@
           <a:lstStyle xmlns:a="http://schemas.openxmlformats.org/drawingml/2006/main"/>
           <a:p xmlns:a="http://schemas.openxmlformats.org/drawingml/2006/main">
             <a:pPr algn="l">
+              <a:buNone/>
               <a:defRPr sz="1575" b="1">
                 <a:solidFill>
                   <a:srgbClr val="D76532"/>
@@ -5409,6 +5441,7 @@
           <a:lstStyle xmlns:a="http://schemas.openxmlformats.org/drawingml/2006/main"/>
           <a:p xmlns:a="http://schemas.openxmlformats.org/drawingml/2006/main">
             <a:pPr algn="l">
+              <a:buNone/>
               <a:defRPr sz="1800" b="1">
                 <a:solidFill>
                   <a:srgbClr val="172737"/>
@@ -5528,6 +5561,7 @@
           <a:lstStyle xmlns:a="http://schemas.openxmlformats.org/drawingml/2006/main"/>
           <a:p xmlns:a="http://schemas.openxmlformats.org/drawingml/2006/main">
             <a:pPr algn="l">
+              <a:buNone/>
               <a:defRPr sz="1425" b="0">
                 <a:solidFill>
                   <a:srgbClr val="5F6B76"/>
@@ -5617,6 +5651,7 @@
           <a:lstStyle xmlns:a="http://schemas.openxmlformats.org/drawingml/2006/main"/>
           <a:p xmlns:a="http://schemas.openxmlformats.org/drawingml/2006/main">
             <a:pPr algn="l">
+              <a:buNone/>
               <a:defRPr sz="1425" b="0">
                 <a:solidFill>
                   <a:srgbClr val="5F6B76"/>
@@ -5706,6 +5741,7 @@
           <a:lstStyle xmlns:a="http://schemas.openxmlformats.org/drawingml/2006/main"/>
           <a:p xmlns:a="http://schemas.openxmlformats.org/drawingml/2006/main">
             <a:pPr algn="l">
+              <a:buNone/>
               <a:defRPr sz="1425" b="0">
                 <a:solidFill>
                   <a:srgbClr val="5F6B76"/>
@@ -5795,6 +5831,7 @@
           <a:lstStyle xmlns:a="http://schemas.openxmlformats.org/drawingml/2006/main"/>
           <a:p xmlns:a="http://schemas.openxmlformats.org/drawingml/2006/main">
             <a:pPr algn="l">
+              <a:buNone/>
               <a:defRPr sz="1425" b="0">
                 <a:solidFill>
                   <a:srgbClr val="5F6B76"/>
@@ -5852,6 +5889,7 @@
           <a:lstStyle xmlns:a="http://schemas.openxmlformats.org/drawingml/2006/main"/>
           <a:p xmlns:a="http://schemas.openxmlformats.org/drawingml/2006/main">
             <a:pPr algn="l">
+              <a:buNone/>
               <a:defRPr sz="1800" b="1">
                 <a:solidFill>
                   <a:srgbClr val="172737"/>
@@ -5971,6 +6009,7 @@
           <a:lstStyle xmlns:a="http://schemas.openxmlformats.org/drawingml/2006/main"/>
           <a:p xmlns:a="http://schemas.openxmlformats.org/drawingml/2006/main">
             <a:pPr algn="l">
+              <a:buNone/>
               <a:defRPr sz="1425" b="0">
                 <a:solidFill>
                   <a:srgbClr val="5F6B76"/>
@@ -6060,6 +6099,7 @@
           <a:lstStyle xmlns:a="http://schemas.openxmlformats.org/drawingml/2006/main"/>
           <a:p xmlns:a="http://schemas.openxmlformats.org/drawingml/2006/main">
             <a:pPr algn="l">
+              <a:buNone/>
               <a:defRPr sz="1425" b="0">
                 <a:solidFill>
                   <a:srgbClr val="5F6B76"/>
@@ -6149,6 +6189,7 @@
           <a:lstStyle xmlns:a="http://schemas.openxmlformats.org/drawingml/2006/main"/>
           <a:p xmlns:a="http://schemas.openxmlformats.org/drawingml/2006/main">
             <a:pPr algn="l">
+              <a:buNone/>
               <a:defRPr sz="1425" b="0">
                 <a:solidFill>
                   <a:srgbClr val="5F6B76"/>
@@ -6238,6 +6279,7 @@
           <a:lstStyle xmlns:a="http://schemas.openxmlformats.org/drawingml/2006/main"/>
           <a:p xmlns:a="http://schemas.openxmlformats.org/drawingml/2006/main">
             <a:pPr algn="l">
+              <a:buNone/>
               <a:defRPr sz="1425" b="0">
                 <a:solidFill>
                   <a:srgbClr val="5F6B76"/>
@@ -6324,6 +6366,7 @@
           <a:lstStyle xmlns:a="http://schemas.openxmlformats.org/drawingml/2006/main"/>
           <a:p xmlns:a="http://schemas.openxmlformats.org/drawingml/2006/main">
             <a:pPr algn="l">
+              <a:buNone/>
               <a:defRPr sz="975" b="1">
                 <a:solidFill>
                   <a:srgbClr val="D76532"/>
@@ -6342,7 +6385,7 @@
                 <a:ea typeface="Arial"/>
                 <a:cs typeface="Arial"/>
               </a:rPr>
-              <a:t>STEPS 6 AND 7</a:t>
+              <a:t>02  THE WORKING METHOD</a:t>
             </a:r>
           </a:p>
         </p:txBody>
@@ -6381,6 +6424,7 @@
           <a:lstStyle xmlns:a="http://schemas.openxmlformats.org/drawingml/2006/main"/>
           <a:p xmlns:a="http://schemas.openxmlformats.org/drawingml/2006/main">
             <a:pPr algn="r">
+              <a:buNone/>
               <a:defRPr sz="825" b="0">
                 <a:solidFill>
                   <a:srgbClr val="8A8179"/>
@@ -6438,6 +6482,7 @@
           <a:lstStyle xmlns:a="http://schemas.openxmlformats.org/drawingml/2006/main"/>
           <a:p xmlns:a="http://schemas.openxmlformats.org/drawingml/2006/main">
             <a:pPr algn="l">
+              <a:buNone/>
               <a:defRPr sz="2850" b="1">
                 <a:solidFill>
                   <a:srgbClr val="172737"/>
@@ -6495,6 +6540,7 @@
           <a:lstStyle xmlns:a="http://schemas.openxmlformats.org/drawingml/2006/main"/>
           <a:p xmlns:a="http://schemas.openxmlformats.org/drawingml/2006/main">
             <a:pPr algn="l">
+              <a:buNone/>
               <a:defRPr sz="1800" b="1">
                 <a:solidFill>
                   <a:srgbClr val="172737"/>
@@ -6614,6 +6660,7 @@
           <a:lstStyle xmlns:a="http://schemas.openxmlformats.org/drawingml/2006/main"/>
           <a:p xmlns:a="http://schemas.openxmlformats.org/drawingml/2006/main">
             <a:pPr algn="l">
+              <a:buNone/>
               <a:defRPr sz="1425" b="0">
                 <a:solidFill>
                   <a:srgbClr val="5F6B76"/>
@@ -6703,6 +6750,7 @@
           <a:lstStyle xmlns:a="http://schemas.openxmlformats.org/drawingml/2006/main"/>
           <a:p xmlns:a="http://schemas.openxmlformats.org/drawingml/2006/main">
             <a:pPr algn="l">
+              <a:buNone/>
               <a:defRPr sz="1425" b="0">
                 <a:solidFill>
                   <a:srgbClr val="5F6B76"/>
@@ -6792,6 +6840,7 @@
           <a:lstStyle xmlns:a="http://schemas.openxmlformats.org/drawingml/2006/main"/>
           <a:p xmlns:a="http://schemas.openxmlformats.org/drawingml/2006/main">
             <a:pPr algn="l">
+              <a:buNone/>
               <a:defRPr sz="1425" b="0">
                 <a:solidFill>
                   <a:srgbClr val="5F6B76"/>
@@ -6881,6 +6930,7 @@
           <a:lstStyle xmlns:a="http://schemas.openxmlformats.org/drawingml/2006/main"/>
           <a:p xmlns:a="http://schemas.openxmlformats.org/drawingml/2006/main">
             <a:pPr algn="l">
+              <a:buNone/>
               <a:defRPr sz="1425" b="0">
                 <a:solidFill>
                   <a:srgbClr val="5F6B76"/>
@@ -6938,6 +6988,7 @@
           <a:lstStyle xmlns:a="http://schemas.openxmlformats.org/drawingml/2006/main"/>
           <a:p xmlns:a="http://schemas.openxmlformats.org/drawingml/2006/main">
             <a:pPr algn="l">
+              <a:buNone/>
               <a:defRPr sz="1800" b="1">
                 <a:solidFill>
                   <a:srgbClr val="172737"/>
@@ -7057,6 +7108,7 @@
           <a:lstStyle xmlns:a="http://schemas.openxmlformats.org/drawingml/2006/main"/>
           <a:p xmlns:a="http://schemas.openxmlformats.org/drawingml/2006/main">
             <a:pPr algn="l">
+              <a:buNone/>
               <a:defRPr sz="1425" b="0">
                 <a:solidFill>
                   <a:srgbClr val="5F6B76"/>
@@ -7146,6 +7198,7 @@
           <a:lstStyle xmlns:a="http://schemas.openxmlformats.org/drawingml/2006/main"/>
           <a:p xmlns:a="http://schemas.openxmlformats.org/drawingml/2006/main">
             <a:pPr algn="l">
+              <a:buNone/>
               <a:defRPr sz="1425" b="0">
                 <a:solidFill>
                   <a:srgbClr val="5F6B76"/>
@@ -7235,6 +7288,7 @@
           <a:lstStyle xmlns:a="http://schemas.openxmlformats.org/drawingml/2006/main"/>
           <a:p xmlns:a="http://schemas.openxmlformats.org/drawingml/2006/main">
             <a:pPr algn="l">
+              <a:buNone/>
               <a:defRPr sz="1425" b="0">
                 <a:solidFill>
                   <a:srgbClr val="5F6B76"/>
@@ -7324,6 +7378,7 @@
           <a:lstStyle xmlns:a="http://schemas.openxmlformats.org/drawingml/2006/main"/>
           <a:p xmlns:a="http://schemas.openxmlformats.org/drawingml/2006/main">
             <a:pPr algn="l">
+              <a:buNone/>
               <a:defRPr sz="1425" b="0">
                 <a:solidFill>
                   <a:srgbClr val="5F6B76"/>
@@ -7381,6 +7436,7 @@
           <a:lstStyle xmlns:a="http://schemas.openxmlformats.org/drawingml/2006/main"/>
           <a:p xmlns:a="http://schemas.openxmlformats.org/drawingml/2006/main">
             <a:pPr algn="l">
+              <a:buNone/>
               <a:defRPr sz="1500" b="1">
                 <a:solidFill>
                   <a:srgbClr val="D76532"/>
@@ -7467,6 +7523,7 @@
           <a:lstStyle xmlns:a="http://schemas.openxmlformats.org/drawingml/2006/main"/>
           <a:p xmlns:a="http://schemas.openxmlformats.org/drawingml/2006/main">
             <a:pPr algn="l">
+              <a:buNone/>
               <a:defRPr sz="975" b="1">
                 <a:solidFill>
                   <a:srgbClr val="D76532"/>
@@ -7485,7 +7542,7 @@
                 <a:ea typeface="Arial"/>
                 <a:cs typeface="Arial"/>
               </a:rPr>
-              <a:t>CASE STUDY</a:t>
+              <a:t>03  THE PRODUCT LAUNCH PILOT</a:t>
             </a:r>
           </a:p>
         </p:txBody>
@@ -7524,6 +7581,7 @@
           <a:lstStyle xmlns:a="http://schemas.openxmlformats.org/drawingml/2006/main"/>
           <a:p xmlns:a="http://schemas.openxmlformats.org/drawingml/2006/main">
             <a:pPr algn="r">
+              <a:buNone/>
               <a:defRPr sz="825" b="0">
                 <a:solidFill>
                   <a:srgbClr val="8293A4"/>
@@ -7581,6 +7639,7 @@
           <a:lstStyle xmlns:a="http://schemas.openxmlformats.org/drawingml/2006/main"/>
           <a:p xmlns:a="http://schemas.openxmlformats.org/drawingml/2006/main">
             <a:pPr algn="l">
+              <a:buNone/>
               <a:defRPr sz="2850" b="1">
                 <a:solidFill>
                   <a:srgbClr val="FFFFFF"/>
@@ -7638,6 +7697,7 @@
           <a:lstStyle xmlns:a="http://schemas.openxmlformats.org/drawingml/2006/main"/>
           <a:p xmlns:a="http://schemas.openxmlformats.org/drawingml/2006/main">
             <a:pPr algn="l">
+              <a:buNone/>
               <a:defRPr sz="975" b="1">
                 <a:solidFill>
                   <a:srgbClr val="D76532"/>
@@ -7695,6 +7755,7 @@
           <a:lstStyle xmlns:a="http://schemas.openxmlformats.org/drawingml/2006/main"/>
           <a:p xmlns:a="http://schemas.openxmlformats.org/drawingml/2006/main">
             <a:pPr algn="l">
+              <a:buNone/>
               <a:defRPr sz="1650" b="1">
                 <a:solidFill>
                   <a:srgbClr val="FFFFFF"/>
@@ -7752,6 +7813,7 @@
           <a:lstStyle xmlns:a="http://schemas.openxmlformats.org/drawingml/2006/main"/>
           <a:p xmlns:a="http://schemas.openxmlformats.org/drawingml/2006/main">
             <a:pPr algn="l">
+              <a:buNone/>
               <a:defRPr sz="975" b="1">
                 <a:solidFill>
                   <a:srgbClr val="D76532"/>
@@ -7809,6 +7871,7 @@
           <a:lstStyle xmlns:a="http://schemas.openxmlformats.org/drawingml/2006/main"/>
           <a:p xmlns:a="http://schemas.openxmlformats.org/drawingml/2006/main">
             <a:pPr algn="l">
+              <a:buNone/>
               <a:defRPr sz="1650" b="1">
                 <a:solidFill>
                   <a:srgbClr val="FFFFFF"/>
@@ -7896,6 +7959,7 @@
           <a:lstStyle xmlns:a="http://schemas.openxmlformats.org/drawingml/2006/main"/>
           <a:p xmlns:a="http://schemas.openxmlformats.org/drawingml/2006/main">
             <a:pPr algn="l">
+              <a:buNone/>
               <a:defRPr sz="1650" b="1">
                 <a:solidFill>
                   <a:srgbClr val="FFFFFF"/>
@@ -7982,6 +8046,7 @@
           <a:lstStyle xmlns:a="http://schemas.openxmlformats.org/drawingml/2006/main"/>
           <a:p xmlns:a="http://schemas.openxmlformats.org/drawingml/2006/main">
             <a:pPr algn="l">
+              <a:buNone/>
               <a:defRPr sz="975" b="1">
                 <a:solidFill>
                   <a:srgbClr val="D76532"/>
@@ -8000,7 +8065,7 @@
                 <a:ea typeface="Arial"/>
                 <a:cs typeface="Arial"/>
               </a:rPr>
-              <a:t>EVIDENCE</a:t>
+              <a:t>03  THE PRODUCT LAUNCH PILOT</a:t>
             </a:r>
           </a:p>
         </p:txBody>
@@ -8039,6 +8104,7 @@
           <a:lstStyle xmlns:a="http://schemas.openxmlformats.org/drawingml/2006/main"/>
           <a:p xmlns:a="http://schemas.openxmlformats.org/drawingml/2006/main">
             <a:pPr algn="r">
+              <a:buNone/>
               <a:defRPr sz="825" b="0">
                 <a:solidFill>
                   <a:srgbClr val="8A8179"/>
@@ -8096,6 +8162,7 @@
           <a:lstStyle xmlns:a="http://schemas.openxmlformats.org/drawingml/2006/main"/>
           <a:p xmlns:a="http://schemas.openxmlformats.org/drawingml/2006/main">
             <a:pPr algn="l">
+              <a:buNone/>
               <a:defRPr sz="2850" b="1">
                 <a:solidFill>
                   <a:srgbClr val="172737"/>
@@ -8153,6 +8220,7 @@
           <a:lstStyle xmlns:a="http://schemas.openxmlformats.org/drawingml/2006/main"/>
           <a:p xmlns:a="http://schemas.openxmlformats.org/drawingml/2006/main">
             <a:pPr algn="l">
+              <a:buNone/>
               <a:defRPr sz="6300" b="1">
                 <a:solidFill>
                   <a:srgbClr val="D76532"/>
@@ -8210,6 +8278,7 @@
           <a:lstStyle xmlns:a="http://schemas.openxmlformats.org/drawingml/2006/main"/>
           <a:p xmlns:a="http://schemas.openxmlformats.org/drawingml/2006/main">
             <a:pPr algn="l">
+              <a:buNone/>
               <a:defRPr sz="1500" b="1">
                 <a:solidFill>
                   <a:srgbClr val="172737"/>
@@ -8267,6 +8336,7 @@
           <a:lstStyle xmlns:a="http://schemas.openxmlformats.org/drawingml/2006/main"/>
           <a:p xmlns:a="http://schemas.openxmlformats.org/drawingml/2006/main">
             <a:pPr algn="l">
+              <a:buNone/>
               <a:defRPr sz="1725" b="1">
                 <a:solidFill>
                   <a:srgbClr val="172737"/>
@@ -8356,6 +8426,7 @@
           <a:lstStyle xmlns:a="http://schemas.openxmlformats.org/drawingml/2006/main"/>
           <a:p xmlns:a="http://schemas.openxmlformats.org/drawingml/2006/main">
             <a:pPr algn="l">
+              <a:buNone/>
               <a:defRPr sz="1425" b="0">
                 <a:solidFill>
                   <a:srgbClr val="5F6B76"/>
@@ -8445,6 +8516,7 @@
           <a:lstStyle xmlns:a="http://schemas.openxmlformats.org/drawingml/2006/main"/>
           <a:p xmlns:a="http://schemas.openxmlformats.org/drawingml/2006/main">
             <a:pPr algn="l">
+              <a:buNone/>
               <a:defRPr sz="1425" b="0">
                 <a:solidFill>
                   <a:srgbClr val="5F6B76"/>
@@ -8534,6 +8606,7 @@
           <a:lstStyle xmlns:a="http://schemas.openxmlformats.org/drawingml/2006/main"/>
           <a:p xmlns:a="http://schemas.openxmlformats.org/drawingml/2006/main">
             <a:pPr algn="l">
+              <a:buNone/>
               <a:defRPr sz="1425" b="0">
                 <a:solidFill>
                   <a:srgbClr val="5F6B76"/>
@@ -8623,6 +8696,7 @@
           <a:lstStyle xmlns:a="http://schemas.openxmlformats.org/drawingml/2006/main"/>
           <a:p xmlns:a="http://schemas.openxmlformats.org/drawingml/2006/main">
             <a:pPr algn="l">
+              <a:buNone/>
               <a:defRPr sz="1425" b="0">
                 <a:solidFill>
                   <a:srgbClr val="5F6B76"/>
@@ -8680,6 +8754,7 @@
           <a:lstStyle xmlns:a="http://schemas.openxmlformats.org/drawingml/2006/main"/>
           <a:p xmlns:a="http://schemas.openxmlformats.org/drawingml/2006/main">
             <a:pPr algn="l">
+              <a:buNone/>
               <a:defRPr sz="900" b="0">
                 <a:solidFill>
                   <a:srgbClr val="8A8179"/>
@@ -8766,6 +8841,7 @@
           <a:lstStyle xmlns:a="http://schemas.openxmlformats.org/drawingml/2006/main"/>
           <a:p xmlns:a="http://schemas.openxmlformats.org/drawingml/2006/main">
             <a:pPr algn="l">
+              <a:buNone/>
               <a:defRPr sz="975" b="1">
                 <a:solidFill>
                   <a:srgbClr val="D76532"/>
@@ -8784,7 +8860,7 @@
                 <a:ea typeface="Arial"/>
                 <a:cs typeface="Arial"/>
               </a:rPr>
-              <a:t>OPERATING MODEL</a:t>
+              <a:t>03  THE PRODUCT LAUNCH PILOT</a:t>
             </a:r>
           </a:p>
         </p:txBody>
@@ -8823,6 +8899,7 @@
           <a:lstStyle xmlns:a="http://schemas.openxmlformats.org/drawingml/2006/main"/>
           <a:p xmlns:a="http://schemas.openxmlformats.org/drawingml/2006/main">
             <a:pPr algn="r">
+              <a:buNone/>
               <a:defRPr sz="825" b="0">
                 <a:solidFill>
                   <a:srgbClr val="8293A4"/>
@@ -8880,6 +8957,7 @@
           <a:lstStyle xmlns:a="http://schemas.openxmlformats.org/drawingml/2006/main"/>
           <a:p xmlns:a="http://schemas.openxmlformats.org/drawingml/2006/main">
             <a:pPr algn="l">
+              <a:buNone/>
               <a:defRPr sz="2850" b="1">
                 <a:solidFill>
                   <a:srgbClr val="FFFFFF"/>
@@ -8937,6 +9015,7 @@
           <a:lstStyle xmlns:a="http://schemas.openxmlformats.org/drawingml/2006/main"/>
           <a:p xmlns:a="http://schemas.openxmlformats.org/drawingml/2006/main">
             <a:pPr algn="l">
+              <a:buNone/>
               <a:defRPr sz="1575" b="1">
                 <a:solidFill>
                   <a:srgbClr val="FFFFFF"/>
@@ -9024,6 +9103,7 @@
           <a:lstStyle xmlns:a="http://schemas.openxmlformats.org/drawingml/2006/main"/>
           <a:p xmlns:a="http://schemas.openxmlformats.org/drawingml/2006/main">
             <a:pPr algn="l">
+              <a:buNone/>
               <a:defRPr sz="1425" b="0">
                 <a:solidFill>
                   <a:srgbClr val="C1CDD6"/>
@@ -9047,6 +9127,7 @@
           </a:p>
           <a:p xmlns:a="http://schemas.openxmlformats.org/drawingml/2006/main">
             <a:pPr algn="l">
+              <a:buNone/>
               <a:defRPr sz="1425" b="0">
                 <a:solidFill>
                   <a:srgbClr val="C1CDD6"/>
@@ -9070,6 +9151,7 @@
           </a:p>
           <a:p xmlns:a="http://schemas.openxmlformats.org/drawingml/2006/main">
             <a:pPr algn="l">
+              <a:buNone/>
               <a:defRPr sz="1425" b="0">
                 <a:solidFill>
                   <a:srgbClr val="C1CDD6"/>
@@ -9127,6 +9209,7 @@
           <a:lstStyle xmlns:a="http://schemas.openxmlformats.org/drawingml/2006/main"/>
           <a:p xmlns:a="http://schemas.openxmlformats.org/drawingml/2006/main">
             <a:pPr algn="l">
+              <a:buNone/>
               <a:defRPr sz="1575" b="1">
                 <a:solidFill>
                   <a:srgbClr val="FFFFFF"/>
@@ -9214,6 +9297,7 @@
           <a:lstStyle xmlns:a="http://schemas.openxmlformats.org/drawingml/2006/main"/>
           <a:p xmlns:a="http://schemas.openxmlformats.org/drawingml/2006/main">
             <a:pPr algn="l">
+              <a:buNone/>
               <a:defRPr sz="1425" b="0">
                 <a:solidFill>
                   <a:srgbClr val="C1CDD6"/>
@@ -9237,6 +9321,7 @@
           </a:p>
           <a:p xmlns:a="http://schemas.openxmlformats.org/drawingml/2006/main">
             <a:pPr algn="l">
+              <a:buNone/>
               <a:defRPr sz="1425" b="0">
                 <a:solidFill>
                   <a:srgbClr val="C1CDD6"/>
@@ -9260,6 +9345,7 @@
           </a:p>
           <a:p xmlns:a="http://schemas.openxmlformats.org/drawingml/2006/main">
             <a:pPr algn="l">
+              <a:buNone/>
               <a:defRPr sz="1425" b="0">
                 <a:solidFill>
                   <a:srgbClr val="C1CDD6"/>
@@ -9317,6 +9403,7 @@
           <a:lstStyle xmlns:a="http://schemas.openxmlformats.org/drawingml/2006/main"/>
           <a:p xmlns:a="http://schemas.openxmlformats.org/drawingml/2006/main">
             <a:pPr algn="l">
+              <a:buNone/>
               <a:defRPr sz="1575" b="1">
                 <a:solidFill>
                   <a:srgbClr val="FFFFFF"/>
@@ -9404,6 +9491,7 @@
           <a:lstStyle xmlns:a="http://schemas.openxmlformats.org/drawingml/2006/main"/>
           <a:p xmlns:a="http://schemas.openxmlformats.org/drawingml/2006/main">
             <a:pPr algn="l">
+              <a:buNone/>
               <a:defRPr sz="1425" b="0">
                 <a:solidFill>
                   <a:srgbClr val="C1CDD6"/>
@@ -9427,6 +9515,7 @@
           </a:p>
           <a:p xmlns:a="http://schemas.openxmlformats.org/drawingml/2006/main">
             <a:pPr algn="l">
+              <a:buNone/>
               <a:defRPr sz="1425" b="0">
                 <a:solidFill>
                   <a:srgbClr val="C1CDD6"/>
@@ -9450,6 +9539,7 @@
           </a:p>
           <a:p xmlns:a="http://schemas.openxmlformats.org/drawingml/2006/main">
             <a:pPr algn="l">
+              <a:buNone/>
               <a:defRPr sz="1425" b="0">
                 <a:solidFill>
                   <a:srgbClr val="C1CDD6"/>
@@ -9507,6 +9597,7 @@
           <a:lstStyle xmlns:a="http://schemas.openxmlformats.org/drawingml/2006/main"/>
           <a:p xmlns:a="http://schemas.openxmlformats.org/drawingml/2006/main">
             <a:pPr algn="l">
+              <a:buNone/>
               <a:defRPr sz="1575" b="1">
                 <a:solidFill>
                   <a:srgbClr val="FFFFFF"/>
@@ -9594,6 +9685,7 @@
           <a:lstStyle xmlns:a="http://schemas.openxmlformats.org/drawingml/2006/main"/>
           <a:p xmlns:a="http://schemas.openxmlformats.org/drawingml/2006/main">
             <a:pPr algn="l">
+              <a:buNone/>
               <a:defRPr sz="1425" b="0">
                 <a:solidFill>
                   <a:srgbClr val="C1CDD6"/>
@@ -9617,6 +9709,7 @@
           </a:p>
           <a:p xmlns:a="http://schemas.openxmlformats.org/drawingml/2006/main">
             <a:pPr algn="l">
+              <a:buNone/>
               <a:defRPr sz="1425" b="0">
                 <a:solidFill>
                   <a:srgbClr val="C1CDD6"/>
@@ -9640,6 +9733,7 @@
           </a:p>
           <a:p xmlns:a="http://schemas.openxmlformats.org/drawingml/2006/main">
             <a:pPr algn="l">
+              <a:buNone/>
               <a:defRPr sz="1425" b="0">
                 <a:solidFill>
                   <a:srgbClr val="C1CDD6"/>
@@ -9697,6 +9791,7 @@
           <a:lstStyle xmlns:a="http://schemas.openxmlformats.org/drawingml/2006/main"/>
           <a:p xmlns:a="http://schemas.openxmlformats.org/drawingml/2006/main">
             <a:pPr algn="l">
+              <a:buNone/>
               <a:defRPr sz="1500" b="1">
                 <a:solidFill>
                   <a:srgbClr val="FFFFFF"/>
@@ -9783,6 +9878,7 @@
           <a:lstStyle xmlns:a="http://schemas.openxmlformats.org/drawingml/2006/main"/>
           <a:p xmlns:a="http://schemas.openxmlformats.org/drawingml/2006/main">
             <a:pPr algn="l">
+              <a:buNone/>
               <a:defRPr sz="975" b="1">
                 <a:solidFill>
                   <a:srgbClr val="D76532"/>
@@ -9801,7 +9897,7 @@
                 <a:ea typeface="Arial"/>
                 <a:cs typeface="Arial"/>
               </a:rPr>
-              <a:t>REUSE</a:t>
+              <a:t>03  THE PRODUCT LAUNCH PILOT</a:t>
             </a:r>
           </a:p>
         </p:txBody>
@@ -9840,6 +9936,7 @@
           <a:lstStyle xmlns:a="http://schemas.openxmlformats.org/drawingml/2006/main"/>
           <a:p xmlns:a="http://schemas.openxmlformats.org/drawingml/2006/main">
             <a:pPr algn="r">
+              <a:buNone/>
               <a:defRPr sz="825" b="0">
                 <a:solidFill>
                   <a:srgbClr val="8A8179"/>
@@ -9897,6 +9994,7 @@
           <a:lstStyle xmlns:a="http://schemas.openxmlformats.org/drawingml/2006/main"/>
           <a:p xmlns:a="http://schemas.openxmlformats.org/drawingml/2006/main">
             <a:pPr algn="l">
+              <a:buNone/>
               <a:defRPr sz="2850" b="1">
                 <a:solidFill>
                   <a:srgbClr val="172737"/>
@@ -9986,6 +10084,7 @@
           <a:lstStyle xmlns:a="http://schemas.openxmlformats.org/drawingml/2006/main"/>
           <a:p xmlns:a="http://schemas.openxmlformats.org/drawingml/2006/main">
             <a:pPr algn="ctr">
+              <a:buNone/>
               <a:defRPr sz="1650" b="1">
                 <a:solidFill>
                   <a:srgbClr val="FFFFFF"/>
@@ -10075,6 +10174,7 @@
           <a:lstStyle xmlns:a="http://schemas.openxmlformats.org/drawingml/2006/main"/>
           <a:p xmlns:a="http://schemas.openxmlformats.org/drawingml/2006/main">
             <a:pPr algn="ctr">
+              <a:buNone/>
               <a:defRPr sz="1350" b="1">
                 <a:solidFill>
                   <a:srgbClr val="FFFFFF"/>
@@ -10194,6 +10294,7 @@
           <a:lstStyle xmlns:a="http://schemas.openxmlformats.org/drawingml/2006/main"/>
           <a:p xmlns:a="http://schemas.openxmlformats.org/drawingml/2006/main">
             <a:pPr algn="ctr">
+              <a:buNone/>
               <a:defRPr sz="1350" b="1">
                 <a:solidFill>
                   <a:srgbClr val="FFFFFF"/>
@@ -10313,6 +10414,7 @@
           <a:lstStyle xmlns:a="http://schemas.openxmlformats.org/drawingml/2006/main"/>
           <a:p xmlns:a="http://schemas.openxmlformats.org/drawingml/2006/main">
             <a:pPr algn="ctr">
+              <a:buNone/>
               <a:defRPr sz="1350" b="1">
                 <a:solidFill>
                   <a:srgbClr val="FFFFFF"/>
@@ -10432,6 +10534,7 @@
           <a:lstStyle xmlns:a="http://schemas.openxmlformats.org/drawingml/2006/main"/>
           <a:p xmlns:a="http://schemas.openxmlformats.org/drawingml/2006/main">
             <a:pPr algn="ctr">
+              <a:buNone/>
               <a:defRPr sz="1350" b="1">
                 <a:solidFill>
                   <a:srgbClr val="FFFFFF"/>
@@ -10551,6 +10654,7 @@
           <a:lstStyle xmlns:a="http://schemas.openxmlformats.org/drawingml/2006/main"/>
           <a:p xmlns:a="http://schemas.openxmlformats.org/drawingml/2006/main">
             <a:pPr algn="ctr">
+              <a:buNone/>
               <a:defRPr sz="1350" b="1">
                 <a:solidFill>
                   <a:srgbClr val="FFFFFF"/>
@@ -10670,6 +10774,7 @@
           <a:lstStyle xmlns:a="http://schemas.openxmlformats.org/drawingml/2006/main"/>
           <a:p xmlns:a="http://schemas.openxmlformats.org/drawingml/2006/main">
             <a:pPr algn="ctr">
+              <a:buNone/>
               <a:defRPr sz="1350" b="1">
                 <a:solidFill>
                   <a:srgbClr val="FFFFFF"/>
@@ -10757,6 +10862,7 @@
           <a:lstStyle xmlns:a="http://schemas.openxmlformats.org/drawingml/2006/main"/>
           <a:p xmlns:a="http://schemas.openxmlformats.org/drawingml/2006/main">
             <a:pPr algn="l">
+              <a:buNone/>
               <a:defRPr sz="1650" b="1">
                 <a:solidFill>
                   <a:srgbClr val="172737"/>
@@ -10843,6 +10949,7 @@
           <a:lstStyle xmlns:a="http://schemas.openxmlformats.org/drawingml/2006/main"/>
           <a:p xmlns:a="http://schemas.openxmlformats.org/drawingml/2006/main">
             <a:pPr algn="l">
+              <a:buNone/>
               <a:defRPr sz="975" b="1">
                 <a:solidFill>
                   <a:srgbClr val="D76532"/>
@@ -10861,7 +10968,7 @@
                 <a:ea typeface="Arial"/>
                 <a:cs typeface="Arial"/>
               </a:rPr>
-              <a:t>THE ASSET</a:t>
+              <a:t>04  CONTENT AS A BUSINESS ASSET</a:t>
             </a:r>
           </a:p>
         </p:txBody>
@@ -10900,6 +11007,7 @@
           <a:lstStyle xmlns:a="http://schemas.openxmlformats.org/drawingml/2006/main"/>
           <a:p xmlns:a="http://schemas.openxmlformats.org/drawingml/2006/main">
             <a:pPr algn="r">
+              <a:buNone/>
               <a:defRPr sz="825" b="0">
                 <a:solidFill>
                   <a:srgbClr val="8293A4"/>
@@ -10957,6 +11065,7 @@
           <a:lstStyle xmlns:a="http://schemas.openxmlformats.org/drawingml/2006/main"/>
           <a:p xmlns:a="http://schemas.openxmlformats.org/drawingml/2006/main">
             <a:pPr algn="l">
+              <a:buNone/>
               <a:defRPr sz="2850" b="1">
                 <a:solidFill>
                   <a:srgbClr val="FFFFFF"/>
@@ -11014,6 +11123,7 @@
           <a:lstStyle xmlns:a="http://schemas.openxmlformats.org/drawingml/2006/main"/>
           <a:p xmlns:a="http://schemas.openxmlformats.org/drawingml/2006/main">
             <a:pPr algn="l">
+              <a:buNone/>
               <a:defRPr sz="1200" b="1">
                 <a:solidFill>
                   <a:srgbClr val="D76532"/>
@@ -11071,6 +11181,7 @@
           <a:lstStyle xmlns:a="http://schemas.openxmlformats.org/drawingml/2006/main"/>
           <a:p xmlns:a="http://schemas.openxmlformats.org/drawingml/2006/main">
             <a:pPr algn="l">
+              <a:buNone/>
               <a:defRPr sz="1875" b="1">
                 <a:solidFill>
                   <a:srgbClr val="FFFFFF"/>
@@ -11128,6 +11239,7 @@
           <a:lstStyle xmlns:a="http://schemas.openxmlformats.org/drawingml/2006/main"/>
           <a:p xmlns:a="http://schemas.openxmlformats.org/drawingml/2006/main">
             <a:pPr algn="l">
+              <a:buNone/>
               <a:defRPr sz="1500" b="0">
                 <a:solidFill>
                   <a:srgbClr val="C4CED7"/>
@@ -11185,6 +11297,7 @@
           <a:lstStyle xmlns:a="http://schemas.openxmlformats.org/drawingml/2006/main"/>
           <a:p xmlns:a="http://schemas.openxmlformats.org/drawingml/2006/main">
             <a:pPr algn="l">
+              <a:buNone/>
               <a:defRPr sz="1200" b="1">
                 <a:solidFill>
                   <a:srgbClr val="65B8A5"/>
@@ -11242,6 +11355,7 @@
           <a:lstStyle xmlns:a="http://schemas.openxmlformats.org/drawingml/2006/main"/>
           <a:p xmlns:a="http://schemas.openxmlformats.org/drawingml/2006/main">
             <a:pPr algn="l">
+              <a:buNone/>
               <a:defRPr sz="1875" b="1">
                 <a:solidFill>
                   <a:srgbClr val="FFFFFF"/>
@@ -11299,6 +11413,7 @@
           <a:lstStyle xmlns:a="http://schemas.openxmlformats.org/drawingml/2006/main"/>
           <a:p xmlns:a="http://schemas.openxmlformats.org/drawingml/2006/main">
             <a:pPr algn="l">
+              <a:buNone/>
               <a:defRPr sz="1500" b="0">
                 <a:solidFill>
                   <a:srgbClr val="C4CED7"/>
@@ -11356,6 +11471,7 @@
           <a:lstStyle xmlns:a="http://schemas.openxmlformats.org/drawingml/2006/main"/>
           <a:p xmlns:a="http://schemas.openxmlformats.org/drawingml/2006/main">
             <a:pPr algn="l">
+              <a:buNone/>
               <a:defRPr sz="1200" b="1">
                 <a:solidFill>
                   <a:srgbClr val="E2A93B"/>
@@ -11413,6 +11529,7 @@
           <a:lstStyle xmlns:a="http://schemas.openxmlformats.org/drawingml/2006/main"/>
           <a:p xmlns:a="http://schemas.openxmlformats.org/drawingml/2006/main">
             <a:pPr algn="l">
+              <a:buNone/>
               <a:defRPr sz="1875" b="1">
                 <a:solidFill>
                   <a:srgbClr val="FFFFFF"/>
@@ -11470,6 +11587,7 @@
           <a:lstStyle xmlns:a="http://schemas.openxmlformats.org/drawingml/2006/main"/>
           <a:p xmlns:a="http://schemas.openxmlformats.org/drawingml/2006/main">
             <a:pPr algn="l">
+              <a:buNone/>
               <a:defRPr sz="1500" b="0">
                 <a:solidFill>
                   <a:srgbClr val="C4CED7"/>
@@ -11527,6 +11645,7 @@
           <a:lstStyle xmlns:a="http://schemas.openxmlformats.org/drawingml/2006/main"/>
           <a:p xmlns:a="http://schemas.openxmlformats.org/drawingml/2006/main">
             <a:pPr algn="l">
+              <a:buNone/>
               <a:defRPr sz="1650" b="1">
                 <a:solidFill>
                   <a:srgbClr val="FFFFFF"/>
@@ -11613,6 +11732,7 @@
           <a:lstStyle xmlns:a="http://schemas.openxmlformats.org/drawingml/2006/main"/>
           <a:p xmlns:a="http://schemas.openxmlformats.org/drawingml/2006/main">
             <a:pPr algn="l">
+              <a:buNone/>
               <a:defRPr sz="975" b="1">
                 <a:solidFill>
                   <a:srgbClr val="D76532"/>
@@ -11631,7 +11751,7 @@
                 <a:ea typeface="Arial"/>
                 <a:cs typeface="Arial"/>
               </a:rPr>
-              <a:t>CONTENT VALUE</a:t>
+              <a:t>04  CONTENT AS A BUSINESS ASSET</a:t>
             </a:r>
           </a:p>
         </p:txBody>
@@ -11670,6 +11790,7 @@
           <a:lstStyle xmlns:a="http://schemas.openxmlformats.org/drawingml/2006/main"/>
           <a:p xmlns:a="http://schemas.openxmlformats.org/drawingml/2006/main">
             <a:pPr algn="r">
+              <a:buNone/>
               <a:defRPr sz="825" b="0">
                 <a:solidFill>
                   <a:srgbClr val="8A8179"/>
@@ -11727,6 +11848,7 @@
           <a:lstStyle xmlns:a="http://schemas.openxmlformats.org/drawingml/2006/main"/>
           <a:p xmlns:a="http://schemas.openxmlformats.org/drawingml/2006/main">
             <a:pPr algn="l">
+              <a:buNone/>
               <a:defRPr sz="2850" b="1">
                 <a:solidFill>
                   <a:srgbClr val="172737"/>
@@ -11784,6 +11906,7 @@
           <a:lstStyle xmlns:a="http://schemas.openxmlformats.org/drawingml/2006/main"/>
           <a:p xmlns:a="http://schemas.openxmlformats.org/drawingml/2006/main">
             <a:pPr algn="l">
+              <a:buNone/>
               <a:defRPr sz="1575" b="1">
                 <a:solidFill>
                   <a:srgbClr val="D76532"/>
@@ -11873,6 +11996,7 @@
           <a:lstStyle xmlns:a="http://schemas.openxmlformats.org/drawingml/2006/main"/>
           <a:p xmlns:a="http://schemas.openxmlformats.org/drawingml/2006/main">
             <a:pPr algn="ctr">
+              <a:buNone/>
               <a:defRPr sz="2025" b="1">
                 <a:solidFill>
                   <a:srgbClr val="FFFFFF"/>
@@ -11930,6 +12054,7 @@
           <a:lstStyle xmlns:a="http://schemas.openxmlformats.org/drawingml/2006/main"/>
           <a:p xmlns:a="http://schemas.openxmlformats.org/drawingml/2006/main">
             <a:pPr algn="l">
+              <a:buNone/>
               <a:defRPr sz="1500" b="1">
                 <a:solidFill>
                   <a:srgbClr val="D76532"/>
@@ -11987,6 +12112,7 @@
           <a:lstStyle xmlns:a="http://schemas.openxmlformats.org/drawingml/2006/main"/>
           <a:p xmlns:a="http://schemas.openxmlformats.org/drawingml/2006/main">
             <a:pPr algn="l">
+              <a:buNone/>
               <a:defRPr sz="1275" b="0">
                 <a:solidFill>
                   <a:srgbClr val="5F6B76"/>
@@ -12044,6 +12170,7 @@
           <a:lstStyle xmlns:a="http://schemas.openxmlformats.org/drawingml/2006/main"/>
           <a:p xmlns:a="http://schemas.openxmlformats.org/drawingml/2006/main">
             <a:pPr algn="l">
+              <a:buNone/>
               <a:defRPr sz="1500" b="1">
                 <a:solidFill>
                   <a:srgbClr val="65B8A5"/>
@@ -12101,6 +12228,7 @@
           <a:lstStyle xmlns:a="http://schemas.openxmlformats.org/drawingml/2006/main"/>
           <a:p xmlns:a="http://schemas.openxmlformats.org/drawingml/2006/main">
             <a:pPr algn="l">
+              <a:buNone/>
               <a:defRPr sz="1275" b="0">
                 <a:solidFill>
                   <a:srgbClr val="5F6B76"/>
@@ -12158,6 +12286,7 @@
           <a:lstStyle xmlns:a="http://schemas.openxmlformats.org/drawingml/2006/main"/>
           <a:p xmlns:a="http://schemas.openxmlformats.org/drawingml/2006/main">
             <a:pPr algn="l">
+              <a:buNone/>
               <a:defRPr sz="1500" b="1">
                 <a:solidFill>
                   <a:srgbClr val="E2A93B"/>
@@ -12215,6 +12344,7 @@
           <a:lstStyle xmlns:a="http://schemas.openxmlformats.org/drawingml/2006/main"/>
           <a:p xmlns:a="http://schemas.openxmlformats.org/drawingml/2006/main">
             <a:pPr algn="l">
+              <a:buNone/>
               <a:defRPr sz="1275" b="0">
                 <a:solidFill>
                   <a:srgbClr val="5F6B76"/>
@@ -12272,6 +12402,7 @@
           <a:lstStyle xmlns:a="http://schemas.openxmlformats.org/drawingml/2006/main"/>
           <a:p xmlns:a="http://schemas.openxmlformats.org/drawingml/2006/main">
             <a:pPr algn="l">
+              <a:buNone/>
               <a:defRPr sz="1500" b="1">
                 <a:solidFill>
                   <a:srgbClr val="7189A5"/>
@@ -12329,6 +12460,7 @@
           <a:lstStyle xmlns:a="http://schemas.openxmlformats.org/drawingml/2006/main"/>
           <a:p xmlns:a="http://schemas.openxmlformats.org/drawingml/2006/main">
             <a:pPr algn="l">
+              <a:buNone/>
               <a:defRPr sz="1275" b="0">
                 <a:solidFill>
                   <a:srgbClr val="5F6B76"/>
@@ -12386,6 +12518,7 @@
           <a:lstStyle xmlns:a="http://schemas.openxmlformats.org/drawingml/2006/main"/>
           <a:p xmlns:a="http://schemas.openxmlformats.org/drawingml/2006/main">
             <a:pPr algn="l">
+              <a:buNone/>
               <a:defRPr sz="1500" b="1">
                 <a:solidFill>
                   <a:srgbClr val="D76532"/>
@@ -12443,6 +12576,7 @@
           <a:lstStyle xmlns:a="http://schemas.openxmlformats.org/drawingml/2006/main"/>
           <a:p xmlns:a="http://schemas.openxmlformats.org/drawingml/2006/main">
             <a:pPr algn="l">
+              <a:buNone/>
               <a:defRPr sz="1275" b="0">
                 <a:solidFill>
                   <a:srgbClr val="5F6B76"/>
@@ -12500,6 +12634,7 @@
           <a:lstStyle xmlns:a="http://schemas.openxmlformats.org/drawingml/2006/main"/>
           <a:p xmlns:a="http://schemas.openxmlformats.org/drawingml/2006/main">
             <a:pPr algn="l">
+              <a:buNone/>
               <a:defRPr sz="1275" b="1">
                 <a:solidFill>
                   <a:srgbClr val="172737"/>
@@ -12586,6 +12721,7 @@
           <a:lstStyle xmlns:a="http://schemas.openxmlformats.org/drawingml/2006/main"/>
           <a:p xmlns:a="http://schemas.openxmlformats.org/drawingml/2006/main">
             <a:pPr algn="l">
+              <a:buNone/>
               <a:defRPr sz="975" b="1">
                 <a:solidFill>
                   <a:srgbClr val="D76532"/>
@@ -12604,7 +12740,7 @@
                 <a:ea typeface="Arial"/>
                 <a:cs typeface="Arial"/>
               </a:rPr>
-              <a:t>THE COMBINED STORY</a:t>
+              <a:t>EXECUTIVE SUMMARY</a:t>
             </a:r>
           </a:p>
         </p:txBody>
@@ -12643,6 +12779,7 @@
           <a:lstStyle xmlns:a="http://schemas.openxmlformats.org/drawingml/2006/main"/>
           <a:p xmlns:a="http://schemas.openxmlformats.org/drawingml/2006/main">
             <a:pPr algn="r">
+              <a:buNone/>
               <a:defRPr sz="825" b="0">
                 <a:solidFill>
                   <a:srgbClr val="8A8179"/>
@@ -12700,6 +12837,7 @@
           <a:lstStyle xmlns:a="http://schemas.openxmlformats.org/drawingml/2006/main"/>
           <a:p xmlns:a="http://schemas.openxmlformats.org/drawingml/2006/main">
             <a:pPr algn="l">
+              <a:buNone/>
               <a:defRPr sz="2850" b="1">
                 <a:solidFill>
                   <a:srgbClr val="172737"/>
@@ -12718,7 +12856,7 @@
                 <a:ea typeface="Arial"/>
                 <a:cs typeface="Arial"/>
               </a:rPr>
-              <a:t>Content earns investment when its value is visible</a:t>
+              <a:t>A unified content program makes value visible</a:t>
             </a:r>
           </a:p>
         </p:txBody>
@@ -12757,6 +12895,7 @@
           <a:lstStyle xmlns:a="http://schemas.openxmlformats.org/drawingml/2006/main"/>
           <a:p xmlns:a="http://schemas.openxmlformats.org/drawingml/2006/main">
             <a:pPr algn="l">
+              <a:buNone/>
               <a:defRPr sz="1575" b="1">
                 <a:solidFill>
                   <a:srgbClr val="D76532"/>
@@ -12775,7 +12914,7 @@
                 <a:ea typeface="Arial"/>
                 <a:cs typeface="Arial"/>
               </a:rPr>
-              <a:t>A unified strategy connects customer needs, source content, team effort, and business results.</a:t>
+              <a:t>The deck connects customer needs to a shared way of working, then shows how to measure and manage the resulting asset.</a:t>
             </a:r>
           </a:p>
         </p:txBody>
@@ -12814,6 +12953,7 @@
           <a:lstStyle xmlns:a="http://schemas.openxmlformats.org/drawingml/2006/main"/>
           <a:p xmlns:a="http://schemas.openxmlformats.org/drawingml/2006/main">
             <a:pPr algn="l">
+              <a:buNone/>
               <a:defRPr sz="3600" b="1">
                 <a:solidFill>
                   <a:srgbClr val="D76532"/>
@@ -12866,11 +13006,12 @@
         </p:spPr>
         <p:txBody>
           <a:bodyPr xmlns:a="http://schemas.openxmlformats.org/drawingml/2006/main" anchor="ctr">
-            <a:normAutofit fontScale="100000"/>
+            <a:normAutofit fontScale="91846"/>
           </a:bodyPr>
           <a:lstStyle xmlns:a="http://schemas.openxmlformats.org/drawingml/2006/main"/>
           <a:p xmlns:a="http://schemas.openxmlformats.org/drawingml/2006/main">
             <a:pPr algn="l">
+              <a:buNone/>
               <a:defRPr sz="1725" b="1">
                 <a:solidFill>
                   <a:srgbClr val="172737"/>
@@ -12889,7 +13030,7 @@
                 <a:ea typeface="Arial"/>
                 <a:cs typeface="Arial"/>
               </a:rPr>
-              <a:t>Treat content as a product</a:t>
+              <a:t>Start with the customer journey</a:t>
             </a:r>
           </a:p>
         </p:txBody>
@@ -12928,6 +13069,7 @@
           <a:lstStyle xmlns:a="http://schemas.openxmlformats.org/drawingml/2006/main"/>
           <a:p xmlns:a="http://schemas.openxmlformats.org/drawingml/2006/main">
             <a:pPr algn="l">
+              <a:buNone/>
               <a:defRPr sz="1350" b="0">
                 <a:solidFill>
                   <a:srgbClr val="5F6B76"/>
@@ -12946,7 +13088,7 @@
                 <a:ea typeface="Arial"/>
                 <a:cs typeface="Arial"/>
               </a:rPr>
-              <a:t>Define the customer problem, owner, lifecycle, and evidence of use.</a:t>
+              <a:t>Agree on the customer task, authoritative source, owner, and lifecycle before producing another format.</a:t>
             </a:r>
           </a:p>
         </p:txBody>
@@ -12985,6 +13127,7 @@
           <a:lstStyle xmlns:a="http://schemas.openxmlformats.org/drawingml/2006/main"/>
           <a:p xmlns:a="http://schemas.openxmlformats.org/drawingml/2006/main">
             <a:pPr algn="l">
+              <a:buNone/>
               <a:defRPr sz="3600" b="1">
                 <a:solidFill>
                   <a:srgbClr val="65B8A5"/>
@@ -13042,6 +13185,7 @@
           <a:lstStyle xmlns:a="http://schemas.openxmlformats.org/drawingml/2006/main"/>
           <a:p xmlns:a="http://schemas.openxmlformats.org/drawingml/2006/main">
             <a:pPr algn="l">
+              <a:buNone/>
               <a:defRPr sz="1725" b="1">
                 <a:solidFill>
                   <a:srgbClr val="172737"/>
@@ -13060,7 +13204,7 @@
                 <a:ea typeface="Arial"/>
                 <a:cs typeface="Arial"/>
               </a:rPr>
-              <a:t>Coordinate the system</a:t>
+              <a:t>Run one planning method</a:t>
             </a:r>
           </a:p>
         </p:txBody>
@@ -13099,6 +13243,7 @@
           <a:lstStyle xmlns:a="http://schemas.openxmlformats.org/drawingml/2006/main"/>
           <a:p xmlns:a="http://schemas.openxmlformats.org/drawingml/2006/main">
             <a:pPr algn="l">
+              <a:buNone/>
               <a:defRPr sz="1350" b="0">
                 <a:solidFill>
                   <a:srgbClr val="5F6B76"/>
@@ -13117,7 +13262,7 @@
                 <a:ea typeface="Arial"/>
                 <a:cs typeface="Arial"/>
               </a:rPr>
-              <a:t>Agree on sources, responsibilities, reuse, review, and measures.</a:t>
+              <a:t>Use the seven-step framework and a shared pilot to expose overlap, gaps, and decisions.</a:t>
             </a:r>
           </a:p>
         </p:txBody>
@@ -13156,6 +13301,7 @@
           <a:lstStyle xmlns:a="http://schemas.openxmlformats.org/drawingml/2006/main"/>
           <a:p xmlns:a="http://schemas.openxmlformats.org/drawingml/2006/main">
             <a:pPr algn="l">
+              <a:buNone/>
               <a:defRPr sz="3600" b="1">
                 <a:solidFill>
                   <a:srgbClr val="E2A93B"/>
@@ -13213,6 +13359,7 @@
           <a:lstStyle xmlns:a="http://schemas.openxmlformats.org/drawingml/2006/main"/>
           <a:p xmlns:a="http://schemas.openxmlformats.org/drawingml/2006/main">
             <a:pPr algn="l">
+              <a:buNone/>
               <a:defRPr sz="1725" b="1">
                 <a:solidFill>
                   <a:srgbClr val="172737"/>
@@ -13231,7 +13378,7 @@
                 <a:ea typeface="Arial"/>
                 <a:cs typeface="Arial"/>
               </a:rPr>
-              <a:t>Manage the asset</a:t>
+              <a:t>Show the business case</a:t>
             </a:r>
           </a:p>
         </p:txBody>
@@ -13270,6 +13417,7 @@
           <a:lstStyle xmlns:a="http://schemas.openxmlformats.org/drawingml/2006/main"/>
           <a:p xmlns:a="http://schemas.openxmlformats.org/drawingml/2006/main">
             <a:pPr algn="l">
+              <a:buNone/>
               <a:defRPr sz="1350" b="0">
                 <a:solidFill>
                   <a:srgbClr val="5F6B76"/>
@@ -13288,7 +13436,7 @@
                 <a:ea typeface="Arial"/>
                 <a:cs typeface="Arial"/>
               </a:rPr>
-              <a:t>Estimate cost, contribution, risk, and future reuse before funding work.</a:t>
+              <a:t>Track reuse, quality, cost, and performance to guide investment and retirement.</a:t>
             </a:r>
           </a:p>
         </p:txBody>
@@ -13356,6 +13504,7 @@
           <a:lstStyle xmlns:a="http://schemas.openxmlformats.org/drawingml/2006/main"/>
           <a:p xmlns:a="http://schemas.openxmlformats.org/drawingml/2006/main">
             <a:pPr algn="l">
+              <a:buNone/>
               <a:defRPr sz="975" b="1">
                 <a:solidFill>
                   <a:srgbClr val="D76532"/>
@@ -13374,7 +13523,7 @@
                 <a:ea typeface="Arial"/>
                 <a:cs typeface="Arial"/>
               </a:rPr>
-              <a:t>CONTENT VALUE</a:t>
+              <a:t>04  CONTENT AS A BUSINESS ASSET</a:t>
             </a:r>
           </a:p>
         </p:txBody>
@@ -13413,6 +13562,7 @@
           <a:lstStyle xmlns:a="http://schemas.openxmlformats.org/drawingml/2006/main"/>
           <a:p xmlns:a="http://schemas.openxmlformats.org/drawingml/2006/main">
             <a:pPr algn="r">
+              <a:buNone/>
               <a:defRPr sz="825" b="0">
                 <a:solidFill>
                   <a:srgbClr val="8A8179"/>
@@ -13470,6 +13620,7 @@
           <a:lstStyle xmlns:a="http://schemas.openxmlformats.org/drawingml/2006/main"/>
           <a:p xmlns:a="http://schemas.openxmlformats.org/drawingml/2006/main">
             <a:pPr algn="l">
+              <a:buNone/>
               <a:defRPr sz="2850" b="1">
                 <a:solidFill>
                   <a:srgbClr val="172737"/>
@@ -13527,6 +13678,7 @@
           <a:lstStyle xmlns:a="http://schemas.openxmlformats.org/drawingml/2006/main"/>
           <a:p xmlns:a="http://schemas.openxmlformats.org/drawingml/2006/main">
             <a:pPr algn="l">
+              <a:buNone/>
               <a:defRPr sz="1575" b="1">
                 <a:solidFill>
                   <a:srgbClr val="D76532"/>
@@ -13552,7 +13704,7 @@
       </p:sp>
       <p:graphicFrame>
         <p:nvGraphicFramePr>
-          <p:cNvPr id="11" name=""/>
+          <p:cNvPr id="13" name=""/>
           <p:cNvGraphicFramePr/>
           <p:nvPr/>
         </p:nvGraphicFramePr>
@@ -14051,6 +14203,7 @@
           <a:lstStyle xmlns:a="http://schemas.openxmlformats.org/drawingml/2006/main"/>
           <a:p xmlns:a="http://schemas.openxmlformats.org/drawingml/2006/main">
             <a:pPr algn="l">
+              <a:buNone/>
               <a:defRPr sz="1200" b="0">
                 <a:solidFill>
                   <a:srgbClr val="5F6B76"/>
@@ -14137,6 +14290,7 @@
           <a:lstStyle xmlns:a="http://schemas.openxmlformats.org/drawingml/2006/main"/>
           <a:p xmlns:a="http://schemas.openxmlformats.org/drawingml/2006/main">
             <a:pPr algn="l">
+              <a:buNone/>
               <a:defRPr sz="975" b="1">
                 <a:solidFill>
                   <a:srgbClr val="D76532"/>
@@ -14155,7 +14309,7 @@
                 <a:ea typeface="Arial"/>
                 <a:cs typeface="Arial"/>
               </a:rPr>
-              <a:t>QUALITY VALUE</a:t>
+              <a:t>04  CONTENT AS A BUSINESS ASSET</a:t>
             </a:r>
           </a:p>
         </p:txBody>
@@ -14194,6 +14348,7 @@
           <a:lstStyle xmlns:a="http://schemas.openxmlformats.org/drawingml/2006/main"/>
           <a:p xmlns:a="http://schemas.openxmlformats.org/drawingml/2006/main">
             <a:pPr algn="r">
+              <a:buNone/>
               <a:defRPr sz="825" b="0">
                 <a:solidFill>
                   <a:srgbClr val="8293A4"/>
@@ -14251,6 +14406,7 @@
           <a:lstStyle xmlns:a="http://schemas.openxmlformats.org/drawingml/2006/main"/>
           <a:p xmlns:a="http://schemas.openxmlformats.org/drawingml/2006/main">
             <a:pPr algn="l">
+              <a:buNone/>
               <a:defRPr sz="2850" b="1">
                 <a:solidFill>
                   <a:srgbClr val="FFFFFF"/>
@@ -14308,6 +14464,7 @@
           <a:lstStyle xmlns:a="http://schemas.openxmlformats.org/drawingml/2006/main"/>
           <a:p xmlns:a="http://schemas.openxmlformats.org/drawingml/2006/main">
             <a:pPr algn="l">
+              <a:buNone/>
               <a:defRPr sz="2025" b="1">
                 <a:solidFill>
                   <a:srgbClr val="D76532"/>
@@ -14365,6 +14522,7 @@
           <a:lstStyle xmlns:a="http://schemas.openxmlformats.org/drawingml/2006/main"/>
           <a:p xmlns:a="http://schemas.openxmlformats.org/drawingml/2006/main">
             <a:pPr algn="l">
+              <a:buNone/>
               <a:defRPr sz="1575" b="1">
                 <a:solidFill>
                   <a:srgbClr val="FFFFFF"/>
@@ -14422,6 +14580,7 @@
           <a:lstStyle xmlns:a="http://schemas.openxmlformats.org/drawingml/2006/main"/>
           <a:p xmlns:a="http://schemas.openxmlformats.org/drawingml/2006/main">
             <a:pPr algn="l">
+              <a:buNone/>
               <a:defRPr sz="1650" b="0">
                 <a:solidFill>
                   <a:srgbClr val="C6D0D8"/>
@@ -14479,6 +14638,7 @@
           <a:lstStyle xmlns:a="http://schemas.openxmlformats.org/drawingml/2006/main"/>
           <a:p xmlns:a="http://schemas.openxmlformats.org/drawingml/2006/main">
             <a:pPr algn="l">
+              <a:buNone/>
               <a:defRPr sz="2025" b="1">
                 <a:solidFill>
                   <a:srgbClr val="65B8A5"/>
@@ -14536,6 +14696,7 @@
           <a:lstStyle xmlns:a="http://schemas.openxmlformats.org/drawingml/2006/main"/>
           <a:p xmlns:a="http://schemas.openxmlformats.org/drawingml/2006/main">
             <a:pPr algn="l">
+              <a:buNone/>
               <a:defRPr sz="1575" b="1">
                 <a:solidFill>
                   <a:srgbClr val="FFFFFF"/>
@@ -14593,6 +14754,7 @@
           <a:lstStyle xmlns:a="http://schemas.openxmlformats.org/drawingml/2006/main"/>
           <a:p xmlns:a="http://schemas.openxmlformats.org/drawingml/2006/main">
             <a:pPr algn="l">
+              <a:buNone/>
               <a:defRPr sz="1650" b="0">
                 <a:solidFill>
                   <a:srgbClr val="C6D0D8"/>
@@ -14680,6 +14842,7 @@
           <a:lstStyle xmlns:a="http://schemas.openxmlformats.org/drawingml/2006/main"/>
           <a:p xmlns:a="http://schemas.openxmlformats.org/drawingml/2006/main">
             <a:pPr algn="l">
+              <a:buNone/>
               <a:defRPr sz="1575" b="1">
                 <a:solidFill>
                   <a:srgbClr val="FFFFFF"/>
@@ -14766,6 +14929,7 @@
           <a:lstStyle xmlns:a="http://schemas.openxmlformats.org/drawingml/2006/main"/>
           <a:p xmlns:a="http://schemas.openxmlformats.org/drawingml/2006/main">
             <a:pPr algn="l">
+              <a:buNone/>
               <a:defRPr sz="975" b="1">
                 <a:solidFill>
                   <a:srgbClr val="D76532"/>
@@ -14784,7 +14948,7 @@
                 <a:ea typeface="Arial"/>
                 <a:cs typeface="Arial"/>
               </a:rPr>
-              <a:t>EXECUTIVE SCORECARD</a:t>
+              <a:t>04  CONTENT AS A BUSINESS ASSET</a:t>
             </a:r>
           </a:p>
         </p:txBody>
@@ -14823,6 +14987,7 @@
           <a:lstStyle xmlns:a="http://schemas.openxmlformats.org/drawingml/2006/main"/>
           <a:p xmlns:a="http://schemas.openxmlformats.org/drawingml/2006/main">
             <a:pPr algn="r">
+              <a:buNone/>
               <a:defRPr sz="825" b="0">
                 <a:solidFill>
                   <a:srgbClr val="8A8179"/>
@@ -14880,6 +15045,7 @@
           <a:lstStyle xmlns:a="http://schemas.openxmlformats.org/drawingml/2006/main"/>
           <a:p xmlns:a="http://schemas.openxmlformats.org/drawingml/2006/main">
             <a:pPr algn="l">
+              <a:buNone/>
               <a:defRPr sz="2850" b="1">
                 <a:solidFill>
                   <a:srgbClr val="172737"/>
@@ -14905,7 +15071,7 @@
       </p:sp>
       <p:graphicFrame>
         <p:nvGraphicFramePr>
-          <p:cNvPr id="9" name=""/>
+          <p:cNvPr id="11" name=""/>
           <p:cNvGraphicFramePr/>
           <p:nvPr/>
         </p:nvGraphicFramePr>
@@ -15478,6 +15644,7 @@
           <a:lstStyle xmlns:a="http://schemas.openxmlformats.org/drawingml/2006/main"/>
           <a:p xmlns:a="http://schemas.openxmlformats.org/drawingml/2006/main">
             <a:pPr algn="l">
+              <a:buNone/>
               <a:defRPr sz="1200" b="0">
                 <a:solidFill>
                   <a:srgbClr val="5F6B76"/>
@@ -15564,6 +15731,7 @@
           <a:lstStyle xmlns:a="http://schemas.openxmlformats.org/drawingml/2006/main"/>
           <a:p xmlns:a="http://schemas.openxmlformats.org/drawingml/2006/main">
             <a:pPr algn="l">
+              <a:buNone/>
               <a:defRPr sz="975" b="1">
                 <a:solidFill>
                   <a:srgbClr val="D76532"/>
@@ -15582,7 +15750,7 @@
                 <a:ea typeface="Arial"/>
                 <a:cs typeface="Arial"/>
               </a:rPr>
-              <a:t>ASSET MANAGEMENT</a:t>
+              <a:t>04  CONTENT AS A BUSINESS ASSET</a:t>
             </a:r>
           </a:p>
         </p:txBody>
@@ -15621,6 +15789,7 @@
           <a:lstStyle xmlns:a="http://schemas.openxmlformats.org/drawingml/2006/main"/>
           <a:p xmlns:a="http://schemas.openxmlformats.org/drawingml/2006/main">
             <a:pPr algn="r">
+              <a:buNone/>
               <a:defRPr sz="825" b="0">
                 <a:solidFill>
                   <a:srgbClr val="8293A4"/>
@@ -15678,6 +15847,7 @@
           <a:lstStyle xmlns:a="http://schemas.openxmlformats.org/drawingml/2006/main"/>
           <a:p xmlns:a="http://schemas.openxmlformats.org/drawingml/2006/main">
             <a:pPr algn="l">
+              <a:buNone/>
               <a:defRPr sz="2850" b="1">
                 <a:solidFill>
                   <a:srgbClr val="FFFFFF"/>
@@ -15703,7 +15873,7 @@
       </p:sp>
       <p:graphicFrame>
         <p:nvGraphicFramePr>
-          <p:cNvPr id="8" name=""/>
+          <p:cNvPr id="10" name=""/>
           <p:cNvGraphicFramePr/>
           <p:nvPr/>
         </p:nvGraphicFramePr>
@@ -16136,6 +16306,7 @@
           <a:lstStyle xmlns:a="http://schemas.openxmlformats.org/drawingml/2006/main"/>
           <a:p xmlns:a="http://schemas.openxmlformats.org/drawingml/2006/main">
             <a:pPr algn="l">
+              <a:buNone/>
               <a:defRPr sz="975" b="1">
                 <a:solidFill>
                   <a:srgbClr val="D76532"/>
@@ -16154,7 +16325,7 @@
                 <a:ea typeface="Arial"/>
                 <a:cs typeface="Arial"/>
               </a:rPr>
-              <a:t>PORTFOLIO DECISIONS</a:t>
+              <a:t>04  CONTENT AS A BUSINESS ASSET</a:t>
             </a:r>
           </a:p>
         </p:txBody>
@@ -16193,6 +16364,7 @@
           <a:lstStyle xmlns:a="http://schemas.openxmlformats.org/drawingml/2006/main"/>
           <a:p xmlns:a="http://schemas.openxmlformats.org/drawingml/2006/main">
             <a:pPr algn="r">
+              <a:buNone/>
               <a:defRPr sz="825" b="0">
                 <a:solidFill>
                   <a:srgbClr val="8A8179"/>
@@ -16250,6 +16422,7 @@
           <a:lstStyle xmlns:a="http://schemas.openxmlformats.org/drawingml/2006/main"/>
           <a:p xmlns:a="http://schemas.openxmlformats.org/drawingml/2006/main">
             <a:pPr algn="l">
+              <a:buNone/>
               <a:defRPr sz="2850" b="1">
                 <a:solidFill>
                   <a:srgbClr val="172737"/>
@@ -16307,6 +16480,7 @@
           <a:lstStyle xmlns:a="http://schemas.openxmlformats.org/drawingml/2006/main"/>
           <a:p xmlns:a="http://schemas.openxmlformats.org/drawingml/2006/main">
             <a:pPr algn="l">
+              <a:buNone/>
               <a:defRPr sz="2100" b="1">
                 <a:solidFill>
                   <a:srgbClr val="D76532"/>
@@ -16364,6 +16538,7 @@
           <a:lstStyle xmlns:a="http://schemas.openxmlformats.org/drawingml/2006/main"/>
           <a:p xmlns:a="http://schemas.openxmlformats.org/drawingml/2006/main">
             <a:pPr algn="l">
+              <a:buNone/>
               <a:defRPr sz="1275" b="1">
                 <a:solidFill>
                   <a:srgbClr val="172737"/>
@@ -16421,6 +16596,7 @@
           <a:lstStyle xmlns:a="http://schemas.openxmlformats.org/drawingml/2006/main"/>
           <a:p xmlns:a="http://schemas.openxmlformats.org/drawingml/2006/main">
             <a:pPr algn="l">
+              <a:buNone/>
               <a:defRPr sz="1425" b="0">
                 <a:solidFill>
                   <a:srgbClr val="5F6B76"/>
@@ -16478,6 +16654,7 @@
           <a:lstStyle xmlns:a="http://schemas.openxmlformats.org/drawingml/2006/main"/>
           <a:p xmlns:a="http://schemas.openxmlformats.org/drawingml/2006/main">
             <a:pPr algn="l">
+              <a:buNone/>
               <a:defRPr sz="2100" b="1">
                 <a:solidFill>
                   <a:srgbClr val="65B8A5"/>
@@ -16535,6 +16712,7 @@
           <a:lstStyle xmlns:a="http://schemas.openxmlformats.org/drawingml/2006/main"/>
           <a:p xmlns:a="http://schemas.openxmlformats.org/drawingml/2006/main">
             <a:pPr algn="l">
+              <a:buNone/>
               <a:defRPr sz="1275" b="1">
                 <a:solidFill>
                   <a:srgbClr val="172737"/>
@@ -16592,6 +16770,7 @@
           <a:lstStyle xmlns:a="http://schemas.openxmlformats.org/drawingml/2006/main"/>
           <a:p xmlns:a="http://schemas.openxmlformats.org/drawingml/2006/main">
             <a:pPr algn="l">
+              <a:buNone/>
               <a:defRPr sz="1425" b="0">
                 <a:solidFill>
                   <a:srgbClr val="5F6B76"/>
@@ -16649,6 +16828,7 @@
           <a:lstStyle xmlns:a="http://schemas.openxmlformats.org/drawingml/2006/main"/>
           <a:p xmlns:a="http://schemas.openxmlformats.org/drawingml/2006/main">
             <a:pPr algn="l">
+              <a:buNone/>
               <a:defRPr sz="2100" b="1">
                 <a:solidFill>
                   <a:srgbClr val="E2A93B"/>
@@ -16706,6 +16886,7 @@
           <a:lstStyle xmlns:a="http://schemas.openxmlformats.org/drawingml/2006/main"/>
           <a:p xmlns:a="http://schemas.openxmlformats.org/drawingml/2006/main">
             <a:pPr algn="l">
+              <a:buNone/>
               <a:defRPr sz="1275" b="1">
                 <a:solidFill>
                   <a:srgbClr val="172737"/>
@@ -16763,6 +16944,7 @@
           <a:lstStyle xmlns:a="http://schemas.openxmlformats.org/drawingml/2006/main"/>
           <a:p xmlns:a="http://schemas.openxmlformats.org/drawingml/2006/main">
             <a:pPr algn="l">
+              <a:buNone/>
               <a:defRPr sz="1425" b="0">
                 <a:solidFill>
                   <a:srgbClr val="5F6B76"/>
@@ -16820,6 +17002,7 @@
           <a:lstStyle xmlns:a="http://schemas.openxmlformats.org/drawingml/2006/main"/>
           <a:p xmlns:a="http://schemas.openxmlformats.org/drawingml/2006/main">
             <a:pPr algn="l">
+              <a:buNone/>
               <a:defRPr sz="2100" b="1">
                 <a:solidFill>
                   <a:srgbClr val="7189A5"/>
@@ -16877,6 +17060,7 @@
           <a:lstStyle xmlns:a="http://schemas.openxmlformats.org/drawingml/2006/main"/>
           <a:p xmlns:a="http://schemas.openxmlformats.org/drawingml/2006/main">
             <a:pPr algn="l">
+              <a:buNone/>
               <a:defRPr sz="1275" b="1">
                 <a:solidFill>
                   <a:srgbClr val="172737"/>
@@ -16934,6 +17118,7 @@
           <a:lstStyle xmlns:a="http://schemas.openxmlformats.org/drawingml/2006/main"/>
           <a:p xmlns:a="http://schemas.openxmlformats.org/drawingml/2006/main">
             <a:pPr algn="l">
+              <a:buNone/>
               <a:defRPr sz="1425" b="0">
                 <a:solidFill>
                   <a:srgbClr val="5F6B76"/>
@@ -16991,6 +17176,7 @@
           <a:lstStyle xmlns:a="http://schemas.openxmlformats.org/drawingml/2006/main"/>
           <a:p xmlns:a="http://schemas.openxmlformats.org/drawingml/2006/main">
             <a:pPr algn="l">
+              <a:buNone/>
               <a:defRPr sz="1500" b="1">
                 <a:solidFill>
                   <a:srgbClr val="172737"/>
@@ -17077,6 +17263,7 @@
           <a:lstStyle xmlns:a="http://schemas.openxmlformats.org/drawingml/2006/main"/>
           <a:p xmlns:a="http://schemas.openxmlformats.org/drawingml/2006/main">
             <a:pPr algn="l">
+              <a:buNone/>
               <a:defRPr sz="975" b="1">
                 <a:solidFill>
                   <a:srgbClr val="D76532"/>
@@ -17095,7 +17282,7 @@
                 <a:ea typeface="Arial"/>
                 <a:cs typeface="Arial"/>
               </a:rPr>
-              <a:t>WHAT WE LEARNED</a:t>
+              <a:t>05  LESSONS AND NEXT STEPS</a:t>
             </a:r>
           </a:p>
         </p:txBody>
@@ -17134,6 +17321,7 @@
           <a:lstStyle xmlns:a="http://schemas.openxmlformats.org/drawingml/2006/main"/>
           <a:p xmlns:a="http://schemas.openxmlformats.org/drawingml/2006/main">
             <a:pPr algn="r">
+              <a:buNone/>
               <a:defRPr sz="825" b="0">
                 <a:solidFill>
                   <a:srgbClr val="8293A4"/>
@@ -17191,6 +17379,7 @@
           <a:lstStyle xmlns:a="http://schemas.openxmlformats.org/drawingml/2006/main"/>
           <a:p xmlns:a="http://schemas.openxmlformats.org/drawingml/2006/main">
             <a:pPr algn="l">
+              <a:buNone/>
               <a:defRPr sz="2850" b="1">
                 <a:solidFill>
                   <a:srgbClr val="FFFFFF"/>
@@ -17248,6 +17437,7 @@
           <a:lstStyle xmlns:a="http://schemas.openxmlformats.org/drawingml/2006/main"/>
           <a:p xmlns:a="http://schemas.openxmlformats.org/drawingml/2006/main">
             <a:pPr algn="l">
+              <a:buNone/>
               <a:defRPr sz="1650" b="1">
                 <a:solidFill>
                   <a:srgbClr val="FFFFFF"/>
@@ -17335,6 +17525,7 @@
           <a:lstStyle xmlns:a="http://schemas.openxmlformats.org/drawingml/2006/main"/>
           <a:p xmlns:a="http://schemas.openxmlformats.org/drawingml/2006/main">
             <a:pPr algn="l">
+              <a:buNone/>
               <a:defRPr sz="1425" b="0">
                 <a:solidFill>
                   <a:srgbClr val="C1CCD5"/>
@@ -17392,6 +17583,7 @@
           <a:lstStyle xmlns:a="http://schemas.openxmlformats.org/drawingml/2006/main"/>
           <a:p xmlns:a="http://schemas.openxmlformats.org/drawingml/2006/main">
             <a:pPr algn="l">
+              <a:buNone/>
               <a:defRPr sz="1650" b="1">
                 <a:solidFill>
                   <a:srgbClr val="FFFFFF"/>
@@ -17479,6 +17671,7 @@
           <a:lstStyle xmlns:a="http://schemas.openxmlformats.org/drawingml/2006/main"/>
           <a:p xmlns:a="http://schemas.openxmlformats.org/drawingml/2006/main">
             <a:pPr algn="l">
+              <a:buNone/>
               <a:defRPr sz="1425" b="0">
                 <a:solidFill>
                   <a:srgbClr val="C1CCD5"/>
@@ -17536,6 +17729,7 @@
           <a:lstStyle xmlns:a="http://schemas.openxmlformats.org/drawingml/2006/main"/>
           <a:p xmlns:a="http://schemas.openxmlformats.org/drawingml/2006/main">
             <a:pPr algn="l">
+              <a:buNone/>
               <a:defRPr sz="1650" b="1">
                 <a:solidFill>
                   <a:srgbClr val="FFFFFF"/>
@@ -17623,6 +17817,7 @@
           <a:lstStyle xmlns:a="http://schemas.openxmlformats.org/drawingml/2006/main"/>
           <a:p xmlns:a="http://schemas.openxmlformats.org/drawingml/2006/main">
             <a:pPr algn="l">
+              <a:buNone/>
               <a:defRPr sz="1425" b="0">
                 <a:solidFill>
                   <a:srgbClr val="C1CCD5"/>
@@ -17680,6 +17875,7 @@
           <a:lstStyle xmlns:a="http://schemas.openxmlformats.org/drawingml/2006/main"/>
           <a:p xmlns:a="http://schemas.openxmlformats.org/drawingml/2006/main">
             <a:pPr algn="l">
+              <a:buNone/>
               <a:defRPr sz="1650" b="1">
                 <a:solidFill>
                   <a:srgbClr val="FFFFFF"/>
@@ -17767,6 +17963,7 @@
           <a:lstStyle xmlns:a="http://schemas.openxmlformats.org/drawingml/2006/main"/>
           <a:p xmlns:a="http://schemas.openxmlformats.org/drawingml/2006/main">
             <a:pPr algn="l">
+              <a:buNone/>
               <a:defRPr sz="1425" b="0">
                 <a:solidFill>
                   <a:srgbClr val="C1CCD5"/>
@@ -17853,6 +18050,7 @@
           <a:lstStyle xmlns:a="http://schemas.openxmlformats.org/drawingml/2006/main"/>
           <a:p xmlns:a="http://schemas.openxmlformats.org/drawingml/2006/main">
             <a:pPr algn="l">
+              <a:buNone/>
               <a:defRPr sz="975" b="1">
                 <a:solidFill>
                   <a:srgbClr val="D76532"/>
@@ -17871,7 +18069,7 @@
                 <a:ea typeface="Arial"/>
                 <a:cs typeface="Arial"/>
               </a:rPr>
-              <a:t>NEXT STEPS</a:t>
+              <a:t>05  LESSONS AND NEXT STEPS</a:t>
             </a:r>
           </a:p>
         </p:txBody>
@@ -17910,6 +18108,7 @@
           <a:lstStyle xmlns:a="http://schemas.openxmlformats.org/drawingml/2006/main"/>
           <a:p xmlns:a="http://schemas.openxmlformats.org/drawingml/2006/main">
             <a:pPr algn="r">
+              <a:buNone/>
               <a:defRPr sz="825" b="0">
                 <a:solidFill>
                   <a:srgbClr val="8A8179"/>
@@ -17967,6 +18166,7 @@
           <a:lstStyle xmlns:a="http://schemas.openxmlformats.org/drawingml/2006/main"/>
           <a:p xmlns:a="http://schemas.openxmlformats.org/drawingml/2006/main">
             <a:pPr algn="l">
+              <a:buNone/>
               <a:defRPr sz="2850" b="1">
                 <a:solidFill>
                   <a:srgbClr val="172737"/>
@@ -18024,6 +18224,7 @@
           <a:lstStyle xmlns:a="http://schemas.openxmlformats.org/drawingml/2006/main"/>
           <a:p xmlns:a="http://schemas.openxmlformats.org/drawingml/2006/main">
             <a:pPr algn="l">
+              <a:buNone/>
               <a:defRPr sz="1350" b="1">
                 <a:solidFill>
                   <a:srgbClr val="D76532"/>
@@ -18115,6 +18316,7 @@
           <a:lstStyle xmlns:a="http://schemas.openxmlformats.org/drawingml/2006/main"/>
           <a:p xmlns:a="http://schemas.openxmlformats.org/drawingml/2006/main">
             <a:pPr algn="l">
+              <a:buNone/>
               <a:defRPr sz="1575" b="1">
                 <a:solidFill>
                   <a:srgbClr val="172737"/>
@@ -18172,6 +18374,7 @@
           <a:lstStyle xmlns:a="http://schemas.openxmlformats.org/drawingml/2006/main"/>
           <a:p xmlns:a="http://schemas.openxmlformats.org/drawingml/2006/main">
             <a:pPr algn="l">
+              <a:buNone/>
               <a:defRPr sz="1350" b="1">
                 <a:solidFill>
                   <a:srgbClr val="D76532"/>
@@ -18263,6 +18466,7 @@
           <a:lstStyle xmlns:a="http://schemas.openxmlformats.org/drawingml/2006/main"/>
           <a:p xmlns:a="http://schemas.openxmlformats.org/drawingml/2006/main">
             <a:pPr algn="l">
+              <a:buNone/>
               <a:defRPr sz="1575" b="1">
                 <a:solidFill>
                   <a:srgbClr val="172737"/>
@@ -18320,6 +18524,7 @@
           <a:lstStyle xmlns:a="http://schemas.openxmlformats.org/drawingml/2006/main"/>
           <a:p xmlns:a="http://schemas.openxmlformats.org/drawingml/2006/main">
             <a:pPr algn="l">
+              <a:buNone/>
               <a:defRPr sz="1350" b="1">
                 <a:solidFill>
                   <a:srgbClr val="D76532"/>
@@ -18411,6 +18616,7 @@
           <a:lstStyle xmlns:a="http://schemas.openxmlformats.org/drawingml/2006/main"/>
           <a:p xmlns:a="http://schemas.openxmlformats.org/drawingml/2006/main">
             <a:pPr algn="l">
+              <a:buNone/>
               <a:defRPr sz="1575" b="1">
                 <a:solidFill>
                   <a:srgbClr val="172737"/>
@@ -18468,6 +18674,7 @@
           <a:lstStyle xmlns:a="http://schemas.openxmlformats.org/drawingml/2006/main"/>
           <a:p xmlns:a="http://schemas.openxmlformats.org/drawingml/2006/main">
             <a:pPr algn="ctr">
+              <a:buNone/>
               <a:defRPr sz="1650" b="1">
                 <a:solidFill>
                   <a:srgbClr val="172737"/>
@@ -18554,6 +18761,7 @@
           <a:lstStyle xmlns:a="http://schemas.openxmlformats.org/drawingml/2006/main"/>
           <a:p xmlns:a="http://schemas.openxmlformats.org/drawingml/2006/main">
             <a:pPr algn="l">
+              <a:buNone/>
               <a:defRPr sz="975" b="1">
                 <a:solidFill>
                   <a:srgbClr val="D76532"/>
@@ -18572,7 +18780,7 @@
                 <a:ea typeface="Arial"/>
                 <a:cs typeface="Arial"/>
               </a:rPr>
-              <a:t>CONTENT AS A BUSINESS ASSET</a:t>
+              <a:t>05  LESSONS AND NEXT STEPS</a:t>
             </a:r>
           </a:p>
         </p:txBody>
@@ -18611,6 +18819,7 @@
           <a:lstStyle xmlns:a="http://schemas.openxmlformats.org/drawingml/2006/main"/>
           <a:p xmlns:a="http://schemas.openxmlformats.org/drawingml/2006/main">
             <a:pPr algn="r">
+              <a:buNone/>
               <a:defRPr sz="825" b="0">
                 <a:solidFill>
                   <a:srgbClr val="8293A4"/>
@@ -18668,6 +18877,7 @@
           <a:lstStyle xmlns:a="http://schemas.openxmlformats.org/drawingml/2006/main"/>
           <a:p xmlns:a="http://schemas.openxmlformats.org/drawingml/2006/main">
             <a:pPr algn="l">
+              <a:buNone/>
               <a:defRPr sz="2850" b="1">
                 <a:solidFill>
                   <a:srgbClr val="FFFFFF"/>
@@ -18725,6 +18935,7 @@
           <a:lstStyle xmlns:a="http://schemas.openxmlformats.org/drawingml/2006/main"/>
           <a:p xmlns:a="http://schemas.openxmlformats.org/drawingml/2006/main">
             <a:pPr algn="l">
+              <a:buNone/>
               <a:defRPr sz="1875" b="0">
                 <a:solidFill>
                   <a:srgbClr val="C4CFD7"/>
@@ -18812,6 +19023,7 @@
           <a:lstStyle xmlns:a="http://schemas.openxmlformats.org/drawingml/2006/main"/>
           <a:p xmlns:a="http://schemas.openxmlformats.org/drawingml/2006/main">
             <a:pPr algn="l">
+              <a:buNone/>
               <a:defRPr sz="2100" b="1">
                 <a:solidFill>
                   <a:srgbClr val="FFFFFF"/>
@@ -18869,6 +19081,7 @@
           <a:lstStyle xmlns:a="http://schemas.openxmlformats.org/drawingml/2006/main"/>
           <a:p xmlns:a="http://schemas.openxmlformats.org/drawingml/2006/main">
             <a:pPr algn="l">
+              <a:buNone/>
               <a:defRPr sz="1500" b="1">
                 <a:solidFill>
                   <a:srgbClr val="D76532"/>
@@ -18955,6 +19168,7 @@
           <a:lstStyle xmlns:a="http://schemas.openxmlformats.org/drawingml/2006/main"/>
           <a:p xmlns:a="http://schemas.openxmlformats.org/drawingml/2006/main">
             <a:pPr algn="l">
+              <a:buNone/>
               <a:defRPr sz="975" b="1">
                 <a:solidFill>
                   <a:srgbClr val="D76532"/>
@@ -18973,7 +19187,7 @@
                 <a:ea typeface="Arial"/>
                 <a:cs typeface="Arial"/>
               </a:rPr>
-              <a:t>CONTENT AS A PRODUCT</a:t>
+              <a:t>01  CONTEXT AND PRODUCT</a:t>
             </a:r>
           </a:p>
         </p:txBody>
@@ -19012,6 +19226,7 @@
           <a:lstStyle xmlns:a="http://schemas.openxmlformats.org/drawingml/2006/main"/>
           <a:p xmlns:a="http://schemas.openxmlformats.org/drawingml/2006/main">
             <a:pPr algn="r">
+              <a:buNone/>
               <a:defRPr sz="825" b="0">
                 <a:solidFill>
                   <a:srgbClr val="8293A4"/>
@@ -19069,6 +19284,7 @@
           <a:lstStyle xmlns:a="http://schemas.openxmlformats.org/drawingml/2006/main"/>
           <a:p xmlns:a="http://schemas.openxmlformats.org/drawingml/2006/main">
             <a:pPr algn="l">
+              <a:buNone/>
               <a:defRPr sz="2850" b="1">
                 <a:solidFill>
                   <a:srgbClr val="FFFFFF"/>
@@ -19126,6 +19342,7 @@
           <a:lstStyle xmlns:a="http://schemas.openxmlformats.org/drawingml/2006/main"/>
           <a:p xmlns:a="http://schemas.openxmlformats.org/drawingml/2006/main">
             <a:pPr algn="l">
+              <a:buNone/>
               <a:defRPr sz="1125" b="1">
                 <a:solidFill>
                   <a:srgbClr val="D76532"/>
@@ -19183,6 +19400,7 @@
           <a:lstStyle xmlns:a="http://schemas.openxmlformats.org/drawingml/2006/main"/>
           <a:p xmlns:a="http://schemas.openxmlformats.org/drawingml/2006/main">
             <a:pPr algn="l">
+              <a:buNone/>
               <a:defRPr sz="1950" b="1">
                 <a:solidFill>
                   <a:srgbClr val="FFFFFF"/>
@@ -19240,6 +19458,7 @@
           <a:lstStyle xmlns:a="http://schemas.openxmlformats.org/drawingml/2006/main"/>
           <a:p xmlns:a="http://schemas.openxmlformats.org/drawingml/2006/main">
             <a:pPr algn="l">
+              <a:buNone/>
               <a:defRPr sz="1425" b="0">
                 <a:solidFill>
                   <a:srgbClr val="BCC9D3"/>
@@ -19327,6 +19546,7 @@
           <a:lstStyle xmlns:a="http://schemas.openxmlformats.org/drawingml/2006/main"/>
           <a:p xmlns:a="http://schemas.openxmlformats.org/drawingml/2006/main">
             <a:pPr algn="l">
+              <a:buNone/>
               <a:defRPr sz="1125" b="1">
                 <a:solidFill>
                   <a:srgbClr val="D76532"/>
@@ -19384,6 +19604,7 @@
           <a:lstStyle xmlns:a="http://schemas.openxmlformats.org/drawingml/2006/main"/>
           <a:p xmlns:a="http://schemas.openxmlformats.org/drawingml/2006/main">
             <a:pPr algn="l">
+              <a:buNone/>
               <a:defRPr sz="1950" b="1">
                 <a:solidFill>
                   <a:srgbClr val="FFFFFF"/>
@@ -19441,6 +19662,7 @@
           <a:lstStyle xmlns:a="http://schemas.openxmlformats.org/drawingml/2006/main"/>
           <a:p xmlns:a="http://schemas.openxmlformats.org/drawingml/2006/main">
             <a:pPr algn="l">
+              <a:buNone/>
               <a:defRPr sz="1425" b="0">
                 <a:solidFill>
                   <a:srgbClr val="BCC9D3"/>
@@ -19528,6 +19750,7 @@
           <a:lstStyle xmlns:a="http://schemas.openxmlformats.org/drawingml/2006/main"/>
           <a:p xmlns:a="http://schemas.openxmlformats.org/drawingml/2006/main">
             <a:pPr algn="l">
+              <a:buNone/>
               <a:defRPr sz="1125" b="1">
                 <a:solidFill>
                   <a:srgbClr val="D76532"/>
@@ -19585,6 +19808,7 @@
           <a:lstStyle xmlns:a="http://schemas.openxmlformats.org/drawingml/2006/main"/>
           <a:p xmlns:a="http://schemas.openxmlformats.org/drawingml/2006/main">
             <a:pPr algn="l">
+              <a:buNone/>
               <a:defRPr sz="1950" b="1">
                 <a:solidFill>
                   <a:srgbClr val="FFFFFF"/>
@@ -19642,6 +19866,7 @@
           <a:lstStyle xmlns:a="http://schemas.openxmlformats.org/drawingml/2006/main"/>
           <a:p xmlns:a="http://schemas.openxmlformats.org/drawingml/2006/main">
             <a:pPr algn="l">
+              <a:buNone/>
               <a:defRPr sz="1425" b="0">
                 <a:solidFill>
                   <a:srgbClr val="BCC9D3"/>
@@ -19729,6 +19954,7 @@
           <a:lstStyle xmlns:a="http://schemas.openxmlformats.org/drawingml/2006/main"/>
           <a:p xmlns:a="http://schemas.openxmlformats.org/drawingml/2006/main">
             <a:pPr algn="l">
+              <a:buNone/>
               <a:defRPr sz="1125" b="1">
                 <a:solidFill>
                   <a:srgbClr val="D76532"/>
@@ -19786,6 +20012,7 @@
           <a:lstStyle xmlns:a="http://schemas.openxmlformats.org/drawingml/2006/main"/>
           <a:p xmlns:a="http://schemas.openxmlformats.org/drawingml/2006/main">
             <a:pPr algn="l">
+              <a:buNone/>
               <a:defRPr sz="1950" b="1">
                 <a:solidFill>
                   <a:srgbClr val="FFFFFF"/>
@@ -19843,6 +20070,7 @@
           <a:lstStyle xmlns:a="http://schemas.openxmlformats.org/drawingml/2006/main"/>
           <a:p xmlns:a="http://schemas.openxmlformats.org/drawingml/2006/main">
             <a:pPr algn="l">
+              <a:buNone/>
               <a:defRPr sz="1425" b="0">
                 <a:solidFill>
                   <a:srgbClr val="BCC9D3"/>
@@ -19900,6 +20128,7 @@
           <a:lstStyle xmlns:a="http://schemas.openxmlformats.org/drawingml/2006/main"/>
           <a:p xmlns:a="http://schemas.openxmlformats.org/drawingml/2006/main">
             <a:pPr algn="l">
+              <a:buNone/>
               <a:defRPr sz="1650" b="1">
                 <a:solidFill>
                   <a:srgbClr val="FFFFFF"/>
@@ -19986,6 +20215,7 @@
           <a:lstStyle xmlns:a="http://schemas.openxmlformats.org/drawingml/2006/main"/>
           <a:p xmlns:a="http://schemas.openxmlformats.org/drawingml/2006/main">
             <a:pPr algn="l">
+              <a:buNone/>
               <a:defRPr sz="975" b="1">
                 <a:solidFill>
                   <a:srgbClr val="D76532"/>
@@ -20004,7 +20234,7 @@
                 <a:ea typeface="Arial"/>
                 <a:cs typeface="Arial"/>
               </a:rPr>
-              <a:t>WHY THIS MATTERS</a:t>
+              <a:t>01  CONTEXT AND PRODUCT</a:t>
             </a:r>
           </a:p>
         </p:txBody>
@@ -20043,6 +20273,7 @@
           <a:lstStyle xmlns:a="http://schemas.openxmlformats.org/drawingml/2006/main"/>
           <a:p xmlns:a="http://schemas.openxmlformats.org/drawingml/2006/main">
             <a:pPr algn="r">
+              <a:buNone/>
               <a:defRPr sz="825" b="0">
                 <a:solidFill>
                   <a:srgbClr val="8A8179"/>
@@ -20100,6 +20331,7 @@
           <a:lstStyle xmlns:a="http://schemas.openxmlformats.org/drawingml/2006/main"/>
           <a:p xmlns:a="http://schemas.openxmlformats.org/drawingml/2006/main">
             <a:pPr algn="l">
+              <a:buNone/>
               <a:defRPr sz="2850" b="1">
                 <a:solidFill>
                   <a:srgbClr val="172737"/>
@@ -20157,6 +20389,7 @@
           <a:lstStyle xmlns:a="http://schemas.openxmlformats.org/drawingml/2006/main"/>
           <a:p xmlns:a="http://schemas.openxmlformats.org/drawingml/2006/main">
             <a:pPr algn="l">
+              <a:buNone/>
               <a:defRPr sz="1575" b="1">
                 <a:solidFill>
                   <a:srgbClr val="D76532"/>
@@ -20214,6 +20447,7 @@
           <a:lstStyle xmlns:a="http://schemas.openxmlformats.org/drawingml/2006/main"/>
           <a:p xmlns:a="http://schemas.openxmlformats.org/drawingml/2006/main">
             <a:pPr algn="l">
+              <a:buNone/>
               <a:defRPr sz="1800" b="1">
                 <a:solidFill>
                   <a:srgbClr val="172737"/>
@@ -20303,6 +20537,7 @@
           <a:lstStyle xmlns:a="http://schemas.openxmlformats.org/drawingml/2006/main"/>
           <a:p xmlns:a="http://schemas.openxmlformats.org/drawingml/2006/main">
             <a:pPr algn="l">
+              <a:buNone/>
               <a:defRPr sz="1500" b="0">
                 <a:solidFill>
                   <a:srgbClr val="5F6B76"/>
@@ -20392,6 +20627,7 @@
           <a:lstStyle xmlns:a="http://schemas.openxmlformats.org/drawingml/2006/main"/>
           <a:p xmlns:a="http://schemas.openxmlformats.org/drawingml/2006/main">
             <a:pPr algn="l">
+              <a:buNone/>
               <a:defRPr sz="1500" b="0">
                 <a:solidFill>
                   <a:srgbClr val="5F6B76"/>
@@ -20481,6 +20717,7 @@
           <a:lstStyle xmlns:a="http://schemas.openxmlformats.org/drawingml/2006/main"/>
           <a:p xmlns:a="http://schemas.openxmlformats.org/drawingml/2006/main">
             <a:pPr algn="l">
+              <a:buNone/>
               <a:defRPr sz="1500" b="0">
                 <a:solidFill>
                   <a:srgbClr val="5F6B76"/>
@@ -20570,6 +20807,7 @@
           <a:lstStyle xmlns:a="http://schemas.openxmlformats.org/drawingml/2006/main"/>
           <a:p xmlns:a="http://schemas.openxmlformats.org/drawingml/2006/main">
             <a:pPr algn="l">
+              <a:buNone/>
               <a:defRPr sz="1500" b="0">
                 <a:solidFill>
                   <a:srgbClr val="5F6B76"/>
@@ -20659,6 +20897,7 @@
           <a:lstStyle xmlns:a="http://schemas.openxmlformats.org/drawingml/2006/main"/>
           <a:p xmlns:a="http://schemas.openxmlformats.org/drawingml/2006/main">
             <a:pPr algn="l">
+              <a:buNone/>
               <a:defRPr sz="1875" b="1">
                 <a:solidFill>
                   <a:srgbClr val="FFFFFF"/>
@@ -20716,6 +20955,7 @@
           <a:lstStyle xmlns:a="http://schemas.openxmlformats.org/drawingml/2006/main"/>
           <a:p xmlns:a="http://schemas.openxmlformats.org/drawingml/2006/main">
             <a:pPr algn="l">
+              <a:buNone/>
               <a:defRPr sz="1650" b="0">
                 <a:solidFill>
                   <a:srgbClr val="C6D0D8"/>
@@ -20832,6 +21072,7 @@
           <a:lstStyle xmlns:a="http://schemas.openxmlformats.org/drawingml/2006/main"/>
           <a:p xmlns:a="http://schemas.openxmlformats.org/drawingml/2006/main">
             <a:pPr algn="l">
+              <a:buNone/>
               <a:defRPr sz="975" b="1">
                 <a:solidFill>
                   <a:srgbClr val="D76532"/>
@@ -20850,7 +21091,7 @@
                 <a:ea typeface="Arial"/>
                 <a:cs typeface="Arial"/>
               </a:rPr>
-              <a:t>THE PROBLEM</a:t>
+              <a:t>01  CONTEXT AND PRODUCT</a:t>
             </a:r>
           </a:p>
         </p:txBody>
@@ -20889,6 +21130,7 @@
           <a:lstStyle xmlns:a="http://schemas.openxmlformats.org/drawingml/2006/main"/>
           <a:p xmlns:a="http://schemas.openxmlformats.org/drawingml/2006/main">
             <a:pPr algn="r">
+              <a:buNone/>
               <a:defRPr sz="825" b="0">
                 <a:solidFill>
                   <a:srgbClr val="8293A4"/>
@@ -20946,6 +21188,7 @@
           <a:lstStyle xmlns:a="http://schemas.openxmlformats.org/drawingml/2006/main"/>
           <a:p xmlns:a="http://schemas.openxmlformats.org/drawingml/2006/main">
             <a:pPr algn="l">
+              <a:buNone/>
               <a:defRPr sz="2850" b="1">
                 <a:solidFill>
                   <a:srgbClr val="FFFFFF"/>
@@ -21035,6 +21278,7 @@
           <a:lstStyle xmlns:a="http://schemas.openxmlformats.org/drawingml/2006/main"/>
           <a:p xmlns:a="http://schemas.openxmlformats.org/drawingml/2006/main">
             <a:pPr algn="ctr">
+              <a:buNone/>
               <a:defRPr sz="1500" b="1">
                 <a:solidFill>
                   <a:srgbClr val="0B1B2A"/>
@@ -21092,6 +21336,7 @@
           <a:lstStyle xmlns:a="http://schemas.openxmlformats.org/drawingml/2006/main"/>
           <a:p xmlns:a="http://schemas.openxmlformats.org/drawingml/2006/main">
             <a:pPr algn="ctr">
+              <a:buNone/>
               <a:defRPr sz="1200" b="0">
                 <a:solidFill>
                   <a:srgbClr val="BFCAD3"/>
@@ -21181,6 +21426,7 @@
           <a:lstStyle xmlns:a="http://schemas.openxmlformats.org/drawingml/2006/main"/>
           <a:p xmlns:a="http://schemas.openxmlformats.org/drawingml/2006/main">
             <a:pPr algn="ctr">
+              <a:buNone/>
               <a:defRPr sz="1500" b="1">
                 <a:solidFill>
                   <a:srgbClr val="172737"/>
@@ -21238,6 +21484,7 @@
           <a:lstStyle xmlns:a="http://schemas.openxmlformats.org/drawingml/2006/main"/>
           <a:p xmlns:a="http://schemas.openxmlformats.org/drawingml/2006/main">
             <a:pPr algn="ctr">
+              <a:buNone/>
               <a:defRPr sz="1200" b="0">
                 <a:solidFill>
                   <a:srgbClr val="BFCAD3"/>
@@ -21327,6 +21574,7 @@
           <a:lstStyle xmlns:a="http://schemas.openxmlformats.org/drawingml/2006/main"/>
           <a:p xmlns:a="http://schemas.openxmlformats.org/drawingml/2006/main">
             <a:pPr algn="ctr">
+              <a:buNone/>
               <a:defRPr sz="1500" b="1">
                 <a:solidFill>
                   <a:srgbClr val="0B1B2A"/>
@@ -21384,6 +21632,7 @@
           <a:lstStyle xmlns:a="http://schemas.openxmlformats.org/drawingml/2006/main"/>
           <a:p xmlns:a="http://schemas.openxmlformats.org/drawingml/2006/main">
             <a:pPr algn="ctr">
+              <a:buNone/>
               <a:defRPr sz="1200" b="0">
                 <a:solidFill>
                   <a:srgbClr val="BFCAD3"/>
@@ -21473,6 +21722,7 @@
           <a:lstStyle xmlns:a="http://schemas.openxmlformats.org/drawingml/2006/main"/>
           <a:p xmlns:a="http://schemas.openxmlformats.org/drawingml/2006/main">
             <a:pPr algn="ctr">
+              <a:buNone/>
               <a:defRPr sz="1500" b="1">
                 <a:solidFill>
                   <a:srgbClr val="0B1B2A"/>
@@ -21530,6 +21780,7 @@
           <a:lstStyle xmlns:a="http://schemas.openxmlformats.org/drawingml/2006/main"/>
           <a:p xmlns:a="http://schemas.openxmlformats.org/drawingml/2006/main">
             <a:pPr algn="ctr">
+              <a:buNone/>
               <a:defRPr sz="1200" b="0">
                 <a:solidFill>
                   <a:srgbClr val="BFCAD3"/>
@@ -21587,6 +21838,7 @@
           <a:lstStyle xmlns:a="http://schemas.openxmlformats.org/drawingml/2006/main"/>
           <a:p xmlns:a="http://schemas.openxmlformats.org/drawingml/2006/main">
             <a:pPr algn="ctr">
+              <a:buNone/>
               <a:defRPr sz="1875" b="1">
                 <a:solidFill>
                   <a:srgbClr val="FFFFFF"/>
@@ -21673,6 +21925,7 @@
           <a:lstStyle xmlns:a="http://schemas.openxmlformats.org/drawingml/2006/main"/>
           <a:p xmlns:a="http://schemas.openxmlformats.org/drawingml/2006/main">
             <a:pPr algn="l">
+              <a:buNone/>
               <a:defRPr sz="975" b="1">
                 <a:solidFill>
                   <a:srgbClr val="D76532"/>
@@ -21691,7 +21944,7 @@
                 <a:ea typeface="Arial"/>
                 <a:cs typeface="Arial"/>
               </a:rPr>
-              <a:t>WORKING TOGETHER</a:t>
+              <a:t>01  CONTEXT AND PRODUCT</a:t>
             </a:r>
           </a:p>
         </p:txBody>
@@ -21730,6 +21983,7 @@
           <a:lstStyle xmlns:a="http://schemas.openxmlformats.org/drawingml/2006/main"/>
           <a:p xmlns:a="http://schemas.openxmlformats.org/drawingml/2006/main">
             <a:pPr algn="r">
+              <a:buNone/>
               <a:defRPr sz="825" b="0">
                 <a:solidFill>
                   <a:srgbClr val="8A8179"/>
@@ -21787,6 +22041,7 @@
           <a:lstStyle xmlns:a="http://schemas.openxmlformats.org/drawingml/2006/main"/>
           <a:p xmlns:a="http://schemas.openxmlformats.org/drawingml/2006/main">
             <a:pPr algn="l">
+              <a:buNone/>
               <a:defRPr sz="2850" b="1">
                 <a:solidFill>
                   <a:srgbClr val="172737"/>
@@ -21844,6 +22099,7 @@
           <a:lstStyle xmlns:a="http://schemas.openxmlformats.org/drawingml/2006/main"/>
           <a:p xmlns:a="http://schemas.openxmlformats.org/drawingml/2006/main">
             <a:pPr algn="l">
+              <a:buNone/>
               <a:defRPr sz="975" b="1">
                 <a:solidFill>
                   <a:srgbClr val="D76532"/>
@@ -21901,6 +22157,7 @@
           <a:lstStyle xmlns:a="http://schemas.openxmlformats.org/drawingml/2006/main"/>
           <a:p xmlns:a="http://schemas.openxmlformats.org/drawingml/2006/main">
             <a:pPr algn="l">
+              <a:buNone/>
               <a:defRPr sz="1800" b="1">
                 <a:solidFill>
                   <a:srgbClr val="172737"/>
@@ -21988,6 +22245,7 @@
           <a:lstStyle xmlns:a="http://schemas.openxmlformats.org/drawingml/2006/main"/>
           <a:p xmlns:a="http://schemas.openxmlformats.org/drawingml/2006/main">
             <a:pPr algn="l">
+              <a:buNone/>
               <a:defRPr sz="1350" b="0">
                 <a:solidFill>
                   <a:srgbClr val="5F6B76"/>
@@ -22045,6 +22303,7 @@
           <a:lstStyle xmlns:a="http://schemas.openxmlformats.org/drawingml/2006/main"/>
           <a:p xmlns:a="http://schemas.openxmlformats.org/drawingml/2006/main">
             <a:pPr algn="l">
+              <a:buNone/>
               <a:defRPr sz="975" b="1">
                 <a:solidFill>
                   <a:srgbClr val="D76532"/>
@@ -22102,6 +22361,7 @@
           <a:lstStyle xmlns:a="http://schemas.openxmlformats.org/drawingml/2006/main"/>
           <a:p xmlns:a="http://schemas.openxmlformats.org/drawingml/2006/main">
             <a:pPr algn="l">
+              <a:buNone/>
               <a:defRPr sz="1800" b="1">
                 <a:solidFill>
                   <a:srgbClr val="172737"/>
@@ -22189,6 +22449,7 @@
           <a:lstStyle xmlns:a="http://schemas.openxmlformats.org/drawingml/2006/main"/>
           <a:p xmlns:a="http://schemas.openxmlformats.org/drawingml/2006/main">
             <a:pPr algn="l">
+              <a:buNone/>
               <a:defRPr sz="1350" b="0">
                 <a:solidFill>
                   <a:srgbClr val="5F6B76"/>
@@ -22246,6 +22507,7 @@
           <a:lstStyle xmlns:a="http://schemas.openxmlformats.org/drawingml/2006/main"/>
           <a:p xmlns:a="http://schemas.openxmlformats.org/drawingml/2006/main">
             <a:pPr algn="l">
+              <a:buNone/>
               <a:defRPr sz="975" b="1">
                 <a:solidFill>
                   <a:srgbClr val="D76532"/>
@@ -22303,6 +22565,7 @@
           <a:lstStyle xmlns:a="http://schemas.openxmlformats.org/drawingml/2006/main"/>
           <a:p xmlns:a="http://schemas.openxmlformats.org/drawingml/2006/main">
             <a:pPr algn="l">
+              <a:buNone/>
               <a:defRPr sz="1800" b="1">
                 <a:solidFill>
                   <a:srgbClr val="172737"/>
@@ -22390,6 +22653,7 @@
           <a:lstStyle xmlns:a="http://schemas.openxmlformats.org/drawingml/2006/main"/>
           <a:p xmlns:a="http://schemas.openxmlformats.org/drawingml/2006/main">
             <a:pPr algn="l">
+              <a:buNone/>
               <a:defRPr sz="1350" b="0">
                 <a:solidFill>
                   <a:srgbClr val="5F6B76"/>
@@ -22447,6 +22711,7 @@
           <a:lstStyle xmlns:a="http://schemas.openxmlformats.org/drawingml/2006/main"/>
           <a:p xmlns:a="http://schemas.openxmlformats.org/drawingml/2006/main">
             <a:pPr algn="l">
+              <a:buNone/>
               <a:defRPr sz="975" b="1">
                 <a:solidFill>
                   <a:srgbClr val="D76532"/>
@@ -22504,6 +22769,7 @@
           <a:lstStyle xmlns:a="http://schemas.openxmlformats.org/drawingml/2006/main"/>
           <a:p xmlns:a="http://schemas.openxmlformats.org/drawingml/2006/main">
             <a:pPr algn="l">
+              <a:buNone/>
               <a:defRPr sz="1800" b="1">
                 <a:solidFill>
                   <a:srgbClr val="172737"/>
@@ -22591,6 +22857,7 @@
           <a:lstStyle xmlns:a="http://schemas.openxmlformats.org/drawingml/2006/main"/>
           <a:p xmlns:a="http://schemas.openxmlformats.org/drawingml/2006/main">
             <a:pPr algn="l">
+              <a:buNone/>
               <a:defRPr sz="1350" b="0">
                 <a:solidFill>
                   <a:srgbClr val="5F6B76"/>
@@ -22648,6 +22915,7 @@
           <a:lstStyle xmlns:a="http://schemas.openxmlformats.org/drawingml/2006/main"/>
           <a:p xmlns:a="http://schemas.openxmlformats.org/drawingml/2006/main">
             <a:pPr algn="l">
+              <a:buNone/>
               <a:defRPr sz="1575" b="1">
                 <a:solidFill>
                   <a:srgbClr val="172737"/>
@@ -22734,6 +23002,7 @@
           <a:lstStyle xmlns:a="http://schemas.openxmlformats.org/drawingml/2006/main"/>
           <a:p xmlns:a="http://schemas.openxmlformats.org/drawingml/2006/main">
             <a:pPr algn="l">
+              <a:buNone/>
               <a:defRPr sz="975" b="1">
                 <a:solidFill>
                   <a:srgbClr val="D76532"/>
@@ -22752,7 +23021,7 @@
                 <a:ea typeface="Arial"/>
                 <a:cs typeface="Arial"/>
               </a:rPr>
-              <a:t>FRAMEWORK</a:t>
+              <a:t>02  THE WORKING METHOD</a:t>
             </a:r>
           </a:p>
         </p:txBody>
@@ -22791,6 +23060,7 @@
           <a:lstStyle xmlns:a="http://schemas.openxmlformats.org/drawingml/2006/main"/>
           <a:p xmlns:a="http://schemas.openxmlformats.org/drawingml/2006/main">
             <a:pPr algn="r">
+              <a:buNone/>
               <a:defRPr sz="825" b="0">
                 <a:solidFill>
                   <a:srgbClr val="8293A4"/>
@@ -22848,6 +23118,7 @@
           <a:lstStyle xmlns:a="http://schemas.openxmlformats.org/drawingml/2006/main"/>
           <a:p xmlns:a="http://schemas.openxmlformats.org/drawingml/2006/main">
             <a:pPr algn="l">
+              <a:buNone/>
               <a:defRPr sz="2850" b="1">
                 <a:solidFill>
                   <a:srgbClr val="FFFFFF"/>
@@ -22937,6 +23208,7 @@
           <a:lstStyle xmlns:a="http://schemas.openxmlformats.org/drawingml/2006/main"/>
           <a:p xmlns:a="http://schemas.openxmlformats.org/drawingml/2006/main">
             <a:pPr algn="ctr">
+              <a:buNone/>
               <a:defRPr sz="1125" b="1">
                 <a:solidFill>
                   <a:srgbClr val="FFFFFF"/>
@@ -22994,6 +23266,7 @@
           <a:lstStyle xmlns:a="http://schemas.openxmlformats.org/drawingml/2006/main"/>
           <a:p xmlns:a="http://schemas.openxmlformats.org/drawingml/2006/main">
             <a:pPr algn="l">
+              <a:buNone/>
               <a:defRPr sz="1500" b="1">
                 <a:solidFill>
                   <a:srgbClr val="FFFFFF"/>
@@ -23085,6 +23358,7 @@
           <a:lstStyle xmlns:a="http://schemas.openxmlformats.org/drawingml/2006/main"/>
           <a:p xmlns:a="http://schemas.openxmlformats.org/drawingml/2006/main">
             <a:pPr algn="ctr">
+              <a:buNone/>
               <a:defRPr sz="1125" b="1">
                 <a:solidFill>
                   <a:srgbClr val="FFFFFF"/>
@@ -23142,6 +23416,7 @@
           <a:lstStyle xmlns:a="http://schemas.openxmlformats.org/drawingml/2006/main"/>
           <a:p xmlns:a="http://schemas.openxmlformats.org/drawingml/2006/main">
             <a:pPr algn="l">
+              <a:buNone/>
               <a:defRPr sz="1500" b="0">
                 <a:solidFill>
                   <a:srgbClr val="FFFFFF"/>
@@ -23233,6 +23508,7 @@
           <a:lstStyle xmlns:a="http://schemas.openxmlformats.org/drawingml/2006/main"/>
           <a:p xmlns:a="http://schemas.openxmlformats.org/drawingml/2006/main">
             <a:pPr algn="ctr">
+              <a:buNone/>
               <a:defRPr sz="1125" b="1">
                 <a:solidFill>
                   <a:srgbClr val="FFFFFF"/>
@@ -23290,6 +23566,7 @@
           <a:lstStyle xmlns:a="http://schemas.openxmlformats.org/drawingml/2006/main"/>
           <a:p xmlns:a="http://schemas.openxmlformats.org/drawingml/2006/main">
             <a:pPr algn="l">
+              <a:buNone/>
               <a:defRPr sz="1500" b="0">
                 <a:solidFill>
                   <a:srgbClr val="FFFFFF"/>
@@ -23381,6 +23658,7 @@
           <a:lstStyle xmlns:a="http://schemas.openxmlformats.org/drawingml/2006/main"/>
           <a:p xmlns:a="http://schemas.openxmlformats.org/drawingml/2006/main">
             <a:pPr algn="ctr">
+              <a:buNone/>
               <a:defRPr sz="1125" b="1">
                 <a:solidFill>
                   <a:srgbClr val="FFFFFF"/>
@@ -23438,6 +23716,7 @@
           <a:lstStyle xmlns:a="http://schemas.openxmlformats.org/drawingml/2006/main"/>
           <a:p xmlns:a="http://schemas.openxmlformats.org/drawingml/2006/main">
             <a:pPr algn="l">
+              <a:buNone/>
               <a:defRPr sz="1500" b="0">
                 <a:solidFill>
                   <a:srgbClr val="FFFFFF"/>
@@ -23529,6 +23808,7 @@
           <a:lstStyle xmlns:a="http://schemas.openxmlformats.org/drawingml/2006/main"/>
           <a:p xmlns:a="http://schemas.openxmlformats.org/drawingml/2006/main">
             <a:pPr algn="ctr">
+              <a:buNone/>
               <a:defRPr sz="1125" b="1">
                 <a:solidFill>
                   <a:srgbClr val="FFFFFF"/>
@@ -23586,6 +23866,7 @@
           <a:lstStyle xmlns:a="http://schemas.openxmlformats.org/drawingml/2006/main"/>
           <a:p xmlns:a="http://schemas.openxmlformats.org/drawingml/2006/main">
             <a:pPr algn="l">
+              <a:buNone/>
               <a:defRPr sz="1500" b="0">
                 <a:solidFill>
                   <a:srgbClr val="FFFFFF"/>
@@ -23675,6 +23956,7 @@
           <a:lstStyle xmlns:a="http://schemas.openxmlformats.org/drawingml/2006/main"/>
           <a:p xmlns:a="http://schemas.openxmlformats.org/drawingml/2006/main">
             <a:pPr algn="ctr">
+              <a:buNone/>
               <a:defRPr sz="1125" b="1">
                 <a:solidFill>
                   <a:srgbClr val="FFFFFF"/>
@@ -23732,6 +24014,7 @@
           <a:lstStyle xmlns:a="http://schemas.openxmlformats.org/drawingml/2006/main"/>
           <a:p xmlns:a="http://schemas.openxmlformats.org/drawingml/2006/main">
             <a:pPr algn="l">
+              <a:buNone/>
               <a:defRPr sz="1500" b="1">
                 <a:solidFill>
                   <a:srgbClr val="FFFFFF"/>
@@ -23821,6 +24104,7 @@
           <a:lstStyle xmlns:a="http://schemas.openxmlformats.org/drawingml/2006/main"/>
           <a:p xmlns:a="http://schemas.openxmlformats.org/drawingml/2006/main">
             <a:pPr algn="ctr">
+              <a:buNone/>
               <a:defRPr sz="1125" b="1">
                 <a:solidFill>
                   <a:srgbClr val="FFFFFF"/>
@@ -23878,6 +24162,7 @@
           <a:lstStyle xmlns:a="http://schemas.openxmlformats.org/drawingml/2006/main"/>
           <a:p xmlns:a="http://schemas.openxmlformats.org/drawingml/2006/main">
             <a:pPr algn="l">
+              <a:buNone/>
               <a:defRPr sz="1500" b="1">
                 <a:solidFill>
                   <a:srgbClr val="FFFFFF"/>
@@ -23935,6 +24220,7 @@
           <a:lstStyle xmlns:a="http://schemas.openxmlformats.org/drawingml/2006/main"/>
           <a:p xmlns:a="http://schemas.openxmlformats.org/drawingml/2006/main">
             <a:pPr algn="l">
+              <a:buNone/>
               <a:defRPr sz="1875" b="1">
                 <a:solidFill>
                   <a:srgbClr val="FFFFFF"/>
@@ -24021,6 +24307,7 @@
           <a:lstStyle xmlns:a="http://schemas.openxmlformats.org/drawingml/2006/main"/>
           <a:p xmlns:a="http://schemas.openxmlformats.org/drawingml/2006/main">
             <a:pPr algn="l">
+              <a:buNone/>
               <a:defRPr sz="975" b="1">
                 <a:solidFill>
                   <a:srgbClr val="D76532"/>
@@ -24039,7 +24326,7 @@
                 <a:ea typeface="Arial"/>
                 <a:cs typeface="Arial"/>
               </a:rPr>
-              <a:t>STEP 1</a:t>
+              <a:t>02  THE WORKING METHOD</a:t>
             </a:r>
           </a:p>
         </p:txBody>
@@ -24078,6 +24365,7 @@
           <a:lstStyle xmlns:a="http://schemas.openxmlformats.org/drawingml/2006/main"/>
           <a:p xmlns:a="http://schemas.openxmlformats.org/drawingml/2006/main">
             <a:pPr algn="r">
+              <a:buNone/>
               <a:defRPr sz="825" b="0">
                 <a:solidFill>
                   <a:srgbClr val="8A8179"/>
@@ -24135,6 +24423,7 @@
           <a:lstStyle xmlns:a="http://schemas.openxmlformats.org/drawingml/2006/main"/>
           <a:p xmlns:a="http://schemas.openxmlformats.org/drawingml/2006/main">
             <a:pPr algn="l">
+              <a:buNone/>
               <a:defRPr sz="2850" b="1">
                 <a:solidFill>
                   <a:srgbClr val="172737"/>
@@ -24192,6 +24481,7 @@
           <a:lstStyle xmlns:a="http://schemas.openxmlformats.org/drawingml/2006/main"/>
           <a:p xmlns:a="http://schemas.openxmlformats.org/drawingml/2006/main">
             <a:pPr algn="l">
+              <a:buNone/>
               <a:defRPr sz="1575" b="1">
                 <a:solidFill>
                   <a:srgbClr val="D76532"/>
@@ -24249,6 +24539,7 @@
           <a:lstStyle xmlns:a="http://schemas.openxmlformats.org/drawingml/2006/main"/>
           <a:p xmlns:a="http://schemas.openxmlformats.org/drawingml/2006/main">
             <a:pPr algn="l">
+              <a:buNone/>
               <a:defRPr sz="1800" b="1">
                 <a:solidFill>
                   <a:srgbClr val="172737"/>
@@ -24368,6 +24659,7 @@
           <a:lstStyle xmlns:a="http://schemas.openxmlformats.org/drawingml/2006/main"/>
           <a:p xmlns:a="http://schemas.openxmlformats.org/drawingml/2006/main">
             <a:pPr algn="l">
+              <a:buNone/>
               <a:defRPr sz="1425" b="0">
                 <a:solidFill>
                   <a:srgbClr val="5F6B76"/>
@@ -24457,6 +24749,7 @@
           <a:lstStyle xmlns:a="http://schemas.openxmlformats.org/drawingml/2006/main"/>
           <a:p xmlns:a="http://schemas.openxmlformats.org/drawingml/2006/main">
             <a:pPr algn="l">
+              <a:buNone/>
               <a:defRPr sz="1425" b="0">
                 <a:solidFill>
                   <a:srgbClr val="5F6B76"/>
@@ -24546,6 +24839,7 @@
           <a:lstStyle xmlns:a="http://schemas.openxmlformats.org/drawingml/2006/main"/>
           <a:p xmlns:a="http://schemas.openxmlformats.org/drawingml/2006/main">
             <a:pPr algn="l">
+              <a:buNone/>
               <a:defRPr sz="1425" b="0">
                 <a:solidFill>
                   <a:srgbClr val="5F6B76"/>
@@ -24635,6 +24929,7 @@
           <a:lstStyle xmlns:a="http://schemas.openxmlformats.org/drawingml/2006/main"/>
           <a:p xmlns:a="http://schemas.openxmlformats.org/drawingml/2006/main">
             <a:pPr algn="l">
+              <a:buNone/>
               <a:defRPr sz="1425" b="0">
                 <a:solidFill>
                   <a:srgbClr val="5F6B76"/>
@@ -24692,6 +24987,7 @@
           <a:lstStyle xmlns:a="http://schemas.openxmlformats.org/drawingml/2006/main"/>
           <a:p xmlns:a="http://schemas.openxmlformats.org/drawingml/2006/main">
             <a:pPr algn="l">
+              <a:buNone/>
               <a:defRPr sz="1800" b="1">
                 <a:solidFill>
                   <a:srgbClr val="172737"/>
@@ -24811,6 +25107,7 @@
           <a:lstStyle xmlns:a="http://schemas.openxmlformats.org/drawingml/2006/main"/>
           <a:p xmlns:a="http://schemas.openxmlformats.org/drawingml/2006/main">
             <a:pPr algn="l">
+              <a:buNone/>
               <a:defRPr sz="1425" b="0">
                 <a:solidFill>
                   <a:srgbClr val="5F6B76"/>
@@ -24900,6 +25197,7 @@
           <a:lstStyle xmlns:a="http://schemas.openxmlformats.org/drawingml/2006/main"/>
           <a:p xmlns:a="http://schemas.openxmlformats.org/drawingml/2006/main">
             <a:pPr algn="l">
+              <a:buNone/>
               <a:defRPr sz="1425" b="0">
                 <a:solidFill>
                   <a:srgbClr val="5F6B76"/>
@@ -24989,6 +25287,7 @@
           <a:lstStyle xmlns:a="http://schemas.openxmlformats.org/drawingml/2006/main"/>
           <a:p xmlns:a="http://schemas.openxmlformats.org/drawingml/2006/main">
             <a:pPr algn="l">
+              <a:buNone/>
               <a:defRPr sz="1425" b="0">
                 <a:solidFill>
                   <a:srgbClr val="5F6B76"/>
@@ -25078,6 +25377,7 @@
           <a:lstStyle xmlns:a="http://schemas.openxmlformats.org/drawingml/2006/main"/>
           <a:p xmlns:a="http://schemas.openxmlformats.org/drawingml/2006/main">
             <a:pPr algn="l">
+              <a:buNone/>
               <a:defRPr sz="1425" b="0">
                 <a:solidFill>
                   <a:srgbClr val="5F6B76"/>
@@ -25164,6 +25464,7 @@
           <a:lstStyle xmlns:a="http://schemas.openxmlformats.org/drawingml/2006/main"/>
           <a:p xmlns:a="http://schemas.openxmlformats.org/drawingml/2006/main">
             <a:pPr algn="l">
+              <a:buNone/>
               <a:defRPr sz="975" b="1">
                 <a:solidFill>
                   <a:srgbClr val="D76532"/>
@@ -25182,7 +25483,7 @@
                 <a:ea typeface="Arial"/>
                 <a:cs typeface="Arial"/>
               </a:rPr>
-              <a:t>STEP 2</a:t>
+              <a:t>02  THE WORKING METHOD</a:t>
             </a:r>
           </a:p>
         </p:txBody>
@@ -25221,6 +25522,7 @@
           <a:lstStyle xmlns:a="http://schemas.openxmlformats.org/drawingml/2006/main"/>
           <a:p xmlns:a="http://schemas.openxmlformats.org/drawingml/2006/main">
             <a:pPr algn="r">
+              <a:buNone/>
               <a:defRPr sz="825" b="0">
                 <a:solidFill>
                   <a:srgbClr val="8A8179"/>
@@ -25278,6 +25580,7 @@
           <a:lstStyle xmlns:a="http://schemas.openxmlformats.org/drawingml/2006/main"/>
           <a:p xmlns:a="http://schemas.openxmlformats.org/drawingml/2006/main">
             <a:pPr algn="l">
+              <a:buNone/>
               <a:defRPr sz="2850" b="1">
                 <a:solidFill>
                   <a:srgbClr val="172737"/>
@@ -25335,6 +25638,7 @@
           <a:lstStyle xmlns:a="http://schemas.openxmlformats.org/drawingml/2006/main"/>
           <a:p xmlns:a="http://schemas.openxmlformats.org/drawingml/2006/main">
             <a:pPr algn="l">
+              <a:buNone/>
               <a:defRPr sz="1575" b="1">
                 <a:solidFill>
                   <a:srgbClr val="D76532"/>
@@ -25392,6 +25696,7 @@
           <a:lstStyle xmlns:a="http://schemas.openxmlformats.org/drawingml/2006/main"/>
           <a:p xmlns:a="http://schemas.openxmlformats.org/drawingml/2006/main">
             <a:pPr algn="l">
+              <a:buNone/>
               <a:defRPr sz="1800" b="1">
                 <a:solidFill>
                   <a:srgbClr val="172737"/>
@@ -25511,6 +25816,7 @@
           <a:lstStyle xmlns:a="http://schemas.openxmlformats.org/drawingml/2006/main"/>
           <a:p xmlns:a="http://schemas.openxmlformats.org/drawingml/2006/main">
             <a:pPr algn="l">
+              <a:buNone/>
               <a:defRPr sz="1425" b="0">
                 <a:solidFill>
                   <a:srgbClr val="5F6B76"/>
@@ -25600,6 +25906,7 @@
           <a:lstStyle xmlns:a="http://schemas.openxmlformats.org/drawingml/2006/main"/>
           <a:p xmlns:a="http://schemas.openxmlformats.org/drawingml/2006/main">
             <a:pPr algn="l">
+              <a:buNone/>
               <a:defRPr sz="1425" b="0">
                 <a:solidFill>
                   <a:srgbClr val="5F6B76"/>
@@ -25689,6 +25996,7 @@
           <a:lstStyle xmlns:a="http://schemas.openxmlformats.org/drawingml/2006/main"/>
           <a:p xmlns:a="http://schemas.openxmlformats.org/drawingml/2006/main">
             <a:pPr algn="l">
+              <a:buNone/>
               <a:defRPr sz="1425" b="0">
                 <a:solidFill>
                   <a:srgbClr val="5F6B76"/>
@@ -25778,6 +26086,7 @@
           <a:lstStyle xmlns:a="http://schemas.openxmlformats.org/drawingml/2006/main"/>
           <a:p xmlns:a="http://schemas.openxmlformats.org/drawingml/2006/main">
             <a:pPr algn="l">
+              <a:buNone/>
               <a:defRPr sz="1425" b="0">
                 <a:solidFill>
                   <a:srgbClr val="5F6B76"/>
@@ -25835,6 +26144,7 @@
           <a:lstStyle xmlns:a="http://schemas.openxmlformats.org/drawingml/2006/main"/>
           <a:p xmlns:a="http://schemas.openxmlformats.org/drawingml/2006/main">
             <a:pPr algn="l">
+              <a:buNone/>
               <a:defRPr sz="1800" b="1">
                 <a:solidFill>
                   <a:srgbClr val="172737"/>
@@ -25954,6 +26264,7 @@
           <a:lstStyle xmlns:a="http://schemas.openxmlformats.org/drawingml/2006/main"/>
           <a:p xmlns:a="http://schemas.openxmlformats.org/drawingml/2006/main">
             <a:pPr algn="l">
+              <a:buNone/>
               <a:defRPr sz="1425" b="0">
                 <a:solidFill>
                   <a:srgbClr val="5F6B76"/>
@@ -26043,6 +26354,7 @@
           <a:lstStyle xmlns:a="http://schemas.openxmlformats.org/drawingml/2006/main"/>
           <a:p xmlns:a="http://schemas.openxmlformats.org/drawingml/2006/main">
             <a:pPr algn="l">
+              <a:buNone/>
               <a:defRPr sz="1425" b="0">
                 <a:solidFill>
                   <a:srgbClr val="5F6B76"/>
@@ -26132,6 +26444,7 @@
           <a:lstStyle xmlns:a="http://schemas.openxmlformats.org/drawingml/2006/main"/>
           <a:p xmlns:a="http://schemas.openxmlformats.org/drawingml/2006/main">
             <a:pPr algn="l">
+              <a:buNone/>
               <a:defRPr sz="1425" b="0">
                 <a:solidFill>
                   <a:srgbClr val="5F6B76"/>
@@ -26221,6 +26534,7 @@
           <a:lstStyle xmlns:a="http://schemas.openxmlformats.org/drawingml/2006/main"/>
           <a:p xmlns:a="http://schemas.openxmlformats.org/drawingml/2006/main">
             <a:pPr algn="l">
+              <a:buNone/>
               <a:defRPr sz="1425" b="0">
                 <a:solidFill>
                   <a:srgbClr val="5F6B76"/>

</xml_diff>

<commit_message>
Put original LavaCon slide first
</commit_message>
<xml_diff>
--- a/downloads/Unified_Content_Strategy_in_Practice.pptx
+++ b/downloads/Unified_Content_Strategy_in_Practice.pptx
@@ -2,35 +2,35 @@
 <file path=ppt/presentation.xml><?xml version="1.0" encoding="utf-8"?>
 <p:presentation xmlns:p="http://schemas.openxmlformats.org/presentationml/2006/main">
   <p:sldMasterIdLst>
-    <p:sldMasterId xmlns:r="http://schemas.openxmlformats.org/officeDocument/2006/relationships" id="2147483648" r:id="R697bf1a394944162"/>
+    <p:sldMasterId xmlns:r="http://schemas.openxmlformats.org/officeDocument/2006/relationships" id="2147483648" r:id="R718ba38c483c407c"/>
   </p:sldMasterIdLst>
   <p:notesMasterIdLst>
-    <p:notesMasterId xmlns:r="http://schemas.openxmlformats.org/officeDocument/2006/relationships" r:id="R5d6d397cadd7474c"/>
+    <p:notesMasterId xmlns:r="http://schemas.openxmlformats.org/officeDocument/2006/relationships" r:id="R50eb9f3a7af24838"/>
   </p:notesMasterIdLst>
   <p:sldIdLst>
-    <p:sldId xmlns:r="http://schemas.openxmlformats.org/officeDocument/2006/relationships" id="256" r:id="R9ea0d82aa8564df7"/>
-    <p:sldId xmlns:r="http://schemas.openxmlformats.org/officeDocument/2006/relationships" id="257" r:id="Ra963f69a573349f5"/>
-    <p:sldId xmlns:r="http://schemas.openxmlformats.org/officeDocument/2006/relationships" id="258" r:id="R1eb5bcaaf5f84c0f"/>
-    <p:sldId xmlns:r="http://schemas.openxmlformats.org/officeDocument/2006/relationships" id="259" r:id="R38c8fed9f8434755"/>
-    <p:sldId xmlns:r="http://schemas.openxmlformats.org/officeDocument/2006/relationships" id="260" r:id="Rb897529b06d345dd"/>
-    <p:sldId xmlns:r="http://schemas.openxmlformats.org/officeDocument/2006/relationships" id="261" r:id="R7f7d7e1f7d5447cc"/>
-    <p:sldId xmlns:r="http://schemas.openxmlformats.org/officeDocument/2006/relationships" id="262" r:id="Rf6b67699790d4c03"/>
-    <p:sldId xmlns:r="http://schemas.openxmlformats.org/officeDocument/2006/relationships" id="263" r:id="R52863c9efaf34146"/>
-    <p:sldId xmlns:r="http://schemas.openxmlformats.org/officeDocument/2006/relationships" id="264" r:id="R29355de7df474d45"/>
-    <p:sldId xmlns:r="http://schemas.openxmlformats.org/officeDocument/2006/relationships" id="265" r:id="R251959636ca44bfa"/>
-    <p:sldId xmlns:r="http://schemas.openxmlformats.org/officeDocument/2006/relationships" id="266" r:id="Ra00f5c11419d44d9"/>
-    <p:sldId xmlns:r="http://schemas.openxmlformats.org/officeDocument/2006/relationships" id="267" r:id="Re551de0520724124"/>
-    <p:sldId xmlns:r="http://schemas.openxmlformats.org/officeDocument/2006/relationships" id="268" r:id="R7b9da8b410514e9d"/>
-    <p:sldId xmlns:r="http://schemas.openxmlformats.org/officeDocument/2006/relationships" id="269" r:id="R9416287f18b641b2"/>
-    <p:sldId xmlns:r="http://schemas.openxmlformats.org/officeDocument/2006/relationships" id="270" r:id="R7cdff15d98a6423b"/>
-    <p:sldId xmlns:r="http://schemas.openxmlformats.org/officeDocument/2006/relationships" id="271" r:id="R9f68c3a0ba814bbc"/>
-    <p:sldId xmlns:r="http://schemas.openxmlformats.org/officeDocument/2006/relationships" id="272" r:id="R2b435f0f13754df6"/>
-    <p:sldId xmlns:r="http://schemas.openxmlformats.org/officeDocument/2006/relationships" id="273" r:id="R231c948f16534fdc"/>
-    <p:sldId xmlns:r="http://schemas.openxmlformats.org/officeDocument/2006/relationships" id="274" r:id="Rc3f6a80d89dd4221"/>
-    <p:sldId xmlns:r="http://schemas.openxmlformats.org/officeDocument/2006/relationships" id="275" r:id="Rf43a1e49ca704cb0"/>
-    <p:sldId xmlns:r="http://schemas.openxmlformats.org/officeDocument/2006/relationships" id="276" r:id="Rbbf51ba7ea1f474a"/>
-    <p:sldId xmlns:r="http://schemas.openxmlformats.org/officeDocument/2006/relationships" id="277" r:id="Rfe755b6d3d524221"/>
-    <p:sldId xmlns:r="http://schemas.openxmlformats.org/officeDocument/2006/relationships" id="278" r:id="R85431a13117842c3"/>
+    <p:sldId xmlns:r="http://schemas.openxmlformats.org/officeDocument/2006/relationships" id="256" r:id="R31a3fdb5b25a463b"/>
+    <p:sldId xmlns:r="http://schemas.openxmlformats.org/officeDocument/2006/relationships" id="257" r:id="R9f144d20c8a94d8e"/>
+    <p:sldId xmlns:r="http://schemas.openxmlformats.org/officeDocument/2006/relationships" id="258" r:id="R92b4044aa6994145"/>
+    <p:sldId xmlns:r="http://schemas.openxmlformats.org/officeDocument/2006/relationships" id="259" r:id="R8fd394ed876e4ebe"/>
+    <p:sldId xmlns:r="http://schemas.openxmlformats.org/officeDocument/2006/relationships" id="260" r:id="Rb6a2ce1f1754471d"/>
+    <p:sldId xmlns:r="http://schemas.openxmlformats.org/officeDocument/2006/relationships" id="261" r:id="Rc2208c4bf3bf4486"/>
+    <p:sldId xmlns:r="http://schemas.openxmlformats.org/officeDocument/2006/relationships" id="262" r:id="Rc8d9e5f846594614"/>
+    <p:sldId xmlns:r="http://schemas.openxmlformats.org/officeDocument/2006/relationships" id="263" r:id="R4d82ea0342aa48fb"/>
+    <p:sldId xmlns:r="http://schemas.openxmlformats.org/officeDocument/2006/relationships" id="264" r:id="R6aa03a2fe84642e4"/>
+    <p:sldId xmlns:r="http://schemas.openxmlformats.org/officeDocument/2006/relationships" id="265" r:id="R88374ff2dce547c2"/>
+    <p:sldId xmlns:r="http://schemas.openxmlformats.org/officeDocument/2006/relationships" id="266" r:id="R25422258b88b410c"/>
+    <p:sldId xmlns:r="http://schemas.openxmlformats.org/officeDocument/2006/relationships" id="267" r:id="Rc9fa17bc858a4c76"/>
+    <p:sldId xmlns:r="http://schemas.openxmlformats.org/officeDocument/2006/relationships" id="268" r:id="R5f4f98a2862c45bf"/>
+    <p:sldId xmlns:r="http://schemas.openxmlformats.org/officeDocument/2006/relationships" id="269" r:id="R6032ba59e56644b7"/>
+    <p:sldId xmlns:r="http://schemas.openxmlformats.org/officeDocument/2006/relationships" id="270" r:id="R27daa6affac94e56"/>
+    <p:sldId xmlns:r="http://schemas.openxmlformats.org/officeDocument/2006/relationships" id="271" r:id="R0bccf89417134832"/>
+    <p:sldId xmlns:r="http://schemas.openxmlformats.org/officeDocument/2006/relationships" id="272" r:id="Rd0e18a792d264354"/>
+    <p:sldId xmlns:r="http://schemas.openxmlformats.org/officeDocument/2006/relationships" id="273" r:id="Rf531222761884ac9"/>
+    <p:sldId xmlns:r="http://schemas.openxmlformats.org/officeDocument/2006/relationships" id="274" r:id="R789a196de7fa409e"/>
+    <p:sldId xmlns:r="http://schemas.openxmlformats.org/officeDocument/2006/relationships" id="275" r:id="Rd27a3e02074943cc"/>
+    <p:sldId xmlns:r="http://schemas.openxmlformats.org/officeDocument/2006/relationships" id="276" r:id="R5912f95353ae4d8f"/>
+    <p:sldId xmlns:r="http://schemas.openxmlformats.org/officeDocument/2006/relationships" id="277" r:id="R8d618d0ead234788"/>
+    <p:sldId xmlns:r="http://schemas.openxmlformats.org/officeDocument/2006/relationships" id="278" r:id="Rda38c5cd48094cad"/>
   </p:sldIdLst>
   <p:sldSz cx="12191999" cy="6858000"/>
   <p:notesSz cx="6858000" cy="9144000"/>
@@ -4962,17 +4962,17 @@
   </p:cSld>
   <p:clrMap bg1="lt1" tx1="dk1" bg2="lt2" tx2="dk2" accent1="accent1" accent2="accent2" accent3="accent3" accent4="accent4" accent5="accent5" accent6="accent6" hlink="hlink" folHlink="folHlink"/>
   <p:sldLayoutIdLst>
-    <p:sldLayoutId xmlns:r="http://schemas.openxmlformats.org/officeDocument/2006/relationships" id="2147483649" r:id="R081d6a7b47e64e25"/>
-    <p:sldLayoutId xmlns:r="http://schemas.openxmlformats.org/officeDocument/2006/relationships" id="2147483650" r:id="R2541e63e31cf465c"/>
-    <p:sldLayoutId xmlns:r="http://schemas.openxmlformats.org/officeDocument/2006/relationships" id="2147483651" r:id="R5562f176b95544f1"/>
-    <p:sldLayoutId xmlns:r="http://schemas.openxmlformats.org/officeDocument/2006/relationships" id="2147483652" r:id="Rf0135c00668846cf"/>
-    <p:sldLayoutId xmlns:r="http://schemas.openxmlformats.org/officeDocument/2006/relationships" id="2147483653" r:id="Rc3362d6399ba4999"/>
-    <p:sldLayoutId xmlns:r="http://schemas.openxmlformats.org/officeDocument/2006/relationships" id="2147483654" r:id="Reaef5ae41e9748c6"/>
-    <p:sldLayoutId xmlns:r="http://schemas.openxmlformats.org/officeDocument/2006/relationships" id="2147483655" r:id="Rf873ba7e2a9b4538"/>
-    <p:sldLayoutId xmlns:r="http://schemas.openxmlformats.org/officeDocument/2006/relationships" id="2147483656" r:id="Ra6b3f18acce641b0"/>
-    <p:sldLayoutId xmlns:r="http://schemas.openxmlformats.org/officeDocument/2006/relationships" id="2147483657" r:id="R95d0d4241d2f4d57"/>
-    <p:sldLayoutId xmlns:r="http://schemas.openxmlformats.org/officeDocument/2006/relationships" id="2147483658" r:id="Ra792521f35a7442d"/>
-    <p:sldLayoutId xmlns:r="http://schemas.openxmlformats.org/officeDocument/2006/relationships" id="2147483659" r:id="R00f4b8798b294d0d"/>
+    <p:sldLayoutId xmlns:r="http://schemas.openxmlformats.org/officeDocument/2006/relationships" id="2147483649" r:id="R6dc69e47d5414ab8"/>
+    <p:sldLayoutId xmlns:r="http://schemas.openxmlformats.org/officeDocument/2006/relationships" id="2147483650" r:id="R6ea06ea83d934af2"/>
+    <p:sldLayoutId xmlns:r="http://schemas.openxmlformats.org/officeDocument/2006/relationships" id="2147483651" r:id="R74d70f0e6f524782"/>
+    <p:sldLayoutId xmlns:r="http://schemas.openxmlformats.org/officeDocument/2006/relationships" id="2147483652" r:id="R93bcb1ac12c54a2c"/>
+    <p:sldLayoutId xmlns:r="http://schemas.openxmlformats.org/officeDocument/2006/relationships" id="2147483653" r:id="Rfbac2fd0bee84a7d"/>
+    <p:sldLayoutId xmlns:r="http://schemas.openxmlformats.org/officeDocument/2006/relationships" id="2147483654" r:id="R1aef61f4b8b34433"/>
+    <p:sldLayoutId xmlns:r="http://schemas.openxmlformats.org/officeDocument/2006/relationships" id="2147483655" r:id="Rfb82fc383ad74f40"/>
+    <p:sldLayoutId xmlns:r="http://schemas.openxmlformats.org/officeDocument/2006/relationships" id="2147483656" r:id="Rad103b64b2884c11"/>
+    <p:sldLayoutId xmlns:r="http://schemas.openxmlformats.org/officeDocument/2006/relationships" id="2147483657" r:id="Re500d97aa8ed4e69"/>
+    <p:sldLayoutId xmlns:r="http://schemas.openxmlformats.org/officeDocument/2006/relationships" id="2147483658" r:id="Ra365b5be212640c0"/>
+    <p:sldLayoutId xmlns:r="http://schemas.openxmlformats.org/officeDocument/2006/relationships" id="2147483659" r:id="Rbc74dc1c901a451a"/>
   </p:sldLayoutIdLst>
   <p:txStyles>
     <p:titleStyle>
@@ -5513,371 +5513,32 @@
       <p:grpSpPr>
         <a:xfrm xmlns:a="http://schemas.openxmlformats.org/drawingml/2006/main"/>
       </p:grpSpPr>
-      <p:sp>
-        <p:nvSpPr>
-          <p:cNvPr id="2" name="Rectangle 1">
-            <a:extLst xmlns:a="http://schemas.openxmlformats.org/drawingml/2006/main">
-              <a:ext uri="{FF2B5EF4-FFF2-40B4-BE49-F238E27FC236}">
-                <a16:creationId xmlns:a16="http://schemas.microsoft.com/office/drawing/2014/main" id="{59E5E2CB-1967-454F-B989-19F0EA07ED92}"/>
-              </a:ext>
-            </a:extLst>
-          </p:cNvPr>
-          <p:cNvSpPr>
-            <a:spLocks xmlns:a="http://schemas.openxmlformats.org/drawingml/2006/main" noGrp="1"/>
-          </p:cNvSpPr>
-          <p:nvPr/>
-        </p:nvSpPr>
+      <p:pic>
+        <p:nvPicPr>
+          <p:cNvPr id="2" name=""/>
+          <p:cNvPicPr>
+            <a:picLocks xmlns:a="http://schemas.openxmlformats.org/drawingml/2006/main" noChangeAspect="1"/>
+          </p:cNvPicPr>
+          <p:nvPr/>
+        </p:nvPicPr>
+        <p:blipFill>
+          <a:blip xmlns:r="http://schemas.openxmlformats.org/officeDocument/2006/relationships" xmlns:a="http://schemas.openxmlformats.org/drawingml/2006/main" r:embed="R33d2f23803d448c5"/>
+          <a:stretch xmlns:a="http://schemas.openxmlformats.org/drawingml/2006/main"/>
+        </p:blipFill>
         <p:spPr>
           <a:xfrm xmlns:a="http://schemas.openxmlformats.org/drawingml/2006/main">
             <a:off x="0" y="0"/>
-            <a:ext cx="12191695" cy="6858000"/>
-          </a:xfrm>
-          <a:prstGeom xmlns:a="http://schemas.openxmlformats.org/drawingml/2006/main" prst="rect">
-            <a:avLst/>
-          </a:prstGeom>
-          <a:solidFill xmlns:a="http://schemas.openxmlformats.org/drawingml/2006/main">
-            <a:srgbClr val="0C1826"/>
-          </a:solidFill>
-          <a:ln xmlns:a="http://schemas.openxmlformats.org/drawingml/2006/main">
-            <a:solidFill>
-              <a:srgbClr val="0C1826"/>
-            </a:solidFill>
-          </a:ln>
-        </p:spPr>
-        <p:style>
-          <a:lnRef xmlns:a="http://schemas.openxmlformats.org/drawingml/2006/main" idx="1">
-            <a:schemeClr val="accent1"/>
-          </a:lnRef>
-          <a:fillRef xmlns:a="http://schemas.openxmlformats.org/drawingml/2006/main" idx="3">
-            <a:schemeClr val="accent1"/>
-          </a:fillRef>
-          <a:effectRef xmlns:a="http://schemas.openxmlformats.org/drawingml/2006/main" idx="2">
-            <a:schemeClr val="accent1"/>
-          </a:effectRef>
-          <a:fontRef xmlns:a="http://schemas.openxmlformats.org/drawingml/2006/main" idx="minor">
-            <a:schemeClr val="lt1"/>
-          </a:fontRef>
-        </p:style>
-        <p:txBody>
-          <a:bodyPr xmlns:a="http://schemas.openxmlformats.org/drawingml/2006/main" anchor="ctr"/>
-          <a:lstStyle xmlns:a="http://schemas.openxmlformats.org/drawingml/2006/main"/>
-          <a:p xmlns:a="http://schemas.openxmlformats.org/drawingml/2006/main">
-            <a:pPr algn="ctr">
-              <a:buNone/>
-            </a:pPr>
-          </a:p>
-        </p:txBody>
-      </p:sp>
-      <p:sp>
-        <p:nvSpPr>
-          <p:cNvPr id="3" name="Rectangle 2">
-            <a:extLst xmlns:a="http://schemas.openxmlformats.org/drawingml/2006/main">
-              <a:ext uri="{FF2B5EF4-FFF2-40B4-BE49-F238E27FC236}">
-                <a16:creationId xmlns:a16="http://schemas.microsoft.com/office/drawing/2014/main" id="{62F058FC-2C26-42A7-9D76-FF38D55919C2}"/>
-              </a:ext>
-            </a:extLst>
-          </p:cNvPr>
-          <p:cNvSpPr>
-            <a:spLocks xmlns:a="http://schemas.openxmlformats.org/drawingml/2006/main" noGrp="1"/>
-          </p:cNvSpPr>
-          <p:nvPr/>
-        </p:nvSpPr>
-        <p:spPr>
-          <a:xfrm xmlns:a="http://schemas.openxmlformats.org/drawingml/2006/main">
-            <a:off x="0" y="0"/>
-            <a:ext cx="164592" cy="6858000"/>
-          </a:xfrm>
-          <a:prstGeom xmlns:a="http://schemas.openxmlformats.org/drawingml/2006/main" prst="rect">
-            <a:avLst/>
-          </a:prstGeom>
-          <a:solidFill xmlns:a="http://schemas.openxmlformats.org/drawingml/2006/main">
-            <a:srgbClr val="CF6836"/>
-          </a:solidFill>
-          <a:ln xmlns:a="http://schemas.openxmlformats.org/drawingml/2006/main">
-            <a:solidFill>
-              <a:srgbClr val="CF6836"/>
-            </a:solidFill>
-          </a:ln>
-        </p:spPr>
-        <p:style>
-          <a:lnRef xmlns:a="http://schemas.openxmlformats.org/drawingml/2006/main" idx="1">
-            <a:schemeClr val="accent1"/>
-          </a:lnRef>
-          <a:fillRef xmlns:a="http://schemas.openxmlformats.org/drawingml/2006/main" idx="3">
-            <a:schemeClr val="accent1"/>
-          </a:fillRef>
-          <a:effectRef xmlns:a="http://schemas.openxmlformats.org/drawingml/2006/main" idx="2">
-            <a:schemeClr val="accent1"/>
-          </a:effectRef>
-          <a:fontRef xmlns:a="http://schemas.openxmlformats.org/drawingml/2006/main" idx="minor">
-            <a:schemeClr val="lt1"/>
-          </a:fontRef>
-        </p:style>
-        <p:txBody>
-          <a:bodyPr xmlns:a="http://schemas.openxmlformats.org/drawingml/2006/main" anchor="ctr"/>
-          <a:lstStyle xmlns:a="http://schemas.openxmlformats.org/drawingml/2006/main"/>
-          <a:p xmlns:a="http://schemas.openxmlformats.org/drawingml/2006/main">
-            <a:pPr algn="ctr">
-              <a:buNone/>
-            </a:pPr>
-          </a:p>
-        </p:txBody>
-      </p:sp>
-      <p:sp>
-        <p:nvSpPr>
-          <p:cNvPr id="4" name="TextBox 3">
-            <a:extLst xmlns:a="http://schemas.openxmlformats.org/drawingml/2006/main">
-              <a:ext uri="{FF2B5EF4-FFF2-40B4-BE49-F238E27FC236}">
-                <a16:creationId xmlns:a16="http://schemas.microsoft.com/office/drawing/2014/main" id="{3D58D985-12B6-4F5A-891A-D9ED565C7930}"/>
-              </a:ext>
-            </a:extLst>
-          </p:cNvPr>
-          <p:cNvSpPr>
-            <a:spLocks xmlns:a="http://schemas.openxmlformats.org/drawingml/2006/main" noGrp="1"/>
-          </p:cNvSpPr>
-          <p:nvPr/>
-        </p:nvSpPr>
-        <p:spPr>
-          <a:xfrm xmlns:a="http://schemas.openxmlformats.org/drawingml/2006/main">
-            <a:off x="685800" y="713232"/>
-            <a:ext cx="7132320" cy="320040"/>
-          </a:xfrm>
-          <a:prstGeom xmlns:a="http://schemas.openxmlformats.org/drawingml/2006/main" prst="rect">
-            <a:avLst/>
-          </a:prstGeom>
-          <a:noFill xmlns:a="http://schemas.openxmlformats.org/drawingml/2006/main"/>
-        </p:spPr>
-        <p:txBody>
-          <a:bodyPr xmlns:a="http://schemas.openxmlformats.org/drawingml/2006/main" wrap="square" lIns="0" tIns="0" rIns="0" bIns="0" anchor="t">
-            <a:spAutoFit/>
-          </a:bodyPr>
-          <a:lstStyle xmlns:a="http://schemas.openxmlformats.org/drawingml/2006/main"/>
-          <a:p xmlns:a="http://schemas.openxmlformats.org/drawingml/2006/main">
-            <a:pPr algn="l">
-              <a:buNone/>
-            </a:pPr>
-            <a:r>
-              <a:rPr sz="1300" b="1" i="0">
-                <a:solidFill>
-                  <a:srgbClr val="CF6836"/>
-                </a:solidFill>
-                <a:latin typeface="Aptos"/>
-                <a:ea typeface="Aptos"/>
-                <a:cs typeface="Aptos"/>
-              </a:rPr>
-              <a:t>CONTENT AS A BUSINESS ASSET</a:t>
-            </a:r>
-          </a:p>
-        </p:txBody>
-      </p:sp>
-      <p:sp>
-        <p:nvSpPr>
-          <p:cNvPr id="5" name="TextBox 4">
-            <a:extLst xmlns:a="http://schemas.openxmlformats.org/drawingml/2006/main">
-              <a:ext uri="{FF2B5EF4-FFF2-40B4-BE49-F238E27FC236}">
-                <a16:creationId xmlns:a16="http://schemas.microsoft.com/office/drawing/2014/main" id="{753616DE-1F0B-4BEA-A642-6A3870D0C114}"/>
-              </a:ext>
-            </a:extLst>
-          </p:cNvPr>
-          <p:cNvSpPr>
-            <a:spLocks xmlns:a="http://schemas.openxmlformats.org/drawingml/2006/main" noGrp="1"/>
-          </p:cNvSpPr>
-          <p:nvPr/>
-        </p:nvSpPr>
-        <p:spPr>
-          <a:xfrm xmlns:a="http://schemas.openxmlformats.org/drawingml/2006/main">
-            <a:off x="685800" y="1325880"/>
-            <a:ext cx="9875520" cy="1691640"/>
-          </a:xfrm>
-          <a:prstGeom xmlns:a="http://schemas.openxmlformats.org/drawingml/2006/main" prst="rect">
-            <a:avLst/>
-          </a:prstGeom>
-          <a:noFill xmlns:a="http://schemas.openxmlformats.org/drawingml/2006/main"/>
-        </p:spPr>
-        <p:txBody>
-          <a:bodyPr xmlns:a="http://schemas.openxmlformats.org/drawingml/2006/main" wrap="square" lIns="0" tIns="0" rIns="0" bIns="0" anchor="t">
-            <a:spAutoFit/>
-          </a:bodyPr>
-          <a:lstStyle xmlns:a="http://schemas.openxmlformats.org/drawingml/2006/main"/>
-          <a:p xmlns:a="http://schemas.openxmlformats.org/drawingml/2006/main">
-            <a:pPr algn="l">
-              <a:buNone/>
-            </a:pPr>
-            <a:r>
-              <a:rPr sz="3600" b="1" i="0">
-                <a:solidFill>
-                  <a:srgbClr val="FFFFFF"/>
-                </a:solidFill>
-                <a:latin typeface="Aptos"/>
-                <a:ea typeface="Aptos"/>
-                <a:cs typeface="Aptos"/>
-              </a:rPr>
-              <a:t>Unified content strategy</a:t>
-            </a:r>
-          </a:p>
-          <a:p xmlns:a="http://schemas.openxmlformats.org/drawingml/2006/main">
-            <a:pPr algn="l">
-              <a:buNone/>
-            </a:pPr>
-            <a:r>
-              <a:rPr sz="3600" b="1" i="0">
-                <a:solidFill>
-                  <a:srgbClr val="FFFFFF"/>
-                </a:solidFill>
-                <a:latin typeface="Aptos"/>
-                <a:ea typeface="Aptos"/>
-                <a:cs typeface="Aptos"/>
-              </a:rPr>
-              <a:t>in practice</a:t>
-            </a:r>
-          </a:p>
-        </p:txBody>
-      </p:sp>
-      <p:sp>
-        <p:nvSpPr>
-          <p:cNvPr id="6" name="TextBox 5">
-            <a:extLst xmlns:a="http://schemas.openxmlformats.org/drawingml/2006/main">
-              <a:ext uri="{FF2B5EF4-FFF2-40B4-BE49-F238E27FC236}">
-                <a16:creationId xmlns:a16="http://schemas.microsoft.com/office/drawing/2014/main" id="{E5717035-7781-405E-B586-73B91D20F8AB}"/>
-              </a:ext>
-            </a:extLst>
-          </p:cNvPr>
-          <p:cNvSpPr>
-            <a:spLocks xmlns:a="http://schemas.openxmlformats.org/drawingml/2006/main" noGrp="1"/>
-          </p:cNvSpPr>
-          <p:nvPr/>
-        </p:nvSpPr>
-        <p:spPr>
-          <a:xfrm xmlns:a="http://schemas.openxmlformats.org/drawingml/2006/main">
-            <a:off x="713232" y="3401568"/>
-            <a:ext cx="7772400" cy="457200"/>
-          </a:xfrm>
-          <a:prstGeom xmlns:a="http://schemas.openxmlformats.org/drawingml/2006/main" prst="rect">
-            <a:avLst/>
-          </a:prstGeom>
-          <a:noFill xmlns:a="http://schemas.openxmlformats.org/drawingml/2006/main"/>
-        </p:spPr>
-        <p:txBody>
-          <a:bodyPr xmlns:a="http://schemas.openxmlformats.org/drawingml/2006/main" wrap="square" lIns="0" tIns="0" rIns="0" bIns="0" anchor="t">
-            <a:spAutoFit/>
-          </a:bodyPr>
-          <a:lstStyle xmlns:a="http://schemas.openxmlformats.org/drawingml/2006/main"/>
-          <a:p xmlns:a="http://schemas.openxmlformats.org/drawingml/2006/main">
-            <a:pPr algn="l">
-              <a:buNone/>
-            </a:pPr>
-            <a:r>
-              <a:rPr sz="1900" b="0" i="0">
-                <a:solidFill>
-                  <a:srgbClr val="C0CDD9"/>
-                </a:solidFill>
-                <a:latin typeface="Aptos"/>
-                <a:ea typeface="Aptos"/>
-                <a:cs typeface="Aptos"/>
-              </a:rPr>
-              <a:t>A LavaCon case study based on a product launch</a:t>
-            </a:r>
-          </a:p>
-        </p:txBody>
-      </p:sp>
-      <p:sp>
-        <p:nvSpPr>
-          <p:cNvPr id="7" name="TextBox 6">
-            <a:extLst xmlns:a="http://schemas.openxmlformats.org/drawingml/2006/main">
-              <a:ext uri="{FF2B5EF4-FFF2-40B4-BE49-F238E27FC236}">
-                <a16:creationId xmlns:a16="http://schemas.microsoft.com/office/drawing/2014/main" id="{5CF09819-6A70-4FBB-86F1-823F47822C8C}"/>
-              </a:ext>
-            </a:extLst>
-          </p:cNvPr>
-          <p:cNvSpPr>
-            <a:spLocks xmlns:a="http://schemas.openxmlformats.org/drawingml/2006/main" noGrp="1"/>
-          </p:cNvSpPr>
-          <p:nvPr/>
-        </p:nvSpPr>
-        <p:spPr>
-          <a:xfrm xmlns:a="http://schemas.openxmlformats.org/drawingml/2006/main">
-            <a:off x="713232" y="5824728"/>
-            <a:ext cx="7315200" cy="320040"/>
-          </a:xfrm>
-          <a:prstGeom xmlns:a="http://schemas.openxmlformats.org/drawingml/2006/main" prst="rect">
-            <a:avLst/>
-          </a:prstGeom>
-          <a:noFill xmlns:a="http://schemas.openxmlformats.org/drawingml/2006/main"/>
-        </p:spPr>
-        <p:txBody>
-          <a:bodyPr xmlns:a="http://schemas.openxmlformats.org/drawingml/2006/main" wrap="square" lIns="0" tIns="0" rIns="0" bIns="0" anchor="t">
-            <a:spAutoFit/>
-          </a:bodyPr>
-          <a:lstStyle xmlns:a="http://schemas.openxmlformats.org/drawingml/2006/main"/>
-          <a:p xmlns:a="http://schemas.openxmlformats.org/drawingml/2006/main">
-            <a:pPr algn="l">
-              <a:buNone/>
-            </a:pPr>
-            <a:r>
-              <a:rPr sz="1600" b="1" i="0">
-                <a:solidFill>
-                  <a:srgbClr val="FFFFFF"/>
-                </a:solidFill>
-                <a:latin typeface="Aptos"/>
-                <a:ea typeface="Aptos"/>
-                <a:cs typeface="Aptos"/>
-              </a:rPr>
-              <a:t>Sharmila Das  ·  Rebecca Rhee</a:t>
-            </a:r>
-          </a:p>
-        </p:txBody>
-      </p:sp>
-      <p:sp>
-        <p:nvSpPr>
-          <p:cNvPr id="8" name="TextBox 7">
-            <a:extLst xmlns:a="http://schemas.openxmlformats.org/drawingml/2006/main">
-              <a:ext uri="{FF2B5EF4-FFF2-40B4-BE49-F238E27FC236}">
-                <a16:creationId xmlns:a16="http://schemas.microsoft.com/office/drawing/2014/main" id="{6072ABA9-75AA-42BD-9356-0E87672E6512}"/>
-              </a:ext>
-            </a:extLst>
-          </p:cNvPr>
-          <p:cNvSpPr>
-            <a:spLocks xmlns:a="http://schemas.openxmlformats.org/drawingml/2006/main" noGrp="1"/>
-          </p:cNvSpPr>
-          <p:nvPr/>
-        </p:nvSpPr>
-        <p:spPr>
-          <a:xfrm xmlns:a="http://schemas.openxmlformats.org/drawingml/2006/main">
-            <a:off x="713232" y="6208776"/>
-            <a:ext cx="9601200" cy="274320"/>
-          </a:xfrm>
-          <a:prstGeom xmlns:a="http://schemas.openxmlformats.org/drawingml/2006/main" prst="rect">
-            <a:avLst/>
-          </a:prstGeom>
-          <a:noFill xmlns:a="http://schemas.openxmlformats.org/drawingml/2006/main"/>
-        </p:spPr>
-        <p:txBody>
-          <a:bodyPr xmlns:a="http://schemas.openxmlformats.org/drawingml/2006/main" wrap="square" lIns="0" tIns="0" rIns="0" bIns="0" anchor="t">
-            <a:spAutoFit/>
-          </a:bodyPr>
-          <a:lstStyle xmlns:a="http://schemas.openxmlformats.org/drawingml/2006/main"/>
-          <a:p xmlns:a="http://schemas.openxmlformats.org/drawingml/2006/main">
-            <a:pPr algn="l">
-              <a:buNone/>
-            </a:pPr>
-            <a:r>
-              <a:rPr sz="1200" b="0" i="0">
-                <a:solidFill>
-                  <a:srgbClr val="687B8E"/>
-                </a:solidFill>
-                <a:latin typeface="Aptos"/>
-                <a:ea typeface="Aptos"/>
-                <a:cs typeface="Aptos"/>
-              </a:rPr>
-              <a:t>Content strategy, information architecture, and cross-team workflow</a:t>
-            </a:r>
-          </a:p>
-        </p:txBody>
-      </p:sp>
+            <a:ext cx="12192000" cy="6858000"/>
+          </a:xfrm>
+          <a:prstGeom xmlns:a="http://schemas.openxmlformats.org/drawingml/2006/main" prst="rect">
+            <a:avLst/>
+          </a:prstGeom>
+        </p:spPr>
+      </p:pic>
     </p:spTree>
     <p:extLst>
       <p:ext uri="{BB962C8B-B14F-4D97-AF65-F5344CB8AC3E}">
-        <p14:creationId xmlns:p14="http://schemas.microsoft.com/office/powerpoint/2010/main" val="1583064581"/>
+        <p14:creationId xmlns:p14="http://schemas.microsoft.com/office/powerpoint/2010/main" val="1462401011"/>
       </p:ext>
     </p:extLst>
   </p:cSld>
@@ -14183,7 +13844,7 @@
           <p:cNvPr id="2" name="Rectangle 1">
             <a:extLst xmlns:a="http://schemas.openxmlformats.org/drawingml/2006/main">
               <a:ext uri="{FF2B5EF4-FFF2-40B4-BE49-F238E27FC236}">
-                <a16:creationId xmlns:a16="http://schemas.microsoft.com/office/drawing/2014/main" id="{6431DF86-C327-4D56-B839-3993C43ACDB1}"/>
+                <a16:creationId xmlns:a16="http://schemas.microsoft.com/office/drawing/2014/main" id="{59E5E2CB-1967-454F-B989-19F0EA07ED92}"/>
               </a:ext>
             </a:extLst>
           </p:cNvPr>
@@ -14201,11 +13862,11 @@
             <a:avLst/>
           </a:prstGeom>
           <a:solidFill xmlns:a="http://schemas.openxmlformats.org/drawingml/2006/main">
-            <a:srgbClr val="F6F2EB"/>
+            <a:srgbClr val="0C1826"/>
           </a:solidFill>
           <a:ln xmlns:a="http://schemas.openxmlformats.org/drawingml/2006/main">
             <a:solidFill>
-              <a:srgbClr val="F6F2EB"/>
+              <a:srgbClr val="0C1826"/>
             </a:solidFill>
           </a:ln>
         </p:spPr>
@@ -14235,173 +13896,32 @@
       </p:sp>
       <p:sp>
         <p:nvSpPr>
-          <p:cNvPr id="3" name="TextBox 2">
-            <a:extLst xmlns:a="http://schemas.openxmlformats.org/drawingml/2006/main">
-              <a:ext uri="{FF2B5EF4-FFF2-40B4-BE49-F238E27FC236}">
-                <a16:creationId xmlns:a16="http://schemas.microsoft.com/office/drawing/2014/main" id="{65768798-9076-4042-B43C-16EC48AD2BB5}"/>
-              </a:ext>
-            </a:extLst>
-          </p:cNvPr>
-          <p:cNvSpPr>
-            <a:spLocks xmlns:a="http://schemas.openxmlformats.org/drawingml/2006/main" noGrp="1"/>
-          </p:cNvSpPr>
-          <p:nvPr/>
-        </p:nvSpPr>
-        <p:spPr>
-          <a:xfrm xmlns:a="http://schemas.openxmlformats.org/drawingml/2006/main">
-            <a:off x="594360" y="320040"/>
-            <a:ext cx="4114800" cy="274320"/>
-          </a:xfrm>
-          <a:prstGeom xmlns:a="http://schemas.openxmlformats.org/drawingml/2006/main" prst="rect">
-            <a:avLst/>
-          </a:prstGeom>
-          <a:noFill xmlns:a="http://schemas.openxmlformats.org/drawingml/2006/main"/>
-        </p:spPr>
-        <p:txBody>
-          <a:bodyPr xmlns:a="http://schemas.openxmlformats.org/drawingml/2006/main" wrap="square" lIns="0" tIns="0" rIns="0" bIns="0" anchor="t">
-            <a:spAutoFit/>
-          </a:bodyPr>
-          <a:lstStyle xmlns:a="http://schemas.openxmlformats.org/drawingml/2006/main"/>
-          <a:p xmlns:a="http://schemas.openxmlformats.org/drawingml/2006/main">
-            <a:pPr algn="l">
-              <a:buNone/>
-            </a:pPr>
-            <a:r>
-              <a:rPr sz="1100" b="1" i="0">
-                <a:solidFill>
-                  <a:srgbClr val="CF6836"/>
-                </a:solidFill>
-                <a:latin typeface="Aptos"/>
-                <a:ea typeface="Aptos"/>
-                <a:cs typeface="Aptos"/>
-              </a:rPr>
-              <a:t>WHY CONTENT IS AN ASSET</a:t>
-            </a:r>
-          </a:p>
-        </p:txBody>
-      </p:sp>
-      <p:sp>
-        <p:nvSpPr>
-          <p:cNvPr id="4" name="TextBox 3">
-            <a:extLst xmlns:a="http://schemas.openxmlformats.org/drawingml/2006/main">
-              <a:ext uri="{FF2B5EF4-FFF2-40B4-BE49-F238E27FC236}">
-                <a16:creationId xmlns:a16="http://schemas.microsoft.com/office/drawing/2014/main" id="{23E44F1B-499C-40B9-953B-F9A7D304BDBC}"/>
-              </a:ext>
-            </a:extLst>
-          </p:cNvPr>
-          <p:cNvSpPr>
-            <a:spLocks xmlns:a="http://schemas.openxmlformats.org/drawingml/2006/main" noGrp="1"/>
-          </p:cNvSpPr>
-          <p:nvPr/>
-        </p:nvSpPr>
-        <p:spPr>
-          <a:xfrm xmlns:a="http://schemas.openxmlformats.org/drawingml/2006/main">
-            <a:off x="594360" y="685800"/>
-            <a:ext cx="10972800" cy="685800"/>
-          </a:xfrm>
-          <a:prstGeom xmlns:a="http://schemas.openxmlformats.org/drawingml/2006/main" prst="rect">
-            <a:avLst/>
-          </a:prstGeom>
-          <a:noFill xmlns:a="http://schemas.openxmlformats.org/drawingml/2006/main"/>
-        </p:spPr>
-        <p:txBody>
-          <a:bodyPr xmlns:a="http://schemas.openxmlformats.org/drawingml/2006/main" wrap="square" lIns="0" tIns="0" rIns="0" bIns="0" anchor="t">
-            <a:spAutoFit/>
-          </a:bodyPr>
-          <a:lstStyle xmlns:a="http://schemas.openxmlformats.org/drawingml/2006/main"/>
-          <a:p xmlns:a="http://schemas.openxmlformats.org/drawingml/2006/main">
-            <a:pPr algn="l">
-              <a:buNone/>
-            </a:pPr>
-            <a:r>
-              <a:rPr sz="3000" b="1" i="0">
-                <a:solidFill>
-                  <a:srgbClr val="222D38"/>
-                </a:solidFill>
-                <a:latin typeface="Aptos"/>
-                <a:ea typeface="Aptos"/>
-                <a:cs typeface="Aptos"/>
-              </a:rPr>
-              <a:t>Content has value beyond one deliverable</a:t>
-            </a:r>
-          </a:p>
-        </p:txBody>
-      </p:sp>
-      <p:sp>
-        <p:nvSpPr>
-          <p:cNvPr id="5" name="TextBox 4">
-            <a:extLst xmlns:a="http://schemas.openxmlformats.org/drawingml/2006/main">
-              <a:ext uri="{FF2B5EF4-FFF2-40B4-BE49-F238E27FC236}">
-                <a16:creationId xmlns:a16="http://schemas.microsoft.com/office/drawing/2014/main" id="{D57CCE0F-3DC4-417A-9BA9-5EFB040DA622}"/>
-              </a:ext>
-            </a:extLst>
-          </p:cNvPr>
-          <p:cNvSpPr>
-            <a:spLocks xmlns:a="http://schemas.openxmlformats.org/drawingml/2006/main" noGrp="1"/>
-          </p:cNvSpPr>
-          <p:nvPr/>
-        </p:nvSpPr>
-        <p:spPr>
-          <a:xfrm xmlns:a="http://schemas.openxmlformats.org/drawingml/2006/main">
-            <a:off x="658368" y="1828800"/>
-            <a:ext cx="6492240" cy="1371600"/>
-          </a:xfrm>
-          <a:prstGeom xmlns:a="http://schemas.openxmlformats.org/drawingml/2006/main" prst="rect">
-            <a:avLst/>
-          </a:prstGeom>
-          <a:noFill xmlns:a="http://schemas.openxmlformats.org/drawingml/2006/main"/>
-        </p:spPr>
-        <p:txBody>
-          <a:bodyPr xmlns:a="http://schemas.openxmlformats.org/drawingml/2006/main" wrap="square" lIns="0" tIns="0" rIns="0" bIns="0" anchor="t">
-            <a:spAutoFit/>
-          </a:bodyPr>
-          <a:lstStyle xmlns:a="http://schemas.openxmlformats.org/drawingml/2006/main"/>
-          <a:p xmlns:a="http://schemas.openxmlformats.org/drawingml/2006/main">
-            <a:pPr algn="l">
-              <a:buNone/>
-            </a:pPr>
-            <a:r>
-              <a:rPr sz="3000" b="1" i="0">
-                <a:solidFill>
-                  <a:srgbClr val="222D38"/>
-                </a:solidFill>
-                <a:latin typeface="Aptos"/>
-                <a:ea typeface="Aptos"/>
-                <a:cs typeface="Aptos"/>
-              </a:rPr>
-              <a:t>A trusted source can serve several formats and customer needs over time.</a:t>
-            </a:r>
-          </a:p>
-        </p:txBody>
-      </p:sp>
-      <p:sp>
-        <p:nvSpPr>
-          <p:cNvPr id="6" name="Rounded Rectangle 5">
-            <a:extLst xmlns:a="http://schemas.openxmlformats.org/drawingml/2006/main">
-              <a:ext uri="{FF2B5EF4-FFF2-40B4-BE49-F238E27FC236}">
-                <a16:creationId xmlns:a16="http://schemas.microsoft.com/office/drawing/2014/main" id="{439CA63E-955A-4964-88EA-3EBA488A28AF}"/>
-              </a:ext>
-            </a:extLst>
-          </p:cNvPr>
-          <p:cNvSpPr>
-            <a:spLocks xmlns:a="http://schemas.openxmlformats.org/drawingml/2006/main" noGrp="1"/>
-          </p:cNvSpPr>
-          <p:nvPr/>
-        </p:nvSpPr>
-        <p:spPr>
-          <a:xfrm xmlns:a="http://schemas.openxmlformats.org/drawingml/2006/main">
-            <a:off x="7818120" y="1600200"/>
-            <a:ext cx="3611880" cy="3291840"/>
-          </a:xfrm>
-          <a:prstGeom xmlns:a="http://schemas.openxmlformats.org/drawingml/2006/main" prst="roundRect">
+          <p:cNvPr id="3" name="Rectangle 2">
+            <a:extLst xmlns:a="http://schemas.openxmlformats.org/drawingml/2006/main">
+              <a:ext uri="{FF2B5EF4-FFF2-40B4-BE49-F238E27FC236}">
+                <a16:creationId xmlns:a16="http://schemas.microsoft.com/office/drawing/2014/main" id="{62F058FC-2C26-42A7-9D76-FF38D55919C2}"/>
+              </a:ext>
+            </a:extLst>
+          </p:cNvPr>
+          <p:cNvSpPr>
+            <a:spLocks xmlns:a="http://schemas.openxmlformats.org/drawingml/2006/main" noGrp="1"/>
+          </p:cNvSpPr>
+          <p:nvPr/>
+        </p:nvSpPr>
+        <p:spPr>
+          <a:xfrm xmlns:a="http://schemas.openxmlformats.org/drawingml/2006/main">
+            <a:off x="0" y="0"/>
+            <a:ext cx="164592" cy="6858000"/>
+          </a:xfrm>
+          <a:prstGeom xmlns:a="http://schemas.openxmlformats.org/drawingml/2006/main" prst="rect">
             <a:avLst/>
           </a:prstGeom>
           <a:solidFill xmlns:a="http://schemas.openxmlformats.org/drawingml/2006/main">
-            <a:srgbClr val="142537"/>
+            <a:srgbClr val="CF6836"/>
           </a:solidFill>
           <a:ln xmlns:a="http://schemas.openxmlformats.org/drawingml/2006/main">
             <a:solidFill>
-              <a:srgbClr val="142537"/>
+              <a:srgbClr val="CF6836"/>
             </a:solidFill>
           </a:ln>
         </p:spPr>
@@ -14431,22 +13951,22 @@
       </p:sp>
       <p:sp>
         <p:nvSpPr>
-          <p:cNvPr id="7" name="TextBox 6">
-            <a:extLst xmlns:a="http://schemas.openxmlformats.org/drawingml/2006/main">
-              <a:ext uri="{FF2B5EF4-FFF2-40B4-BE49-F238E27FC236}">
-                <a16:creationId xmlns:a16="http://schemas.microsoft.com/office/drawing/2014/main" id="{BC37128B-2DBD-43FC-AB7D-5D555E87E24F}"/>
-              </a:ext>
-            </a:extLst>
-          </p:cNvPr>
-          <p:cNvSpPr>
-            <a:spLocks xmlns:a="http://schemas.openxmlformats.org/drawingml/2006/main" noGrp="1"/>
-          </p:cNvSpPr>
-          <p:nvPr/>
-        </p:nvSpPr>
-        <p:spPr>
-          <a:xfrm xmlns:a="http://schemas.openxmlformats.org/drawingml/2006/main">
-            <a:off x="8138160" y="1938528"/>
-            <a:ext cx="2926080" cy="411480"/>
+          <p:cNvPr id="4" name="TextBox 3">
+            <a:extLst xmlns:a="http://schemas.openxmlformats.org/drawingml/2006/main">
+              <a:ext uri="{FF2B5EF4-FFF2-40B4-BE49-F238E27FC236}">
+                <a16:creationId xmlns:a16="http://schemas.microsoft.com/office/drawing/2014/main" id="{3D58D985-12B6-4F5A-891A-D9ED565C7930}"/>
+              </a:ext>
+            </a:extLst>
+          </p:cNvPr>
+          <p:cNvSpPr>
+            <a:spLocks xmlns:a="http://schemas.openxmlformats.org/drawingml/2006/main" noGrp="1"/>
+          </p:cNvSpPr>
+          <p:nvPr/>
+        </p:nvSpPr>
+        <p:spPr>
+          <a:xfrm xmlns:a="http://schemas.openxmlformats.org/drawingml/2006/main">
+            <a:off x="685800" y="713232"/>
+            <a:ext cx="7132320" cy="320040"/>
           </a:xfrm>
           <a:prstGeom xmlns:a="http://schemas.openxmlformats.org/drawingml/2006/main" prst="rect">
             <a:avLst/>
@@ -14463,164 +13983,37 @@
               <a:buNone/>
             </a:pPr>
             <a:r>
-              <a:rPr sz="1600" b="1" i="0">
-                <a:solidFill>
-                  <a:srgbClr val="FFFFFF"/>
-                </a:solidFill>
-                <a:latin typeface="Aptos"/>
-                <a:ea typeface="Aptos"/>
-                <a:cs typeface="Aptos"/>
-              </a:rPr>
-              <a:t>What makes it an asset:</a:t>
-            </a:r>
-          </a:p>
-        </p:txBody>
-      </p:sp>
-      <p:sp>
-        <p:nvSpPr>
-          <p:cNvPr id="8" name="TextBox 7">
-            <a:extLst xmlns:a="http://schemas.openxmlformats.org/drawingml/2006/main">
-              <a:ext uri="{FF2B5EF4-FFF2-40B4-BE49-F238E27FC236}">
-                <a16:creationId xmlns:a16="http://schemas.microsoft.com/office/drawing/2014/main" id="{4C9EAC54-34AA-425B-B447-0EA671FDBD7A}"/>
-              </a:ext>
-            </a:extLst>
-          </p:cNvPr>
-          <p:cNvSpPr>
-            <a:spLocks xmlns:a="http://schemas.openxmlformats.org/drawingml/2006/main" noGrp="1"/>
-          </p:cNvSpPr>
-          <p:nvPr/>
-        </p:nvSpPr>
-        <p:spPr>
-          <a:xfrm xmlns:a="http://schemas.openxmlformats.org/drawingml/2006/main">
-            <a:off x="8138160" y="2542032"/>
-            <a:ext cx="2743200" cy="2011680"/>
-          </a:xfrm>
-          <a:prstGeom xmlns:a="http://schemas.openxmlformats.org/drawingml/2006/main" prst="rect">
-            <a:avLst/>
-          </a:prstGeom>
-          <a:noFill xmlns:a="http://schemas.openxmlformats.org/drawingml/2006/main"/>
-        </p:spPr>
-        <p:txBody>
-          <a:bodyPr xmlns:a="http://schemas.openxmlformats.org/drawingml/2006/main" wrap="square" lIns="0" rIns="0">
-            <a:spAutoFit/>
-          </a:bodyPr>
-          <a:lstStyle xmlns:a="http://schemas.openxmlformats.org/drawingml/2006/main"/>
-          <a:p xmlns:a="http://schemas.openxmlformats.org/drawingml/2006/main">
-            <a:pPr>
-              <a:spcAft>
-                <a:spcPts val="1200"/>
-              </a:spcAft>
-              <a:buNone/>
-              <a:defRPr sz="1600">
-                <a:solidFill>
-                  <a:srgbClr val="FFFFFF"/>
-                </a:solidFill>
-                <a:latin typeface="Aptos"/>
-                <a:ea typeface="Aptos"/>
-                <a:cs typeface="Aptos"/>
-              </a:defRPr>
-            </a:pPr>
-            <a:r>
-              <a:rPr>
-                <a:solidFill>
-                  <a:srgbClr val="FFFFFF"/>
-                </a:solidFill>
-              </a:rPr>
-              <a:t>1. An owner and review date</a:t>
-            </a:r>
-          </a:p>
-          <a:p xmlns:a="http://schemas.openxmlformats.org/drawingml/2006/main">
-            <a:pPr>
-              <a:spcAft>
-                <a:spcPts val="1200"/>
-              </a:spcAft>
-              <a:buNone/>
-              <a:defRPr sz="1600">
-                <a:solidFill>
-                  <a:srgbClr val="FFFFFF"/>
-                </a:solidFill>
-                <a:latin typeface="Aptos"/>
-                <a:ea typeface="Aptos"/>
-                <a:cs typeface="Aptos"/>
-              </a:defRPr>
-            </a:pPr>
-            <a:r>
-              <a:rPr>
-                <a:solidFill>
-                  <a:srgbClr val="FFFFFF"/>
-                </a:solidFill>
-              </a:rPr>
-              <a:t>2. Approved, reusable knowledge</a:t>
-            </a:r>
-          </a:p>
-          <a:p xmlns:a="http://schemas.openxmlformats.org/drawingml/2006/main">
-            <a:pPr>
-              <a:spcAft>
-                <a:spcPts val="1200"/>
-              </a:spcAft>
-              <a:buNone/>
-              <a:defRPr sz="1600">
-                <a:solidFill>
-                  <a:srgbClr val="FFFFFF"/>
-                </a:solidFill>
-                <a:latin typeface="Aptos"/>
-                <a:ea typeface="Aptos"/>
-                <a:cs typeface="Aptos"/>
-              </a:defRPr>
-            </a:pPr>
-            <a:r>
-              <a:rPr>
-                <a:solidFill>
-                  <a:srgbClr val="FFFFFF"/>
-                </a:solidFill>
-              </a:rPr>
-              <a:t>3. Evidence of customer use</a:t>
-            </a:r>
-          </a:p>
-          <a:p xmlns:a="http://schemas.openxmlformats.org/drawingml/2006/main">
-            <a:pPr>
-              <a:spcAft>
-                <a:spcPts val="1200"/>
-              </a:spcAft>
-              <a:buNone/>
-              <a:defRPr sz="1600">
-                <a:solidFill>
-                  <a:srgbClr val="FFFFFF"/>
-                </a:solidFill>
-                <a:latin typeface="Aptos"/>
-                <a:ea typeface="Aptos"/>
-                <a:cs typeface="Aptos"/>
-              </a:defRPr>
-            </a:pPr>
-            <a:r>
-              <a:rPr>
-                <a:solidFill>
-                  <a:srgbClr val="FFFFFF"/>
-                </a:solidFill>
-              </a:rPr>
-              <a:t>4. The cost of upkeep and risk</a:t>
-            </a:r>
-          </a:p>
-        </p:txBody>
-      </p:sp>
-      <p:sp>
-        <p:nvSpPr>
-          <p:cNvPr id="9" name="TextBox 8">
-            <a:extLst xmlns:a="http://schemas.openxmlformats.org/drawingml/2006/main">
-              <a:ext uri="{FF2B5EF4-FFF2-40B4-BE49-F238E27FC236}">
-                <a16:creationId xmlns:a16="http://schemas.microsoft.com/office/drawing/2014/main" id="{4D866905-FC4B-43F5-B059-15FAD39D948B}"/>
-              </a:ext>
-            </a:extLst>
-          </p:cNvPr>
-          <p:cNvSpPr>
-            <a:spLocks xmlns:a="http://schemas.openxmlformats.org/drawingml/2006/main" noGrp="1"/>
-          </p:cNvSpPr>
-          <p:nvPr/>
-        </p:nvSpPr>
-        <p:spPr>
-          <a:xfrm xmlns:a="http://schemas.openxmlformats.org/drawingml/2006/main">
-            <a:off x="658368" y="4160520"/>
-            <a:ext cx="6583680" cy="822960"/>
+              <a:rPr sz="1300" b="1" i="0">
+                <a:solidFill>
+                  <a:srgbClr val="CF6836"/>
+                </a:solidFill>
+                <a:latin typeface="Aptos"/>
+                <a:ea typeface="Aptos"/>
+                <a:cs typeface="Aptos"/>
+              </a:rPr>
+              <a:t>CONTENT AS A BUSINESS ASSET</a:t>
+            </a:r>
+          </a:p>
+        </p:txBody>
+      </p:sp>
+      <p:sp>
+        <p:nvSpPr>
+          <p:cNvPr id="5" name="TextBox 4">
+            <a:extLst xmlns:a="http://schemas.openxmlformats.org/drawingml/2006/main">
+              <a:ext uri="{FF2B5EF4-FFF2-40B4-BE49-F238E27FC236}">
+                <a16:creationId xmlns:a16="http://schemas.microsoft.com/office/drawing/2014/main" id="{753616DE-1F0B-4BEA-A642-6A3870D0C114}"/>
+              </a:ext>
+            </a:extLst>
+          </p:cNvPr>
+          <p:cNvSpPr>
+            <a:spLocks xmlns:a="http://schemas.openxmlformats.org/drawingml/2006/main" noGrp="1"/>
+          </p:cNvSpPr>
+          <p:nvPr/>
+        </p:nvSpPr>
+        <p:spPr>
+          <a:xfrm xmlns:a="http://schemas.openxmlformats.org/drawingml/2006/main">
+            <a:off x="685800" y="1325880"/>
+            <a:ext cx="9875520" cy="1691640"/>
           </a:xfrm>
           <a:prstGeom xmlns:a="http://schemas.openxmlformats.org/drawingml/2006/main" prst="rect">
             <a:avLst/>
@@ -14637,37 +14030,53 @@
               <a:buNone/>
             </a:pPr>
             <a:r>
-              <a:rPr sz="2100" b="1" i="0">
-                <a:solidFill>
-                  <a:srgbClr val="CF6836"/>
-                </a:solidFill>
-                <a:latin typeface="Aptos"/>
-                <a:ea typeface="Aptos"/>
-                <a:cs typeface="Aptos"/>
-              </a:rPr>
-              <a:t>The pilot exposed roughly 30% overlap, creating an immediate reuse opportunity.</a:t>
-            </a:r>
-          </a:p>
-        </p:txBody>
-      </p:sp>
-      <p:sp>
-        <p:nvSpPr>
-          <p:cNvPr id="10" name="TextBox 9">
-            <a:extLst xmlns:a="http://schemas.openxmlformats.org/drawingml/2006/main">
-              <a:ext uri="{FF2B5EF4-FFF2-40B4-BE49-F238E27FC236}">
-                <a16:creationId xmlns:a16="http://schemas.microsoft.com/office/drawing/2014/main" id="{1517326B-C685-438B-8E35-7961E0E7DFC0}"/>
-              </a:ext>
-            </a:extLst>
-          </p:cNvPr>
-          <p:cNvSpPr>
-            <a:spLocks xmlns:a="http://schemas.openxmlformats.org/drawingml/2006/main" noGrp="1"/>
-          </p:cNvSpPr>
-          <p:nvPr/>
-        </p:nvSpPr>
-        <p:spPr>
-          <a:xfrm xmlns:a="http://schemas.openxmlformats.org/drawingml/2006/main">
-            <a:off x="11292840" y="6446520"/>
-            <a:ext cx="320040" cy="182880"/>
+              <a:rPr sz="3600" b="1" i="0">
+                <a:solidFill>
+                  <a:srgbClr val="FFFFFF"/>
+                </a:solidFill>
+                <a:latin typeface="Aptos"/>
+                <a:ea typeface="Aptos"/>
+                <a:cs typeface="Aptos"/>
+              </a:rPr>
+              <a:t>Unified content strategy</a:t>
+            </a:r>
+          </a:p>
+          <a:p xmlns:a="http://schemas.openxmlformats.org/drawingml/2006/main">
+            <a:pPr algn="l">
+              <a:buNone/>
+            </a:pPr>
+            <a:r>
+              <a:rPr sz="3600" b="1" i="0">
+                <a:solidFill>
+                  <a:srgbClr val="FFFFFF"/>
+                </a:solidFill>
+                <a:latin typeface="Aptos"/>
+                <a:ea typeface="Aptos"/>
+                <a:cs typeface="Aptos"/>
+              </a:rPr>
+              <a:t>in practice</a:t>
+            </a:r>
+          </a:p>
+        </p:txBody>
+      </p:sp>
+      <p:sp>
+        <p:nvSpPr>
+          <p:cNvPr id="6" name="TextBox 5">
+            <a:extLst xmlns:a="http://schemas.openxmlformats.org/drawingml/2006/main">
+              <a:ext uri="{FF2B5EF4-FFF2-40B4-BE49-F238E27FC236}">
+                <a16:creationId xmlns:a16="http://schemas.microsoft.com/office/drawing/2014/main" id="{E5717035-7781-405E-B586-73B91D20F8AB}"/>
+              </a:ext>
+            </a:extLst>
+          </p:cNvPr>
+          <p:cNvSpPr>
+            <a:spLocks xmlns:a="http://schemas.openxmlformats.org/drawingml/2006/main" noGrp="1"/>
+          </p:cNvSpPr>
+          <p:nvPr/>
+        </p:nvSpPr>
+        <p:spPr>
+          <a:xfrm xmlns:a="http://schemas.openxmlformats.org/drawingml/2006/main">
+            <a:off x="713232" y="3401568"/>
+            <a:ext cx="7772400" cy="457200"/>
           </a:xfrm>
           <a:prstGeom xmlns:a="http://schemas.openxmlformats.org/drawingml/2006/main" prst="rect">
             <a:avLst/>
@@ -14680,11 +14089,105 @@
           </a:bodyPr>
           <a:lstStyle xmlns:a="http://schemas.openxmlformats.org/drawingml/2006/main"/>
           <a:p xmlns:a="http://schemas.openxmlformats.org/drawingml/2006/main">
-            <a:pPr algn="r">
-              <a:buNone/>
-            </a:pPr>
-            <a:r>
-              <a:rPr sz="1000" b="1" i="0">
+            <a:pPr algn="l">
+              <a:buNone/>
+            </a:pPr>
+            <a:r>
+              <a:rPr sz="1900" b="0" i="0">
+                <a:solidFill>
+                  <a:srgbClr val="C0CDD9"/>
+                </a:solidFill>
+                <a:latin typeface="Aptos"/>
+                <a:ea typeface="Aptos"/>
+                <a:cs typeface="Aptos"/>
+              </a:rPr>
+              <a:t>A LavaCon case study based on a product launch</a:t>
+            </a:r>
+          </a:p>
+        </p:txBody>
+      </p:sp>
+      <p:sp>
+        <p:nvSpPr>
+          <p:cNvPr id="7" name="TextBox 6">
+            <a:extLst xmlns:a="http://schemas.openxmlformats.org/drawingml/2006/main">
+              <a:ext uri="{FF2B5EF4-FFF2-40B4-BE49-F238E27FC236}">
+                <a16:creationId xmlns:a16="http://schemas.microsoft.com/office/drawing/2014/main" id="{5CF09819-6A70-4FBB-86F1-823F47822C8C}"/>
+              </a:ext>
+            </a:extLst>
+          </p:cNvPr>
+          <p:cNvSpPr>
+            <a:spLocks xmlns:a="http://schemas.openxmlformats.org/drawingml/2006/main" noGrp="1"/>
+          </p:cNvSpPr>
+          <p:nvPr/>
+        </p:nvSpPr>
+        <p:spPr>
+          <a:xfrm xmlns:a="http://schemas.openxmlformats.org/drawingml/2006/main">
+            <a:off x="713232" y="5824728"/>
+            <a:ext cx="7315200" cy="320040"/>
+          </a:xfrm>
+          <a:prstGeom xmlns:a="http://schemas.openxmlformats.org/drawingml/2006/main" prst="rect">
+            <a:avLst/>
+          </a:prstGeom>
+          <a:noFill xmlns:a="http://schemas.openxmlformats.org/drawingml/2006/main"/>
+        </p:spPr>
+        <p:txBody>
+          <a:bodyPr xmlns:a="http://schemas.openxmlformats.org/drawingml/2006/main" wrap="square" lIns="0" tIns="0" rIns="0" bIns="0" anchor="t">
+            <a:spAutoFit/>
+          </a:bodyPr>
+          <a:lstStyle xmlns:a="http://schemas.openxmlformats.org/drawingml/2006/main"/>
+          <a:p xmlns:a="http://schemas.openxmlformats.org/drawingml/2006/main">
+            <a:pPr algn="l">
+              <a:buNone/>
+            </a:pPr>
+            <a:r>
+              <a:rPr sz="1600" b="1" i="0">
+                <a:solidFill>
+                  <a:srgbClr val="FFFFFF"/>
+                </a:solidFill>
+                <a:latin typeface="Aptos"/>
+                <a:ea typeface="Aptos"/>
+                <a:cs typeface="Aptos"/>
+              </a:rPr>
+              <a:t>Sharmila Das  ·  Rebecca Rhee</a:t>
+            </a:r>
+          </a:p>
+        </p:txBody>
+      </p:sp>
+      <p:sp>
+        <p:nvSpPr>
+          <p:cNvPr id="8" name="TextBox 7">
+            <a:extLst xmlns:a="http://schemas.openxmlformats.org/drawingml/2006/main">
+              <a:ext uri="{FF2B5EF4-FFF2-40B4-BE49-F238E27FC236}">
+                <a16:creationId xmlns:a16="http://schemas.microsoft.com/office/drawing/2014/main" id="{6072ABA9-75AA-42BD-9356-0E87672E6512}"/>
+              </a:ext>
+            </a:extLst>
+          </p:cNvPr>
+          <p:cNvSpPr>
+            <a:spLocks xmlns:a="http://schemas.openxmlformats.org/drawingml/2006/main" noGrp="1"/>
+          </p:cNvSpPr>
+          <p:nvPr/>
+        </p:nvSpPr>
+        <p:spPr>
+          <a:xfrm xmlns:a="http://schemas.openxmlformats.org/drawingml/2006/main">
+            <a:off x="713232" y="6208776"/>
+            <a:ext cx="9601200" cy="274320"/>
+          </a:xfrm>
+          <a:prstGeom xmlns:a="http://schemas.openxmlformats.org/drawingml/2006/main" prst="rect">
+            <a:avLst/>
+          </a:prstGeom>
+          <a:noFill xmlns:a="http://schemas.openxmlformats.org/drawingml/2006/main"/>
+        </p:spPr>
+        <p:txBody>
+          <a:bodyPr xmlns:a="http://schemas.openxmlformats.org/drawingml/2006/main" wrap="square" lIns="0" tIns="0" rIns="0" bIns="0" anchor="t">
+            <a:spAutoFit/>
+          </a:bodyPr>
+          <a:lstStyle xmlns:a="http://schemas.openxmlformats.org/drawingml/2006/main"/>
+          <a:p xmlns:a="http://schemas.openxmlformats.org/drawingml/2006/main">
+            <a:pPr algn="l">
+              <a:buNone/>
+            </a:pPr>
+            <a:r>
+              <a:rPr sz="1200" b="0" i="0">
                 <a:solidFill>
                   <a:srgbClr val="687B8E"/>
                 </a:solidFill>
@@ -14692,7 +14195,7 @@
                 <a:ea typeface="Aptos"/>
                 <a:cs typeface="Aptos"/>
               </a:rPr>
-              <a:t>02</a:t>
+              <a:t>Content strategy, information architecture, and cross-team workflow</a:t>
             </a:r>
           </a:p>
         </p:txBody>
@@ -14700,7 +14203,7 @@
     </p:spTree>
     <p:extLst>
       <p:ext uri="{BB962C8B-B14F-4D97-AF65-F5344CB8AC3E}">
-        <p14:creationId xmlns:p14="http://schemas.microsoft.com/office/powerpoint/2010/main" val="1184106965"/>
+        <p14:creationId xmlns:p14="http://schemas.microsoft.com/office/powerpoint/2010/main" val="1583064581"/>
       </p:ext>
     </p:extLst>
   </p:cSld>
@@ -17484,7 +16987,7 @@
                 <a:ea typeface="Aptos"/>
                 <a:cs typeface="Aptos"/>
               </a:rPr>
-              <a:t>AT A GLANCE</a:t>
+              <a:t>WHY CONTENT IS AN ASSET</a:t>
             </a:r>
           </a:p>
         </p:txBody>
@@ -17531,7 +17034,7 @@
                 <a:ea typeface="Aptos"/>
                 <a:cs typeface="Aptos"/>
               </a:rPr>
-              <a:t>Unified content strategy at a glance</a:t>
+              <a:t>Content has value beyond one deliverable</a:t>
             </a:r>
           </a:p>
         </p:txBody>
@@ -17578,7 +17081,7 @@
                 <a:ea typeface="Aptos"/>
                 <a:cs typeface="Aptos"/>
               </a:rPr>
-              <a:t>One customer journey needs a shared plan across the teams behind it.</a:t>
+              <a:t>A trusted source can serve several formats and customer needs over time.</a:t>
             </a:r>
           </a:p>
         </p:txBody>
@@ -17680,7 +17183,7 @@
                 <a:ea typeface="Aptos"/>
                 <a:cs typeface="Aptos"/>
               </a:rPr>
-              <a:t>This presentation covers:</a:t>
+              <a:t>What makes it an asset:</a:t>
             </a:r>
           </a:p>
         </p:txBody>
@@ -17735,7 +17238,7 @@
                   <a:srgbClr val="FFFFFF"/>
                 </a:solidFill>
               </a:rPr>
-              <a:t>1. Shared decisions across teams</a:t>
+              <a:t>1. An owner and review date</a:t>
             </a:r>
           </a:p>
           <a:p xmlns:a="http://schemas.openxmlformats.org/drawingml/2006/main">
@@ -17759,7 +17262,7 @@
                   <a:srgbClr val="FFFFFF"/>
                 </a:solidFill>
               </a:rPr>
-              <a:t>2. A seven-step working method</a:t>
+              <a:t>2. Approved, reusable knowledge</a:t>
             </a:r>
           </a:p>
           <a:p xmlns:a="http://schemas.openxmlformats.org/drawingml/2006/main">
@@ -17783,7 +17286,7 @@
                   <a:srgbClr val="FFFFFF"/>
                 </a:solidFill>
               </a:rPr>
-              <a:t>3. A product-launch pilot</a:t>
+              <a:t>3. Evidence of customer use</a:t>
             </a:r>
           </a:p>
           <a:p xmlns:a="http://schemas.openxmlformats.org/drawingml/2006/main">
@@ -17807,7 +17310,7 @@
                   <a:srgbClr val="FFFFFF"/>
                 </a:solidFill>
               </a:rPr>
-              <a:t>4. Lessons and a 90-day start</a:t>
+              <a:t>4. The cost of upkeep and risk</a:t>
             </a:r>
           </a:p>
         </p:txBody>
@@ -17854,7 +17357,7 @@
                 <a:ea typeface="Aptos"/>
                 <a:cs typeface="Aptos"/>
               </a:rPr>
-              <a:t>The pilot found roughly 30% overlap in the content reviewed.</a:t>
+              <a:t>The pilot exposed roughly 30% overlap, creating an immediate reuse opportunity.</a:t>
             </a:r>
           </a:p>
         </p:txBody>
@@ -17928,32 +17431,529 @@
       <p:grpSpPr>
         <a:xfrm xmlns:a="http://schemas.openxmlformats.org/drawingml/2006/main"/>
       </p:grpSpPr>
-      <p:pic>
-        <p:nvPicPr>
-          <p:cNvPr id="2" name=""/>
-          <p:cNvPicPr>
-            <a:picLocks xmlns:a="http://schemas.openxmlformats.org/drawingml/2006/main" noChangeAspect="1"/>
-          </p:cNvPicPr>
-          <p:nvPr/>
-        </p:nvPicPr>
-        <p:blipFill>
-          <a:blip xmlns:r="http://schemas.openxmlformats.org/officeDocument/2006/relationships" xmlns:a="http://schemas.openxmlformats.org/drawingml/2006/main" r:embed="R8bdafc1fd64e45ed"/>
-          <a:stretch xmlns:a="http://schemas.openxmlformats.org/drawingml/2006/main"/>
-        </p:blipFill>
+      <p:sp>
+        <p:nvSpPr>
+          <p:cNvPr id="2" name="Rectangle 1">
+            <a:extLst xmlns:a="http://schemas.openxmlformats.org/drawingml/2006/main">
+              <a:ext uri="{FF2B5EF4-FFF2-40B4-BE49-F238E27FC236}">
+                <a16:creationId xmlns:a16="http://schemas.microsoft.com/office/drawing/2014/main" id="{6431DF86-C327-4D56-B839-3993C43ACDB1}"/>
+              </a:ext>
+            </a:extLst>
+          </p:cNvPr>
+          <p:cNvSpPr>
+            <a:spLocks xmlns:a="http://schemas.openxmlformats.org/drawingml/2006/main" noGrp="1"/>
+          </p:cNvSpPr>
+          <p:nvPr/>
+        </p:nvSpPr>
         <p:spPr>
           <a:xfrm xmlns:a="http://schemas.openxmlformats.org/drawingml/2006/main">
             <a:off x="0" y="0"/>
-            <a:ext cx="12192000" cy="6858000"/>
-          </a:xfrm>
-          <a:prstGeom xmlns:a="http://schemas.openxmlformats.org/drawingml/2006/main" prst="rect">
-            <a:avLst/>
-          </a:prstGeom>
-        </p:spPr>
-      </p:pic>
+            <a:ext cx="12191695" cy="6858000"/>
+          </a:xfrm>
+          <a:prstGeom xmlns:a="http://schemas.openxmlformats.org/drawingml/2006/main" prst="rect">
+            <a:avLst/>
+          </a:prstGeom>
+          <a:solidFill xmlns:a="http://schemas.openxmlformats.org/drawingml/2006/main">
+            <a:srgbClr val="F6F2EB"/>
+          </a:solidFill>
+          <a:ln xmlns:a="http://schemas.openxmlformats.org/drawingml/2006/main">
+            <a:solidFill>
+              <a:srgbClr val="F6F2EB"/>
+            </a:solidFill>
+          </a:ln>
+        </p:spPr>
+        <p:style>
+          <a:lnRef xmlns:a="http://schemas.openxmlformats.org/drawingml/2006/main" idx="1">
+            <a:schemeClr val="accent1"/>
+          </a:lnRef>
+          <a:fillRef xmlns:a="http://schemas.openxmlformats.org/drawingml/2006/main" idx="3">
+            <a:schemeClr val="accent1"/>
+          </a:fillRef>
+          <a:effectRef xmlns:a="http://schemas.openxmlformats.org/drawingml/2006/main" idx="2">
+            <a:schemeClr val="accent1"/>
+          </a:effectRef>
+          <a:fontRef xmlns:a="http://schemas.openxmlformats.org/drawingml/2006/main" idx="minor">
+            <a:schemeClr val="lt1"/>
+          </a:fontRef>
+        </p:style>
+        <p:txBody>
+          <a:bodyPr xmlns:a="http://schemas.openxmlformats.org/drawingml/2006/main" anchor="ctr"/>
+          <a:lstStyle xmlns:a="http://schemas.openxmlformats.org/drawingml/2006/main"/>
+          <a:p xmlns:a="http://schemas.openxmlformats.org/drawingml/2006/main">
+            <a:pPr algn="ctr">
+              <a:buNone/>
+            </a:pPr>
+          </a:p>
+        </p:txBody>
+      </p:sp>
+      <p:sp>
+        <p:nvSpPr>
+          <p:cNvPr id="3" name="TextBox 2">
+            <a:extLst xmlns:a="http://schemas.openxmlformats.org/drawingml/2006/main">
+              <a:ext uri="{FF2B5EF4-FFF2-40B4-BE49-F238E27FC236}">
+                <a16:creationId xmlns:a16="http://schemas.microsoft.com/office/drawing/2014/main" id="{65768798-9076-4042-B43C-16EC48AD2BB5}"/>
+              </a:ext>
+            </a:extLst>
+          </p:cNvPr>
+          <p:cNvSpPr>
+            <a:spLocks xmlns:a="http://schemas.openxmlformats.org/drawingml/2006/main" noGrp="1"/>
+          </p:cNvSpPr>
+          <p:nvPr/>
+        </p:nvSpPr>
+        <p:spPr>
+          <a:xfrm xmlns:a="http://schemas.openxmlformats.org/drawingml/2006/main">
+            <a:off x="594360" y="320040"/>
+            <a:ext cx="4114800" cy="274320"/>
+          </a:xfrm>
+          <a:prstGeom xmlns:a="http://schemas.openxmlformats.org/drawingml/2006/main" prst="rect">
+            <a:avLst/>
+          </a:prstGeom>
+          <a:noFill xmlns:a="http://schemas.openxmlformats.org/drawingml/2006/main"/>
+        </p:spPr>
+        <p:txBody>
+          <a:bodyPr xmlns:a="http://schemas.openxmlformats.org/drawingml/2006/main" wrap="square" lIns="0" tIns="0" rIns="0" bIns="0" anchor="t">
+            <a:spAutoFit/>
+          </a:bodyPr>
+          <a:lstStyle xmlns:a="http://schemas.openxmlformats.org/drawingml/2006/main"/>
+          <a:p xmlns:a="http://schemas.openxmlformats.org/drawingml/2006/main">
+            <a:pPr algn="l">
+              <a:buNone/>
+            </a:pPr>
+            <a:r>
+              <a:rPr sz="1100" b="1" i="0">
+                <a:solidFill>
+                  <a:srgbClr val="CF6836"/>
+                </a:solidFill>
+                <a:latin typeface="Aptos"/>
+                <a:ea typeface="Aptos"/>
+                <a:cs typeface="Aptos"/>
+              </a:rPr>
+              <a:t>AT A GLANCE</a:t>
+            </a:r>
+          </a:p>
+        </p:txBody>
+      </p:sp>
+      <p:sp>
+        <p:nvSpPr>
+          <p:cNvPr id="4" name="TextBox 3">
+            <a:extLst xmlns:a="http://schemas.openxmlformats.org/drawingml/2006/main">
+              <a:ext uri="{FF2B5EF4-FFF2-40B4-BE49-F238E27FC236}">
+                <a16:creationId xmlns:a16="http://schemas.microsoft.com/office/drawing/2014/main" id="{23E44F1B-499C-40B9-953B-F9A7D304BDBC}"/>
+              </a:ext>
+            </a:extLst>
+          </p:cNvPr>
+          <p:cNvSpPr>
+            <a:spLocks xmlns:a="http://schemas.openxmlformats.org/drawingml/2006/main" noGrp="1"/>
+          </p:cNvSpPr>
+          <p:nvPr/>
+        </p:nvSpPr>
+        <p:spPr>
+          <a:xfrm xmlns:a="http://schemas.openxmlformats.org/drawingml/2006/main">
+            <a:off x="594360" y="685800"/>
+            <a:ext cx="10972800" cy="685800"/>
+          </a:xfrm>
+          <a:prstGeom xmlns:a="http://schemas.openxmlformats.org/drawingml/2006/main" prst="rect">
+            <a:avLst/>
+          </a:prstGeom>
+          <a:noFill xmlns:a="http://schemas.openxmlformats.org/drawingml/2006/main"/>
+        </p:spPr>
+        <p:txBody>
+          <a:bodyPr xmlns:a="http://schemas.openxmlformats.org/drawingml/2006/main" wrap="square" lIns="0" tIns="0" rIns="0" bIns="0" anchor="t">
+            <a:spAutoFit/>
+          </a:bodyPr>
+          <a:lstStyle xmlns:a="http://schemas.openxmlformats.org/drawingml/2006/main"/>
+          <a:p xmlns:a="http://schemas.openxmlformats.org/drawingml/2006/main">
+            <a:pPr algn="l">
+              <a:buNone/>
+            </a:pPr>
+            <a:r>
+              <a:rPr sz="3000" b="1" i="0">
+                <a:solidFill>
+                  <a:srgbClr val="222D38"/>
+                </a:solidFill>
+                <a:latin typeface="Aptos"/>
+                <a:ea typeface="Aptos"/>
+                <a:cs typeface="Aptos"/>
+              </a:rPr>
+              <a:t>Unified content strategy at a glance</a:t>
+            </a:r>
+          </a:p>
+        </p:txBody>
+      </p:sp>
+      <p:sp>
+        <p:nvSpPr>
+          <p:cNvPr id="5" name="TextBox 4">
+            <a:extLst xmlns:a="http://schemas.openxmlformats.org/drawingml/2006/main">
+              <a:ext uri="{FF2B5EF4-FFF2-40B4-BE49-F238E27FC236}">
+                <a16:creationId xmlns:a16="http://schemas.microsoft.com/office/drawing/2014/main" id="{D57CCE0F-3DC4-417A-9BA9-5EFB040DA622}"/>
+              </a:ext>
+            </a:extLst>
+          </p:cNvPr>
+          <p:cNvSpPr>
+            <a:spLocks xmlns:a="http://schemas.openxmlformats.org/drawingml/2006/main" noGrp="1"/>
+          </p:cNvSpPr>
+          <p:nvPr/>
+        </p:nvSpPr>
+        <p:spPr>
+          <a:xfrm xmlns:a="http://schemas.openxmlformats.org/drawingml/2006/main">
+            <a:off x="658368" y="1828800"/>
+            <a:ext cx="6492240" cy="1371600"/>
+          </a:xfrm>
+          <a:prstGeom xmlns:a="http://schemas.openxmlformats.org/drawingml/2006/main" prst="rect">
+            <a:avLst/>
+          </a:prstGeom>
+          <a:noFill xmlns:a="http://schemas.openxmlformats.org/drawingml/2006/main"/>
+        </p:spPr>
+        <p:txBody>
+          <a:bodyPr xmlns:a="http://schemas.openxmlformats.org/drawingml/2006/main" wrap="square" lIns="0" tIns="0" rIns="0" bIns="0" anchor="t">
+            <a:spAutoFit/>
+          </a:bodyPr>
+          <a:lstStyle xmlns:a="http://schemas.openxmlformats.org/drawingml/2006/main"/>
+          <a:p xmlns:a="http://schemas.openxmlformats.org/drawingml/2006/main">
+            <a:pPr algn="l">
+              <a:buNone/>
+            </a:pPr>
+            <a:r>
+              <a:rPr sz="3000" b="1" i="0">
+                <a:solidFill>
+                  <a:srgbClr val="222D38"/>
+                </a:solidFill>
+                <a:latin typeface="Aptos"/>
+                <a:ea typeface="Aptos"/>
+                <a:cs typeface="Aptos"/>
+              </a:rPr>
+              <a:t>One customer journey needs a shared plan across the teams behind it.</a:t>
+            </a:r>
+          </a:p>
+        </p:txBody>
+      </p:sp>
+      <p:sp>
+        <p:nvSpPr>
+          <p:cNvPr id="6" name="Rounded Rectangle 5">
+            <a:extLst xmlns:a="http://schemas.openxmlformats.org/drawingml/2006/main">
+              <a:ext uri="{FF2B5EF4-FFF2-40B4-BE49-F238E27FC236}">
+                <a16:creationId xmlns:a16="http://schemas.microsoft.com/office/drawing/2014/main" id="{439CA63E-955A-4964-88EA-3EBA488A28AF}"/>
+              </a:ext>
+            </a:extLst>
+          </p:cNvPr>
+          <p:cNvSpPr>
+            <a:spLocks xmlns:a="http://schemas.openxmlformats.org/drawingml/2006/main" noGrp="1"/>
+          </p:cNvSpPr>
+          <p:nvPr/>
+        </p:nvSpPr>
+        <p:spPr>
+          <a:xfrm xmlns:a="http://schemas.openxmlformats.org/drawingml/2006/main">
+            <a:off x="7818120" y="1600200"/>
+            <a:ext cx="3611880" cy="3291840"/>
+          </a:xfrm>
+          <a:prstGeom xmlns:a="http://schemas.openxmlformats.org/drawingml/2006/main" prst="roundRect">
+            <a:avLst/>
+          </a:prstGeom>
+          <a:solidFill xmlns:a="http://schemas.openxmlformats.org/drawingml/2006/main">
+            <a:srgbClr val="142537"/>
+          </a:solidFill>
+          <a:ln xmlns:a="http://schemas.openxmlformats.org/drawingml/2006/main">
+            <a:solidFill>
+              <a:srgbClr val="142537"/>
+            </a:solidFill>
+          </a:ln>
+        </p:spPr>
+        <p:style>
+          <a:lnRef xmlns:a="http://schemas.openxmlformats.org/drawingml/2006/main" idx="1">
+            <a:schemeClr val="accent1"/>
+          </a:lnRef>
+          <a:fillRef xmlns:a="http://schemas.openxmlformats.org/drawingml/2006/main" idx="3">
+            <a:schemeClr val="accent1"/>
+          </a:fillRef>
+          <a:effectRef xmlns:a="http://schemas.openxmlformats.org/drawingml/2006/main" idx="2">
+            <a:schemeClr val="accent1"/>
+          </a:effectRef>
+          <a:fontRef xmlns:a="http://schemas.openxmlformats.org/drawingml/2006/main" idx="minor">
+            <a:schemeClr val="lt1"/>
+          </a:fontRef>
+        </p:style>
+        <p:txBody>
+          <a:bodyPr xmlns:a="http://schemas.openxmlformats.org/drawingml/2006/main" anchor="ctr"/>
+          <a:lstStyle xmlns:a="http://schemas.openxmlformats.org/drawingml/2006/main"/>
+          <a:p xmlns:a="http://schemas.openxmlformats.org/drawingml/2006/main">
+            <a:pPr algn="ctr">
+              <a:buNone/>
+            </a:pPr>
+          </a:p>
+        </p:txBody>
+      </p:sp>
+      <p:sp>
+        <p:nvSpPr>
+          <p:cNvPr id="7" name="TextBox 6">
+            <a:extLst xmlns:a="http://schemas.openxmlformats.org/drawingml/2006/main">
+              <a:ext uri="{FF2B5EF4-FFF2-40B4-BE49-F238E27FC236}">
+                <a16:creationId xmlns:a16="http://schemas.microsoft.com/office/drawing/2014/main" id="{BC37128B-2DBD-43FC-AB7D-5D555E87E24F}"/>
+              </a:ext>
+            </a:extLst>
+          </p:cNvPr>
+          <p:cNvSpPr>
+            <a:spLocks xmlns:a="http://schemas.openxmlformats.org/drawingml/2006/main" noGrp="1"/>
+          </p:cNvSpPr>
+          <p:nvPr/>
+        </p:nvSpPr>
+        <p:spPr>
+          <a:xfrm xmlns:a="http://schemas.openxmlformats.org/drawingml/2006/main">
+            <a:off x="8138160" y="1938528"/>
+            <a:ext cx="2926080" cy="411480"/>
+          </a:xfrm>
+          <a:prstGeom xmlns:a="http://schemas.openxmlformats.org/drawingml/2006/main" prst="rect">
+            <a:avLst/>
+          </a:prstGeom>
+          <a:noFill xmlns:a="http://schemas.openxmlformats.org/drawingml/2006/main"/>
+        </p:spPr>
+        <p:txBody>
+          <a:bodyPr xmlns:a="http://schemas.openxmlformats.org/drawingml/2006/main" wrap="square" lIns="0" tIns="0" rIns="0" bIns="0" anchor="t">
+            <a:spAutoFit/>
+          </a:bodyPr>
+          <a:lstStyle xmlns:a="http://schemas.openxmlformats.org/drawingml/2006/main"/>
+          <a:p xmlns:a="http://schemas.openxmlformats.org/drawingml/2006/main">
+            <a:pPr algn="l">
+              <a:buNone/>
+            </a:pPr>
+            <a:r>
+              <a:rPr sz="1600" b="1" i="0">
+                <a:solidFill>
+                  <a:srgbClr val="FFFFFF"/>
+                </a:solidFill>
+                <a:latin typeface="Aptos"/>
+                <a:ea typeface="Aptos"/>
+                <a:cs typeface="Aptos"/>
+              </a:rPr>
+              <a:t>This presentation covers:</a:t>
+            </a:r>
+          </a:p>
+        </p:txBody>
+      </p:sp>
+      <p:sp>
+        <p:nvSpPr>
+          <p:cNvPr id="8" name="TextBox 7">
+            <a:extLst xmlns:a="http://schemas.openxmlformats.org/drawingml/2006/main">
+              <a:ext uri="{FF2B5EF4-FFF2-40B4-BE49-F238E27FC236}">
+                <a16:creationId xmlns:a16="http://schemas.microsoft.com/office/drawing/2014/main" id="{4C9EAC54-34AA-425B-B447-0EA671FDBD7A}"/>
+              </a:ext>
+            </a:extLst>
+          </p:cNvPr>
+          <p:cNvSpPr>
+            <a:spLocks xmlns:a="http://schemas.openxmlformats.org/drawingml/2006/main" noGrp="1"/>
+          </p:cNvSpPr>
+          <p:nvPr/>
+        </p:nvSpPr>
+        <p:spPr>
+          <a:xfrm xmlns:a="http://schemas.openxmlformats.org/drawingml/2006/main">
+            <a:off x="8138160" y="2542032"/>
+            <a:ext cx="2743200" cy="2011680"/>
+          </a:xfrm>
+          <a:prstGeom xmlns:a="http://schemas.openxmlformats.org/drawingml/2006/main" prst="rect">
+            <a:avLst/>
+          </a:prstGeom>
+          <a:noFill xmlns:a="http://schemas.openxmlformats.org/drawingml/2006/main"/>
+        </p:spPr>
+        <p:txBody>
+          <a:bodyPr xmlns:a="http://schemas.openxmlformats.org/drawingml/2006/main" wrap="square" lIns="0" rIns="0">
+            <a:spAutoFit/>
+          </a:bodyPr>
+          <a:lstStyle xmlns:a="http://schemas.openxmlformats.org/drawingml/2006/main"/>
+          <a:p xmlns:a="http://schemas.openxmlformats.org/drawingml/2006/main">
+            <a:pPr>
+              <a:spcAft>
+                <a:spcPts val="1200"/>
+              </a:spcAft>
+              <a:buNone/>
+              <a:defRPr sz="1600">
+                <a:solidFill>
+                  <a:srgbClr val="FFFFFF"/>
+                </a:solidFill>
+                <a:latin typeface="Aptos"/>
+                <a:ea typeface="Aptos"/>
+                <a:cs typeface="Aptos"/>
+              </a:defRPr>
+            </a:pPr>
+            <a:r>
+              <a:rPr>
+                <a:solidFill>
+                  <a:srgbClr val="FFFFFF"/>
+                </a:solidFill>
+              </a:rPr>
+              <a:t>1. Shared decisions across teams</a:t>
+            </a:r>
+          </a:p>
+          <a:p xmlns:a="http://schemas.openxmlformats.org/drawingml/2006/main">
+            <a:pPr>
+              <a:spcAft>
+                <a:spcPts val="1200"/>
+              </a:spcAft>
+              <a:buNone/>
+              <a:defRPr sz="1600">
+                <a:solidFill>
+                  <a:srgbClr val="FFFFFF"/>
+                </a:solidFill>
+                <a:latin typeface="Aptos"/>
+                <a:ea typeface="Aptos"/>
+                <a:cs typeface="Aptos"/>
+              </a:defRPr>
+            </a:pPr>
+            <a:r>
+              <a:rPr>
+                <a:solidFill>
+                  <a:srgbClr val="FFFFFF"/>
+                </a:solidFill>
+              </a:rPr>
+              <a:t>2. A seven-step working method</a:t>
+            </a:r>
+          </a:p>
+          <a:p xmlns:a="http://schemas.openxmlformats.org/drawingml/2006/main">
+            <a:pPr>
+              <a:spcAft>
+                <a:spcPts val="1200"/>
+              </a:spcAft>
+              <a:buNone/>
+              <a:defRPr sz="1600">
+                <a:solidFill>
+                  <a:srgbClr val="FFFFFF"/>
+                </a:solidFill>
+                <a:latin typeface="Aptos"/>
+                <a:ea typeface="Aptos"/>
+                <a:cs typeface="Aptos"/>
+              </a:defRPr>
+            </a:pPr>
+            <a:r>
+              <a:rPr>
+                <a:solidFill>
+                  <a:srgbClr val="FFFFFF"/>
+                </a:solidFill>
+              </a:rPr>
+              <a:t>3. A product-launch pilot</a:t>
+            </a:r>
+          </a:p>
+          <a:p xmlns:a="http://schemas.openxmlformats.org/drawingml/2006/main">
+            <a:pPr>
+              <a:spcAft>
+                <a:spcPts val="1200"/>
+              </a:spcAft>
+              <a:buNone/>
+              <a:defRPr sz="1600">
+                <a:solidFill>
+                  <a:srgbClr val="FFFFFF"/>
+                </a:solidFill>
+                <a:latin typeface="Aptos"/>
+                <a:ea typeface="Aptos"/>
+                <a:cs typeface="Aptos"/>
+              </a:defRPr>
+            </a:pPr>
+            <a:r>
+              <a:rPr>
+                <a:solidFill>
+                  <a:srgbClr val="FFFFFF"/>
+                </a:solidFill>
+              </a:rPr>
+              <a:t>4. Lessons and a 90-day start</a:t>
+            </a:r>
+          </a:p>
+        </p:txBody>
+      </p:sp>
+      <p:sp>
+        <p:nvSpPr>
+          <p:cNvPr id="9" name="TextBox 8">
+            <a:extLst xmlns:a="http://schemas.openxmlformats.org/drawingml/2006/main">
+              <a:ext uri="{FF2B5EF4-FFF2-40B4-BE49-F238E27FC236}">
+                <a16:creationId xmlns:a16="http://schemas.microsoft.com/office/drawing/2014/main" id="{4D866905-FC4B-43F5-B059-15FAD39D948B}"/>
+              </a:ext>
+            </a:extLst>
+          </p:cNvPr>
+          <p:cNvSpPr>
+            <a:spLocks xmlns:a="http://schemas.openxmlformats.org/drawingml/2006/main" noGrp="1"/>
+          </p:cNvSpPr>
+          <p:nvPr/>
+        </p:nvSpPr>
+        <p:spPr>
+          <a:xfrm xmlns:a="http://schemas.openxmlformats.org/drawingml/2006/main">
+            <a:off x="658368" y="4160520"/>
+            <a:ext cx="6583680" cy="822960"/>
+          </a:xfrm>
+          <a:prstGeom xmlns:a="http://schemas.openxmlformats.org/drawingml/2006/main" prst="rect">
+            <a:avLst/>
+          </a:prstGeom>
+          <a:noFill xmlns:a="http://schemas.openxmlformats.org/drawingml/2006/main"/>
+        </p:spPr>
+        <p:txBody>
+          <a:bodyPr xmlns:a="http://schemas.openxmlformats.org/drawingml/2006/main" wrap="square" lIns="0" tIns="0" rIns="0" bIns="0" anchor="t">
+            <a:spAutoFit/>
+          </a:bodyPr>
+          <a:lstStyle xmlns:a="http://schemas.openxmlformats.org/drawingml/2006/main"/>
+          <a:p xmlns:a="http://schemas.openxmlformats.org/drawingml/2006/main">
+            <a:pPr algn="l">
+              <a:buNone/>
+            </a:pPr>
+            <a:r>
+              <a:rPr sz="2100" b="1" i="0">
+                <a:solidFill>
+                  <a:srgbClr val="CF6836"/>
+                </a:solidFill>
+                <a:latin typeface="Aptos"/>
+                <a:ea typeface="Aptos"/>
+                <a:cs typeface="Aptos"/>
+              </a:rPr>
+              <a:t>The pilot found roughly 30% overlap in the content reviewed.</a:t>
+            </a:r>
+          </a:p>
+        </p:txBody>
+      </p:sp>
+      <p:sp>
+        <p:nvSpPr>
+          <p:cNvPr id="10" name="TextBox 9">
+            <a:extLst xmlns:a="http://schemas.openxmlformats.org/drawingml/2006/main">
+              <a:ext uri="{FF2B5EF4-FFF2-40B4-BE49-F238E27FC236}">
+                <a16:creationId xmlns:a16="http://schemas.microsoft.com/office/drawing/2014/main" id="{1517326B-C685-438B-8E35-7961E0E7DFC0}"/>
+              </a:ext>
+            </a:extLst>
+          </p:cNvPr>
+          <p:cNvSpPr>
+            <a:spLocks xmlns:a="http://schemas.openxmlformats.org/drawingml/2006/main" noGrp="1"/>
+          </p:cNvSpPr>
+          <p:nvPr/>
+        </p:nvSpPr>
+        <p:spPr>
+          <a:xfrm xmlns:a="http://schemas.openxmlformats.org/drawingml/2006/main">
+            <a:off x="11292840" y="6446520"/>
+            <a:ext cx="320040" cy="182880"/>
+          </a:xfrm>
+          <a:prstGeom xmlns:a="http://schemas.openxmlformats.org/drawingml/2006/main" prst="rect">
+            <a:avLst/>
+          </a:prstGeom>
+          <a:noFill xmlns:a="http://schemas.openxmlformats.org/drawingml/2006/main"/>
+        </p:spPr>
+        <p:txBody>
+          <a:bodyPr xmlns:a="http://schemas.openxmlformats.org/drawingml/2006/main" wrap="square" lIns="0" tIns="0" rIns="0" bIns="0" anchor="t">
+            <a:spAutoFit/>
+          </a:bodyPr>
+          <a:lstStyle xmlns:a="http://schemas.openxmlformats.org/drawingml/2006/main"/>
+          <a:p xmlns:a="http://schemas.openxmlformats.org/drawingml/2006/main">
+            <a:pPr algn="r">
+              <a:buNone/>
+            </a:pPr>
+            <a:r>
+              <a:rPr sz="1000" b="1" i="0">
+                <a:solidFill>
+                  <a:srgbClr val="687B8E"/>
+                </a:solidFill>
+                <a:latin typeface="Aptos"/>
+                <a:ea typeface="Aptos"/>
+                <a:cs typeface="Aptos"/>
+              </a:rPr>
+              <a:t>04</a:t>
+            </a:r>
+          </a:p>
+        </p:txBody>
+      </p:sp>
     </p:spTree>
     <p:extLst>
       <p:ext uri="{BB962C8B-B14F-4D97-AF65-F5344CB8AC3E}">
-        <p14:creationId xmlns:p14="http://schemas.microsoft.com/office/powerpoint/2010/main" val="1462401011"/>
+        <p14:creationId xmlns:p14="http://schemas.microsoft.com/office/powerpoint/2010/main" val="1184106965"/>
       </p:ext>
     </p:extLst>
   </p:cSld>

</xml_diff>